<commit_message>
docs: organize submission materials around the paid physical check
</commit_message>
<xml_diff>
--- a/docs/competition/fieldproof-pitch.pptx
+++ b/docs/competition/fieldproof-pitch.pptx
@@ -2,17 +2,17 @@
 <file path=ppt/presentation.xml><?xml version="1.0" encoding="utf-8"?>
 <p:presentation xmlns:p="http://schemas.openxmlformats.org/presentationml/2006/main">
   <p:sldMasterIdLst>
-    <p:sldMasterId xmlns:r="http://schemas.openxmlformats.org/officeDocument/2006/relationships" id="2147483648" r:id="R882ba68a5fb343a8"/>
+    <p:sldMasterId xmlns:r="http://schemas.openxmlformats.org/officeDocument/2006/relationships" id="2147483648" r:id="R23ea92e1e26b4a6a"/>
   </p:sldMasterIdLst>
   <p:notesMasterIdLst>
-    <p:notesMasterId xmlns:r="http://schemas.openxmlformats.org/officeDocument/2006/relationships" r:id="R75d3a73d1d1d45c4"/>
+    <p:notesMasterId xmlns:r="http://schemas.openxmlformats.org/officeDocument/2006/relationships" r:id="R284703bbfa424e91"/>
   </p:notesMasterIdLst>
   <p:sldIdLst>
-    <p:sldId xmlns:r="http://schemas.openxmlformats.org/officeDocument/2006/relationships" id="256" r:id="Rd80aac3a19f64522"/>
-    <p:sldId xmlns:r="http://schemas.openxmlformats.org/officeDocument/2006/relationships" id="257" r:id="Rcfc93e10a44a45ae"/>
-    <p:sldId xmlns:r="http://schemas.openxmlformats.org/officeDocument/2006/relationships" id="258" r:id="R1ca7f7008b8441b8"/>
-    <p:sldId xmlns:r="http://schemas.openxmlformats.org/officeDocument/2006/relationships" id="259" r:id="Re8560e17e17243ca"/>
-    <p:sldId xmlns:r="http://schemas.openxmlformats.org/officeDocument/2006/relationships" id="260" r:id="Rb45470c038ce4439"/>
+    <p:sldId xmlns:r="http://schemas.openxmlformats.org/officeDocument/2006/relationships" id="256" r:id="R8735ce0ff52a44bc"/>
+    <p:sldId xmlns:r="http://schemas.openxmlformats.org/officeDocument/2006/relationships" id="257" r:id="R442506087e1846b7"/>
+    <p:sldId xmlns:r="http://schemas.openxmlformats.org/officeDocument/2006/relationships" id="258" r:id="R50b15bbfa774469b"/>
+    <p:sldId xmlns:r="http://schemas.openxmlformats.org/officeDocument/2006/relationships" id="259" r:id="Rb9f1aefe962a4d45"/>
+    <p:sldId xmlns:r="http://schemas.openxmlformats.org/officeDocument/2006/relationships" id="260" r:id="Rec604e4503874f26"/>
   </p:sldIdLst>
   <p:sldSz cx="12192000" cy="6858000"/>
   <p:notesSz cx="6858000" cy="9144000"/>
@@ -446,7 +446,7 @@
           <a:lstStyle xmlns:a="http://schemas.openxmlformats.org/drawingml/2006/main"/>
           <a:p xmlns:a="http://schemas.openxmlformats.org/drawingml/2006/main">
             <a:r>
-              <a:t>Source: README.md; docs/SUBMISSION.md. Buyer is a hypothesis, not a customer.</a:t>
+              <a:t>Content source: docs/competition/slides.html. Implementation and evidence: docs/VERIFICATION.md and docs/evidence/device-signed-purchase-20261011.json. Buyer value and commercial pricing are hypotheses. The Solana transaction uses test tokens. Live peaq activation and event readback remain pending. Slide 1 of 5.</a:t>
             </a:r>
           </a:p>
         </p:txBody>
@@ -516,7 +516,7 @@
           <a:lstStyle xmlns:a="http://schemas.openxmlformats.org/drawingml/2006/main"/>
           <a:p xmlns:a="http://schemas.openxmlformats.org/drawingml/2006/main">
             <a:r>
-              <a:t>Source: README.md; docs/VERIFICATION.md. The current signed contract remains gate.closed. This slide gives the buyer-facing question, not a changed receipt field.</a:t>
+              <a:t>Content source: docs/competition/slides.html. Implementation and evidence: docs/VERIFICATION.md and docs/evidence/device-signed-purchase-20261011.json. Buyer value and commercial pricing are hypotheses. The Solana transaction uses test tokens. Live peaq activation and event readback remain pending. Slide 2 of 5.</a:t>
             </a:r>
           </a:p>
         </p:txBody>
@@ -586,7 +586,7 @@
           <a:lstStyle xmlns:a="http://schemas.openxmlformats.org/drawingml/2006/main"/>
           <a:p xmlns:a="http://schemas.openxmlformats.org/drawingml/2006/main">
             <a:r>
-              <a:t>Source: README.md; docs/PEAQ_INTEGRATION.md; docs/VERIFICATION.md. Devnet USDC is a test token. peaq is pending until live finalized readback.</a:t>
+              <a:t>Content source: docs/competition/slides.html. Implementation and evidence: docs/VERIFICATION.md and docs/evidence/device-signed-purchase-20261011.json. Buyer value and commercial pricing are hypotheses. The Solana transaction uses test tokens. Live peaq activation and event readback remain pending. Slide 3 of 5.</a:t>
             </a:r>
           </a:p>
         </p:txBody>
@@ -656,7 +656,7 @@
           <a:lstStyle xmlns:a="http://schemas.openxmlformats.org/drawingml/2006/main"/>
           <a:p xmlns:a="http://schemas.openxmlformats.org/drawingml/2006/main">
             <a:r>
-              <a:t>Source: docs/VERIFICATION.md and public inspector. Ten seconds is buyer policy, not a safety guarantee. Both contact states can fulfill the paid check.</a:t>
+              <a:t>Content source: docs/competition/slides.html. Implementation and evidence: docs/VERIFICATION.md and docs/evidence/device-signed-purchase-20261011.json. Buyer value and commercial pricing are hypotheses. The Solana transaction uses test tokens. Live peaq activation and event readback remain pending. Slide 4 of 5.</a:t>
             </a:r>
           </a:p>
         </p:txBody>
@@ -726,7 +726,7 @@
           <a:lstStyle xmlns:a="http://schemas.openxmlformats.org/drawingml/2006/main"/>
           <a:p xmlns:a="http://schemas.openxmlformats.org/drawingml/2006/main">
             <a:r>
-              <a:t>Source: docs/STRATEGY.md. No customer, revenue, price validation, or market advantage is claimed.</a:t>
+              <a:t>Content source: docs/competition/slides.html. Implementation and evidence: docs/VERIFICATION.md and docs/evidence/device-signed-purchase-20261011.json. Buyer value and commercial pricing are hypotheses. The Solana transaction uses test tokens. Live peaq activation and event readback remain pending. Slide 5 of 5.</a:t>
             </a:r>
           </a:p>
         </p:txBody>
@@ -794,7 +794,7 @@
   </p:cSld>
   <p:clrMap bg1="lt1" tx1="dk1" bg2="lt2" tx2="dk2" accent1="accent1" accent2="accent2" accent3="accent3" accent4="accent4" accent5="accent5" accent6="accent6" hlink="hlink" folHlink="folHlink"/>
   <p:sldLayoutIdLst>
-    <p:sldLayoutId xmlns:r="http://schemas.openxmlformats.org/officeDocument/2006/relationships" id="2147483649" r:id="Rd9d525f9f1254eb6"/>
+    <p:sldLayoutId xmlns:r="http://schemas.openxmlformats.org/officeDocument/2006/relationships" id="2147483649" r:id="Rd55828bcdb86441f"/>
   </p:sldLayoutIdLst>
   <p:txStyles>
     <p:titleStyle>
@@ -1327,7 +1327,7 @@
     <p:bg>
       <p:bgPr>
         <a:solidFill xmlns:a="http://schemas.openxmlformats.org/drawingml/2006/main">
-          <a:srgbClr val="F3F3ED"/>
+          <a:srgbClr val="F4FAFF"/>
         </a:solidFill>
       </p:bgPr>
     </p:bg>
@@ -1345,7 +1345,7 @@
           <p:cNvPr id="7" name="">
             <a:extLst xmlns:a="http://schemas.openxmlformats.org/drawingml/2006/main">
               <a:ext uri="{FF2B5EF4-FFF2-40B4-BE49-F238E27FC236}">
-                <a16:creationId xmlns:a16="http://schemas.microsoft.com/office/drawing/2014/main" id="{C09A9EAE-0FF8-4A86-8774-FF0870E4B35F}"/>
+                <a16:creationId xmlns:a16="http://schemas.microsoft.com/office/drawing/2014/main" id="{A02F20DD-196D-424C-8C39-6E842DBD9C4E}"/>
               </a:ext>
             </a:extLst>
           </p:cNvPr>
@@ -1356,8 +1356,8 @@
         </p:nvSpPr>
         <p:spPr>
           <a:xfrm xmlns:a="http://schemas.openxmlformats.org/drawingml/2006/main">
-            <a:off x="704850" y="495300"/>
-            <a:ext cx="10668000" cy="704850"/>
+            <a:off x="685800" y="457200"/>
+            <a:ext cx="10820400" cy="857250"/>
           </a:xfrm>
           <a:prstGeom xmlns:a="http://schemas.openxmlformats.org/drawingml/2006/main" prst="rect">
             <a:avLst/>
@@ -1368,15 +1368,19 @@
           </a:ln>
         </p:spPr>
         <p:txBody>
-          <a:bodyPr xmlns:a="http://schemas.openxmlformats.org/drawingml/2006/main">
+          <a:bodyPr xmlns:a="http://schemas.openxmlformats.org/drawingml/2006/main" lIns="0" tIns="0" rIns="0" bIns="0" anchor="t">
             <a:noAutofit/>
           </a:bodyPr>
           <a:lstStyle xmlns:a="http://schemas.openxmlformats.org/drawingml/2006/main"/>
           <a:p xmlns:a="http://schemas.openxmlformats.org/drawingml/2006/main">
             <a:pPr>
-              <a:defRPr sz="3300" b="1">
-                <a:solidFill>
-                  <a:srgbClr val="183146"/>
+              <a:lnSpc>
+                <a:spcPct val="118000"/>
+              </a:lnSpc>
+              <a:buNone/>
+              <a:defRPr sz="3450" b="1">
+                <a:solidFill>
+                  <a:srgbClr val="17364D"/>
                 </a:solidFill>
                 <a:latin typeface="Liberation Sans"/>
                 <a:ea typeface="Liberation Sans"/>
@@ -1384,15 +1388,15 @@
               </a:defRPr>
             </a:pPr>
             <a:r>
-              <a:rPr sz="3300" b="1">
-                <a:solidFill>
-                  <a:srgbClr val="183146"/>
+              <a:rPr sz="3450" b="1">
+                <a:solidFill>
+                  <a:srgbClr val="17364D"/>
                 </a:solidFill>
                 <a:latin typeface="Liberation Sans"/>
                 <a:ea typeface="Liberation Sans"/>
                 <a:cs typeface="Liberation Sans"/>
               </a:rPr>
-              <a:t>Paid fresh physical checks</a:t>
+              <a:t>FieldProof</a:t>
             </a:r>
           </a:p>
         </p:txBody>
@@ -1402,7 +1406,7 @@
           <p:cNvPr id="2" name="">
             <a:extLst xmlns:a="http://schemas.openxmlformats.org/drawingml/2006/main">
               <a:ext uri="{FF2B5EF4-FFF2-40B4-BE49-F238E27FC236}">
-                <a16:creationId xmlns:a16="http://schemas.microsoft.com/office/drawing/2014/main" id="{59C54520-2558-47A7-B795-64B5538AC643}"/>
+                <a16:creationId xmlns:a16="http://schemas.microsoft.com/office/drawing/2014/main" id="{F8539FF9-2018-465B-BDA7-FE91098A77BF}"/>
               </a:ext>
             </a:extLst>
           </p:cNvPr>
@@ -1413,8 +1417,8 @@
         </p:nvSpPr>
         <p:spPr>
           <a:xfrm xmlns:a="http://schemas.openxmlformats.org/drawingml/2006/main">
-            <a:off x="714375" y="6343650"/>
-            <a:ext cx="4762500" cy="228600"/>
+            <a:off x="685800" y="1752600"/>
+            <a:ext cx="7810500" cy="1314450"/>
           </a:xfrm>
           <a:prstGeom xmlns:a="http://schemas.openxmlformats.org/drawingml/2006/main" prst="rect">
             <a:avLst/>
@@ -1425,15 +1429,19 @@
           </a:ln>
         </p:spPr>
         <p:txBody>
-          <a:bodyPr xmlns:a="http://schemas.openxmlformats.org/drawingml/2006/main">
+          <a:bodyPr xmlns:a="http://schemas.openxmlformats.org/drawingml/2006/main" lIns="0" tIns="0" rIns="0" bIns="0" anchor="t">
             <a:noAutofit/>
           </a:bodyPr>
           <a:lstStyle xmlns:a="http://schemas.openxmlformats.org/drawingml/2006/main"/>
           <a:p xmlns:a="http://schemas.openxmlformats.org/drawingml/2006/main">
             <a:pPr>
-              <a:defRPr sz="1125" b="1">
-                <a:solidFill>
-                  <a:srgbClr val="146B8D"/>
+              <a:lnSpc>
+                <a:spcPct val="118000"/>
+              </a:lnSpc>
+              <a:buNone/>
+              <a:defRPr sz="3150" b="1">
+                <a:solidFill>
+                  <a:srgbClr val="126C97"/>
                 </a:solidFill>
                 <a:latin typeface="Liberation Sans"/>
                 <a:ea typeface="Liberation Sans"/>
@@ -1441,15 +1449,15 @@
               </a:defRPr>
             </a:pPr>
             <a:r>
-              <a:rPr sz="1125" b="1">
-                <a:solidFill>
-                  <a:srgbClr val="146B8D"/>
+              <a:rPr sz="3150" b="1">
+                <a:solidFill>
+                  <a:srgbClr val="126C97"/>
                 </a:solidFill>
                 <a:latin typeface="Liberation Sans"/>
                 <a:ea typeface="Liberation Sans"/>
                 <a:cs typeface="Liberation Sans"/>
               </a:rPr>
-              <a:t>FIELDPROOF  /  01</a:t>
+              <a:t>Software pays for a fresh physical check.</a:t>
             </a:r>
           </a:p>
         </p:txBody>
@@ -1459,7 +1467,7 @@
           <p:cNvPr id="3" name="">
             <a:extLst xmlns:a="http://schemas.openxmlformats.org/drawingml/2006/main">
               <a:ext uri="{FF2B5EF4-FFF2-40B4-BE49-F238E27FC236}">
-                <a16:creationId xmlns:a16="http://schemas.microsoft.com/office/drawing/2014/main" id="{EF7FB60B-A68B-4E02-92D4-DEE2D7FE211D}"/>
+                <a16:creationId xmlns:a16="http://schemas.microsoft.com/office/drawing/2014/main" id="{8B3635BA-7F43-42FF-805A-A46C8E57D1C8}"/>
               </a:ext>
             </a:extLst>
           </p:cNvPr>
@@ -1470,8 +1478,8 @@
         </p:nvSpPr>
         <p:spPr>
           <a:xfrm xmlns:a="http://schemas.openxmlformats.org/drawingml/2006/main">
-            <a:off x="714375" y="1524000"/>
-            <a:ext cx="6858000" cy="1047750"/>
+            <a:off x="685800" y="3333750"/>
+            <a:ext cx="8096250" cy="1409700"/>
           </a:xfrm>
           <a:prstGeom xmlns:a="http://schemas.openxmlformats.org/drawingml/2006/main" prst="rect">
             <a:avLst/>
@@ -1482,15 +1490,19 @@
           </a:ln>
         </p:spPr>
         <p:txBody>
-          <a:bodyPr xmlns:a="http://schemas.openxmlformats.org/drawingml/2006/main">
+          <a:bodyPr xmlns:a="http://schemas.openxmlformats.org/drawingml/2006/main" lIns="0" tIns="0" rIns="0" bIns="0" anchor="t">
             <a:noAutofit/>
           </a:bodyPr>
           <a:lstStyle xmlns:a="http://schemas.openxmlformats.org/drawingml/2006/main"/>
           <a:p xmlns:a="http://schemas.openxmlformats.org/drawingml/2006/main">
             <a:pPr>
-              <a:defRPr sz="2475" b="0">
-                <a:solidFill>
-                  <a:srgbClr val="146B8D"/>
+              <a:lnSpc>
+                <a:spcPct val="118000"/>
+              </a:lnSpc>
+              <a:buNone/>
+              <a:defRPr sz="2250" b="0">
+                <a:solidFill>
+                  <a:srgbClr val="17364D"/>
                 </a:solidFill>
                 <a:latin typeface="Liberation Sans"/>
                 <a:ea typeface="Liberation Sans"/>
@@ -1498,15 +1510,15 @@
               </a:defRPr>
             </a:pPr>
             <a:r>
-              <a:rPr sz="2475" b="0">
-                <a:solidFill>
-                  <a:srgbClr val="146B8D"/>
+              <a:rPr sz="2250" b="0">
+                <a:solidFill>
+                  <a:srgbClr val="17364D"/>
                 </a:solidFill>
                 <a:latin typeface="Liberation Sans"/>
                 <a:ea typeface="Liberation Sans"/>
                 <a:cs typeface="Liberation Sans"/>
               </a:rPr>
-              <a:t>For AI agents that manage equipment at another site</a:t>
+              <a:t>The device signs its answer. The buyer verifies who answered and whether the answer is still fresh.</a:t>
             </a:r>
           </a:p>
         </p:txBody>
@@ -1516,7 +1528,7 @@
           <p:cNvPr id="4" name="">
             <a:extLst xmlns:a="http://schemas.openxmlformats.org/drawingml/2006/main">
               <a:ext uri="{FF2B5EF4-FFF2-40B4-BE49-F238E27FC236}">
-                <a16:creationId xmlns:a16="http://schemas.microsoft.com/office/drawing/2014/main" id="{BB1BB104-5376-4E7B-B1C8-6E20E8215E01}"/>
+                <a16:creationId xmlns:a16="http://schemas.microsoft.com/office/drawing/2014/main" id="{DD563C8C-DA1A-4AE3-AB8F-500BBA148273}"/>
               </a:ext>
             </a:extLst>
           </p:cNvPr>
@@ -1527,8 +1539,8 @@
         </p:nvSpPr>
         <p:spPr>
           <a:xfrm xmlns:a="http://schemas.openxmlformats.org/drawingml/2006/main">
-            <a:off x="714375" y="3143250"/>
-            <a:ext cx="6762750" cy="952500"/>
+            <a:off x="685800" y="5257800"/>
+            <a:ext cx="8572500" cy="419100"/>
           </a:xfrm>
           <a:prstGeom xmlns:a="http://schemas.openxmlformats.org/drawingml/2006/main" prst="rect">
             <a:avLst/>
@@ -1539,15 +1551,19 @@
           </a:ln>
         </p:spPr>
         <p:txBody>
-          <a:bodyPr xmlns:a="http://schemas.openxmlformats.org/drawingml/2006/main">
+          <a:bodyPr xmlns:a="http://schemas.openxmlformats.org/drawingml/2006/main" lIns="0" tIns="0" rIns="0" bIns="0" anchor="t">
             <a:noAutofit/>
           </a:bodyPr>
           <a:lstStyle xmlns:a="http://schemas.openxmlformats.org/drawingml/2006/main"/>
           <a:p xmlns:a="http://schemas.openxmlformats.org/drawingml/2006/main">
             <a:pPr>
-              <a:defRPr sz="2100" b="0">
-                <a:solidFill>
-                  <a:srgbClr val="183146"/>
+              <a:lnSpc>
+                <a:spcPct val="118000"/>
+              </a:lnSpc>
+              <a:buNone/>
+              <a:defRPr sz="1725" b="0">
+                <a:solidFill>
+                  <a:srgbClr val="536D80"/>
                 </a:solidFill>
                 <a:latin typeface="Liberation Sans"/>
                 <a:ea typeface="Liberation Sans"/>
@@ -1555,102 +1571,106 @@
               </a:defRPr>
             </a:pPr>
             <a:r>
-              <a:rPr sz="2100" b="0">
-                <a:solidFill>
-                  <a:srgbClr val="183146"/>
+              <a:rPr sz="1725" b="0">
+                <a:solidFill>
+                  <a:srgbClr val="536D80"/>
                 </a:solidFill>
                 <a:latin typeface="Liberation Sans"/>
                 <a:ea typeface="Liberation Sans"/>
                 <a:cs typeface="Liberation Sans"/>
               </a:rPr>
-              <a:t>One question. One paid observation. One signed answer with an expiry.</a:t>
-            </a:r>
-          </a:p>
-        </p:txBody>
-      </p:sp>
-      <p:sp>
-        <p:nvSpPr>
-          <p:cNvPr id="5" name="">
-            <a:extLst xmlns:a="http://schemas.openxmlformats.org/drawingml/2006/main">
-              <a:ext uri="{FF2B5EF4-FFF2-40B4-BE49-F238E27FC236}">
-                <a16:creationId xmlns:a16="http://schemas.microsoft.com/office/drawing/2014/main" id="{84B0D4AE-A940-42DC-BDC8-533E2742274B}"/>
-              </a:ext>
-            </a:extLst>
-          </p:cNvPr>
-          <p:cNvSpPr>
-            <a:spLocks xmlns:a="http://schemas.openxmlformats.org/drawingml/2006/main" noGrp="1"/>
-          </p:cNvSpPr>
-          <p:nvPr/>
-        </p:nvSpPr>
-        <p:spPr>
-          <a:xfrm xmlns:a="http://schemas.openxmlformats.org/drawingml/2006/main">
-            <a:off x="714375" y="5381625"/>
-            <a:ext cx="7239000" cy="285750"/>
-          </a:xfrm>
-          <a:prstGeom xmlns:a="http://schemas.openxmlformats.org/drawingml/2006/main" prst="rect">
-            <a:avLst/>
-          </a:prstGeom>
-          <a:noFill xmlns:a="http://schemas.openxmlformats.org/drawingml/2006/main"/>
-          <a:ln xmlns:a="http://schemas.openxmlformats.org/drawingml/2006/main" w="0">
-            <a:noFill/>
-          </a:ln>
-        </p:spPr>
-        <p:txBody>
-          <a:bodyPr xmlns:a="http://schemas.openxmlformats.org/drawingml/2006/main">
-            <a:noAutofit/>
-          </a:bodyPr>
-          <a:lstStyle xmlns:a="http://schemas.openxmlformats.org/drawingml/2006/main"/>
-          <a:p xmlns:a="http://schemas.openxmlformats.org/drawingml/2006/main">
-            <a:pPr>
-              <a:defRPr sz="1500" b="0">
-                <a:solidFill>
-                  <a:srgbClr val="52616C"/>
-                </a:solidFill>
-                <a:latin typeface="Liberation Sans"/>
-                <a:ea typeface="Liberation Sans"/>
-                <a:cs typeface="Liberation Sans"/>
-              </a:defRPr>
-            </a:pPr>
-            <a:r>
-              <a:rPr sz="1500" b="0">
-                <a:solidFill>
-                  <a:srgbClr val="52616C"/>
-                </a:solidFill>
-                <a:latin typeface="Liberation Sans"/>
-                <a:ea typeface="Liberation Sans"/>
-                <a:cs typeface="Liberation Sans"/>
-              </a:rPr>
-              <a:t>Remote-equipment AI builder: initial buyer hypothesis</a:t>
+              <a:t>Working prototype: ESP32-C6 and Solana Devnet.</a:t>
             </a:r>
           </a:p>
         </p:txBody>
       </p:sp>
       <p:pic>
         <p:nvPicPr>
-          <p:cNvPr id="12" name=""/>
+          <p:cNvPr id="11" name=""/>
           <p:cNvPicPr>
             <a:picLocks xmlns:a="http://schemas.openxmlformats.org/drawingml/2006/main" noChangeAspect="1"/>
           </p:cNvPicPr>
           <p:nvPr/>
         </p:nvPicPr>
         <p:blipFill>
-          <a:blip xmlns:r="http://schemas.openxmlformats.org/officeDocument/2006/relationships" xmlns:a="http://schemas.openxmlformats.org/drawingml/2006/main" r:embed="Re877c543449540d6"/>
+          <a:blip xmlns:r="http://schemas.openxmlformats.org/officeDocument/2006/relationships" xmlns:a="http://schemas.openxmlformats.org/drawingml/2006/main" r:embed="R60a19325875149d5"/>
           <a:stretch xmlns:a="http://schemas.openxmlformats.org/drawingml/2006/main"/>
         </p:blipFill>
         <p:spPr>
           <a:xfrm xmlns:a="http://schemas.openxmlformats.org/drawingml/2006/main">
-            <a:off x="8324850" y="1428750"/>
-            <a:ext cx="2952750" cy="2952750"/>
+            <a:off x="9144000" y="2000250"/>
+            <a:ext cx="2381250" cy="2381250"/>
           </a:xfrm>
           <a:prstGeom xmlns:a="http://schemas.openxmlformats.org/drawingml/2006/main" prst="rect">
             <a:avLst/>
           </a:prstGeom>
         </p:spPr>
       </p:pic>
+      <p:sp>
+        <p:nvSpPr>
+          <p:cNvPr id="6" name="">
+            <a:extLst xmlns:a="http://schemas.openxmlformats.org/drawingml/2006/main">
+              <a:ext uri="{FF2B5EF4-FFF2-40B4-BE49-F238E27FC236}">
+                <a16:creationId xmlns:a16="http://schemas.microsoft.com/office/drawing/2014/main" id="{C44AF1B0-FBE7-4FDA-A9C6-A3571D945C4A}"/>
+              </a:ext>
+            </a:extLst>
+          </p:cNvPr>
+          <p:cNvSpPr>
+            <a:spLocks xmlns:a="http://schemas.openxmlformats.org/drawingml/2006/main" noGrp="1"/>
+          </p:cNvSpPr>
+          <p:nvPr/>
+        </p:nvSpPr>
+        <p:spPr>
+          <a:xfrm xmlns:a="http://schemas.openxmlformats.org/drawingml/2006/main">
+            <a:off x="685800" y="6276975"/>
+            <a:ext cx="10820400" cy="419100"/>
+          </a:xfrm>
+          <a:prstGeom xmlns:a="http://schemas.openxmlformats.org/drawingml/2006/main" prst="rect">
+            <a:avLst/>
+          </a:prstGeom>
+          <a:noFill xmlns:a="http://schemas.openxmlformats.org/drawingml/2006/main"/>
+          <a:ln xmlns:a="http://schemas.openxmlformats.org/drawingml/2006/main" w="0">
+            <a:noFill/>
+          </a:ln>
+        </p:spPr>
+        <p:txBody>
+          <a:bodyPr xmlns:a="http://schemas.openxmlformats.org/drawingml/2006/main" lIns="0" tIns="0" rIns="0" bIns="0" anchor="t">
+            <a:noAutofit/>
+          </a:bodyPr>
+          <a:lstStyle xmlns:a="http://schemas.openxmlformats.org/drawingml/2006/main"/>
+          <a:p xmlns:a="http://schemas.openxmlformats.org/drawingml/2006/main">
+            <a:pPr>
+              <a:lnSpc>
+                <a:spcPct val="118000"/>
+              </a:lnSpc>
+              <a:buNone/>
+              <a:defRPr sz="1350" b="0">
+                <a:solidFill>
+                  <a:srgbClr val="536D80"/>
+                </a:solidFill>
+                <a:latin typeface="Liberation Sans"/>
+                <a:ea typeface="Liberation Sans"/>
+                <a:cs typeface="Liberation Sans"/>
+              </a:defRPr>
+            </a:pPr>
+            <a:r>
+              <a:rPr sz="1350" b="0">
+                <a:solidFill>
+                  <a:srgbClr val="536D80"/>
+                </a:solidFill>
+                <a:latin typeface="Liberation Sans"/>
+                <a:ea typeface="Liberation Sans"/>
+                <a:cs typeface="Liberation Sans"/>
+              </a:rPr>
+              <a:t>01 / A device signature authenticates a claim. It does not establish physical truth.</a:t>
+            </a:r>
+          </a:p>
+        </p:txBody>
+      </p:sp>
     </p:spTree>
     <p:extLst>
       <p:ext uri="{BB962C8B-B14F-4D97-AF65-F5344CB8AC3E}">
-        <p14:creationId xmlns:p14="http://schemas.microsoft.com/office/powerpoint/2010/main" val="752144905"/>
+        <p14:creationId xmlns:p14="http://schemas.microsoft.com/office/powerpoint/2010/main" val="96589454"/>
       </p:ext>
     </p:extLst>
   </p:cSld>
@@ -1663,7 +1683,7 @@
     <p:bg>
       <p:bgPr>
         <a:solidFill xmlns:a="http://schemas.openxmlformats.org/drawingml/2006/main">
-          <a:srgbClr val="F3F3ED"/>
+          <a:srgbClr val="F4FAFF"/>
         </a:solidFill>
       </p:bgPr>
     </p:bg>
@@ -1678,10 +1698,10 @@
       </p:grpSpPr>
       <p:sp>
         <p:nvSpPr>
-          <p:cNvPr id="7" name="">
+          <p:cNvPr id="10" name="">
             <a:extLst xmlns:a="http://schemas.openxmlformats.org/drawingml/2006/main">
               <a:ext uri="{FF2B5EF4-FFF2-40B4-BE49-F238E27FC236}">
-                <a16:creationId xmlns:a16="http://schemas.microsoft.com/office/drawing/2014/main" id="{6BA42ABA-9110-4553-9595-9177E3D4390A}"/>
+                <a16:creationId xmlns:a16="http://schemas.microsoft.com/office/drawing/2014/main" id="{F4BBBA1B-FAA3-45C6-8D49-15E16E13DC2B}"/>
               </a:ext>
             </a:extLst>
           </p:cNvPr>
@@ -1692,8 +1712,8 @@
         </p:nvSpPr>
         <p:spPr>
           <a:xfrm xmlns:a="http://schemas.openxmlformats.org/drawingml/2006/main">
-            <a:off x="704850" y="495300"/>
-            <a:ext cx="10668000" cy="704850"/>
+            <a:off x="685800" y="457200"/>
+            <a:ext cx="10820400" cy="857250"/>
           </a:xfrm>
           <a:prstGeom xmlns:a="http://schemas.openxmlformats.org/drawingml/2006/main" prst="rect">
             <a:avLst/>
@@ -1704,15 +1724,19 @@
           </a:ln>
         </p:spPr>
         <p:txBody>
-          <a:bodyPr xmlns:a="http://schemas.openxmlformats.org/drawingml/2006/main">
+          <a:bodyPr xmlns:a="http://schemas.openxmlformats.org/drawingml/2006/main" lIns="0" tIns="0" rIns="0" bIns="0" anchor="t">
             <a:noAutofit/>
           </a:bodyPr>
           <a:lstStyle xmlns:a="http://schemas.openxmlformats.org/drawingml/2006/main"/>
           <a:p xmlns:a="http://schemas.openxmlformats.org/drawingml/2006/main">
             <a:pPr>
-              <a:defRPr sz="3300" b="1">
-                <a:solidFill>
-                  <a:srgbClr val="183146"/>
+              <a:lnSpc>
+                <a:spcPct val="118000"/>
+              </a:lnSpc>
+              <a:buNone/>
+              <a:defRPr sz="3450" b="1">
+                <a:solidFill>
+                  <a:srgbClr val="17364D"/>
                 </a:solidFill>
                 <a:latin typeface="Liberation Sans"/>
                 <a:ea typeface="Liberation Sans"/>
@@ -1720,15 +1744,15 @@
               </a:defRPr>
             </a:pPr>
             <a:r>
-              <a:rPr sz="3300" b="1">
-                <a:solidFill>
-                  <a:srgbClr val="183146"/>
+              <a:rPr sz="3450" b="1">
+                <a:solidFill>
+                  <a:srgbClr val="17364D"/>
                 </a:solidFill>
                 <a:latin typeface="Liberation Sans"/>
                 <a:ea typeface="Liberation Sans"/>
                 <a:cs typeface="Liberation Sans"/>
               </a:rPr>
-              <a:t>The current physical question</a:t>
+              <a:t>A remote inspection before a decision</a:t>
             </a:r>
           </a:p>
         </p:txBody>
@@ -1738,7 +1762,7 @@
           <p:cNvPr id="2" name="">
             <a:extLst xmlns:a="http://schemas.openxmlformats.org/drawingml/2006/main">
               <a:ext uri="{FF2B5EF4-FFF2-40B4-BE49-F238E27FC236}">
-                <a16:creationId xmlns:a16="http://schemas.microsoft.com/office/drawing/2014/main" id="{4B2B3339-96DA-489F-942F-966916A17DBC}"/>
+                <a16:creationId xmlns:a16="http://schemas.microsoft.com/office/drawing/2014/main" id="{28CFCB66-6A7F-41CD-9A7C-243D85C06425}"/>
               </a:ext>
             </a:extLst>
           </p:cNvPr>
@@ -1749,8 +1773,8 @@
         </p:nvSpPr>
         <p:spPr>
           <a:xfrm xmlns:a="http://schemas.openxmlformats.org/drawingml/2006/main">
-            <a:off x="714375" y="6343650"/>
-            <a:ext cx="4762500" cy="228600"/>
+            <a:off x="685800" y="1809750"/>
+            <a:ext cx="5010150" cy="666750"/>
           </a:xfrm>
           <a:prstGeom xmlns:a="http://schemas.openxmlformats.org/drawingml/2006/main" prst="rect">
             <a:avLst/>
@@ -1761,15 +1785,19 @@
           </a:ln>
         </p:spPr>
         <p:txBody>
-          <a:bodyPr xmlns:a="http://schemas.openxmlformats.org/drawingml/2006/main">
+          <a:bodyPr xmlns:a="http://schemas.openxmlformats.org/drawingml/2006/main" lIns="0" tIns="0" rIns="0" bIns="0" anchor="t">
             <a:noAutofit/>
           </a:bodyPr>
           <a:lstStyle xmlns:a="http://schemas.openxmlformats.org/drawingml/2006/main"/>
           <a:p xmlns:a="http://schemas.openxmlformats.org/drawingml/2006/main">
             <a:pPr>
-              <a:defRPr sz="1125" b="1">
-                <a:solidFill>
-                  <a:srgbClr val="146B8D"/>
+              <a:lnSpc>
+                <a:spcPct val="118000"/>
+              </a:lnSpc>
+              <a:buNone/>
+              <a:defRPr sz="2175" b="1">
+                <a:solidFill>
+                  <a:srgbClr val="126C97"/>
                 </a:solidFill>
                 <a:latin typeface="Liberation Sans"/>
                 <a:ea typeface="Liberation Sans"/>
@@ -1777,15 +1805,15 @@
               </a:defRPr>
             </a:pPr>
             <a:r>
-              <a:rPr sz="1125" b="1">
-                <a:solidFill>
-                  <a:srgbClr val="146B8D"/>
+              <a:rPr sz="2175" b="1">
+                <a:solidFill>
+                  <a:srgbClr val="126C97"/>
                 </a:solidFill>
                 <a:latin typeface="Liberation Sans"/>
                 <a:ea typeface="Liberation Sans"/>
                 <a:cs typeface="Liberation Sans"/>
               </a:rPr>
-              <a:t>FIELDPROOF  /  02</a:t>
+              <a:t>Target workflow</a:t>
             </a:r>
           </a:p>
         </p:txBody>
@@ -1795,7 +1823,7 @@
           <p:cNvPr id="3" name="">
             <a:extLst xmlns:a="http://schemas.openxmlformats.org/drawingml/2006/main">
               <a:ext uri="{FF2B5EF4-FFF2-40B4-BE49-F238E27FC236}">
-                <a16:creationId xmlns:a16="http://schemas.microsoft.com/office/drawing/2014/main" id="{521A951A-F323-4A43-9828-CDFD1583331B}"/>
+                <a16:creationId xmlns:a16="http://schemas.microsoft.com/office/drawing/2014/main" id="{7DE2F1E5-6548-4F06-8BC6-C295DFD127CA}"/>
               </a:ext>
             </a:extLst>
           </p:cNvPr>
@@ -1806,8 +1834,8 @@
         </p:nvSpPr>
         <p:spPr>
           <a:xfrm xmlns:a="http://schemas.openxmlformats.org/drawingml/2006/main">
-            <a:off x="714375" y="1438275"/>
-            <a:ext cx="6381750" cy="809625"/>
+            <a:off x="685800" y="2647950"/>
+            <a:ext cx="4895850" cy="1162050"/>
           </a:xfrm>
           <a:prstGeom xmlns:a="http://schemas.openxmlformats.org/drawingml/2006/main" prst="rect">
             <a:avLst/>
@@ -1818,15 +1846,19 @@
           </a:ln>
         </p:spPr>
         <p:txBody>
-          <a:bodyPr xmlns:a="http://schemas.openxmlformats.org/drawingml/2006/main">
+          <a:bodyPr xmlns:a="http://schemas.openxmlformats.org/drawingml/2006/main" lIns="0" tIns="0" rIns="0" bIns="0" anchor="t">
             <a:noAutofit/>
           </a:bodyPr>
           <a:lstStyle xmlns:a="http://schemas.openxmlformats.org/drawingml/2006/main"/>
           <a:p xmlns:a="http://schemas.openxmlformats.org/drawingml/2006/main">
             <a:pPr>
-              <a:defRPr sz="2700" b="1">
-                <a:solidFill>
-                  <a:srgbClr val="146B8D"/>
+              <a:lnSpc>
+                <a:spcPct val="118000"/>
+              </a:lnSpc>
+              <a:buNone/>
+              <a:defRPr sz="2100" b="0">
+                <a:solidFill>
+                  <a:srgbClr val="17364D"/>
                 </a:solidFill>
                 <a:latin typeface="Liberation Sans"/>
                 <a:ea typeface="Liberation Sans"/>
@@ -1834,15 +1866,15 @@
               </a:defRPr>
             </a:pPr>
             <a:r>
-              <a:rPr sz="2700" b="1">
-                <a:solidFill>
-                  <a:srgbClr val="146B8D"/>
+              <a:rPr sz="2100" b="0">
+                <a:solidFill>
+                  <a:srgbClr val="17364D"/>
                 </a:solidFill>
                 <a:latin typeface="Liberation Sans"/>
                 <a:ea typeface="Liberation Sans"/>
                 <a:cs typeface="Liberation Sans"/>
               </a:rPr>
-              <a:t>Is this enclosure contact closed now?</a:t>
+              <a:t>An operator pays someone to check a physical fact at another site.</a:t>
             </a:r>
           </a:p>
         </p:txBody>
@@ -1852,7 +1884,7 @@
           <p:cNvPr id="4" name="">
             <a:extLst xmlns:a="http://schemas.openxmlformats.org/drawingml/2006/main">
               <a:ext uri="{FF2B5EF4-FFF2-40B4-BE49-F238E27FC236}">
-                <a16:creationId xmlns:a16="http://schemas.microsoft.com/office/drawing/2014/main" id="{EA2CC16B-6368-4A52-A131-7E5166F076D8}"/>
+                <a16:creationId xmlns:a16="http://schemas.microsoft.com/office/drawing/2014/main" id="{62A8D1CD-E793-481F-A881-081E5EAE8823}"/>
               </a:ext>
             </a:extLst>
           </p:cNvPr>
@@ -1863,8 +1895,8 @@
         </p:nvSpPr>
         <p:spPr>
           <a:xfrm xmlns:a="http://schemas.openxmlformats.org/drawingml/2006/main">
-            <a:off x="714375" y="2667000"/>
-            <a:ext cx="6286500" cy="1381125"/>
+            <a:off x="685800" y="4000500"/>
+            <a:ext cx="4895850" cy="1295400"/>
           </a:xfrm>
           <a:prstGeom xmlns:a="http://schemas.openxmlformats.org/drawingml/2006/main" prst="rect">
             <a:avLst/>
@@ -1875,15 +1907,19 @@
           </a:ln>
         </p:spPr>
         <p:txBody>
-          <a:bodyPr xmlns:a="http://schemas.openxmlformats.org/drawingml/2006/main">
+          <a:bodyPr xmlns:a="http://schemas.openxmlformats.org/drawingml/2006/main" lIns="0" tIns="0" rIns="0" bIns="0" anchor="t">
             <a:noAutofit/>
           </a:bodyPr>
           <a:lstStyle xmlns:a="http://schemas.openxmlformats.org/drawingml/2006/main"/>
           <a:p xmlns:a="http://schemas.openxmlformats.org/drawingml/2006/main">
             <a:pPr>
-              <a:defRPr sz="2025" b="0">
-                <a:solidFill>
-                  <a:srgbClr val="183146"/>
+              <a:lnSpc>
+                <a:spcPct val="118000"/>
+              </a:lnSpc>
+              <a:buNone/>
+              <a:defRPr sz="2100" b="0">
+                <a:solidFill>
+                  <a:srgbClr val="17364D"/>
                 </a:solidFill>
                 <a:latin typeface="Liberation Sans"/>
                 <a:ea typeface="Liberation Sans"/>
@@ -1891,15 +1927,15 @@
               </a:defRPr>
             </a:pPr>
             <a:r>
-              <a:rPr sz="2025" b="0">
-                <a:solidFill>
-                  <a:srgbClr val="183146"/>
+              <a:rPr sz="2100" b="0">
+                <a:solidFill>
+                  <a:srgbClr val="17364D"/>
                 </a:solidFill>
                 <a:latin typeface="Liberation Sans"/>
                 <a:ea typeface="Liberation Sans"/>
                 <a:cs typeface="Liberation Sans"/>
               </a:rPr>
-              <a:t>The ESP32-C6 samples the BOOT contact stand-in after payment. Its P-256 key signs the question and result.</a:t>
+              <a:t>Its software lacks a reliable answer from an existing API.</a:t>
             </a:r>
           </a:p>
         </p:txBody>
@@ -1909,7 +1945,7 @@
           <p:cNvPr id="5" name="">
             <a:extLst xmlns:a="http://schemas.openxmlformats.org/drawingml/2006/main">
               <a:ext uri="{FF2B5EF4-FFF2-40B4-BE49-F238E27FC236}">
-                <a16:creationId xmlns:a16="http://schemas.microsoft.com/office/drawing/2014/main" id="{772E1208-591C-4D55-9CAB-D3D791BA05E7}"/>
+                <a16:creationId xmlns:a16="http://schemas.microsoft.com/office/drawing/2014/main" id="{E0834333-BB5F-482B-8284-3329BE3FBD13}"/>
               </a:ext>
             </a:extLst>
           </p:cNvPr>
@@ -1920,8 +1956,8 @@
         </p:nvSpPr>
         <p:spPr>
           <a:xfrm xmlns:a="http://schemas.openxmlformats.org/drawingml/2006/main">
-            <a:off x="714375" y="4762500"/>
-            <a:ext cx="6619875" cy="809625"/>
+            <a:off x="6496050" y="1809750"/>
+            <a:ext cx="5010150" cy="666750"/>
           </a:xfrm>
           <a:prstGeom xmlns:a="http://schemas.openxmlformats.org/drawingml/2006/main" prst="rect">
             <a:avLst/>
@@ -1932,15 +1968,19 @@
           </a:ln>
         </p:spPr>
         <p:txBody>
-          <a:bodyPr xmlns:a="http://schemas.openxmlformats.org/drawingml/2006/main">
+          <a:bodyPr xmlns:a="http://schemas.openxmlformats.org/drawingml/2006/main" lIns="0" tIns="0" rIns="0" bIns="0" anchor="t">
             <a:noAutofit/>
           </a:bodyPr>
           <a:lstStyle xmlns:a="http://schemas.openxmlformats.org/drawingml/2006/main"/>
           <a:p xmlns:a="http://schemas.openxmlformats.org/drawingml/2006/main">
             <a:pPr>
-              <a:defRPr sz="1875" b="0">
-                <a:solidFill>
-                  <a:srgbClr val="A35A10"/>
+              <a:lnSpc>
+                <a:spcPct val="118000"/>
+              </a:lnSpc>
+              <a:buNone/>
+              <a:defRPr sz="2175" b="1">
+                <a:solidFill>
+                  <a:srgbClr val="126C97"/>
                 </a:solidFill>
                 <a:latin typeface="Liberation Sans"/>
                 <a:ea typeface="Liberation Sans"/>
@@ -1948,45 +1988,267 @@
               </a:defRPr>
             </a:pPr>
             <a:r>
+              <a:rPr sz="2175" b="1">
+                <a:solidFill>
+                  <a:srgbClr val="126C97"/>
+                </a:solidFill>
+                <a:latin typeface="Liberation Sans"/>
+                <a:ea typeface="Liberation Sans"/>
+                <a:cs typeface="Liberation Sans"/>
+              </a:rPr>
+              <a:t>FieldProof proposal</a:t>
+            </a:r>
+          </a:p>
+        </p:txBody>
+      </p:sp>
+      <p:sp>
+        <p:nvSpPr>
+          <p:cNvPr id="6" name="">
+            <a:extLst xmlns:a="http://schemas.openxmlformats.org/drawingml/2006/main">
+              <a:ext uri="{FF2B5EF4-FFF2-40B4-BE49-F238E27FC236}">
+                <a16:creationId xmlns:a16="http://schemas.microsoft.com/office/drawing/2014/main" id="{9E2F1DFC-9F9C-42CF-B76F-C562E52F80F6}"/>
+              </a:ext>
+            </a:extLst>
+          </p:cNvPr>
+          <p:cNvSpPr>
+            <a:spLocks xmlns:a="http://schemas.openxmlformats.org/drawingml/2006/main" noGrp="1"/>
+          </p:cNvSpPr>
+          <p:nvPr/>
+        </p:nvSpPr>
+        <p:spPr>
+          <a:xfrm xmlns:a="http://schemas.openxmlformats.org/drawingml/2006/main">
+            <a:off x="6496050" y="2647950"/>
+            <a:ext cx="4895850" cy="1162050"/>
+          </a:xfrm>
+          <a:prstGeom xmlns:a="http://schemas.openxmlformats.org/drawingml/2006/main" prst="rect">
+            <a:avLst/>
+          </a:prstGeom>
+          <a:noFill xmlns:a="http://schemas.openxmlformats.org/drawingml/2006/main"/>
+          <a:ln xmlns:a="http://schemas.openxmlformats.org/drawingml/2006/main" w="0">
+            <a:noFill/>
+          </a:ln>
+        </p:spPr>
+        <p:txBody>
+          <a:bodyPr xmlns:a="http://schemas.openxmlformats.org/drawingml/2006/main" lIns="0" tIns="0" rIns="0" bIns="0" anchor="t">
+            <a:noAutofit/>
+          </a:bodyPr>
+          <a:lstStyle xmlns:a="http://schemas.openxmlformats.org/drawingml/2006/main"/>
+          <a:p xmlns:a="http://schemas.openxmlformats.org/drawingml/2006/main">
+            <a:pPr>
+              <a:lnSpc>
+                <a:spcPct val="118000"/>
+              </a:lnSpc>
+              <a:buNone/>
+              <a:defRPr sz="2100" b="0">
+                <a:solidFill>
+                  <a:srgbClr val="17364D"/>
+                </a:solidFill>
+                <a:latin typeface="Liberation Sans"/>
+                <a:ea typeface="Liberation Sans"/>
+                <a:cs typeface="Liberation Sans"/>
+              </a:defRPr>
+            </a:pPr>
+            <a:r>
+              <a:rPr sz="2100" b="0">
+                <a:solidFill>
+                  <a:srgbClr val="17364D"/>
+                </a:solidFill>
+                <a:latin typeface="Liberation Sans"/>
+                <a:ea typeface="Liberation Sans"/>
+                <a:cs typeface="Liberation Sans"/>
+              </a:rPr>
+              <a:t>Commission one check from a device already on site.</a:t>
+            </a:r>
+          </a:p>
+        </p:txBody>
+      </p:sp>
+      <p:sp>
+        <p:nvSpPr>
+          <p:cNvPr id="7" name="">
+            <a:extLst xmlns:a="http://schemas.openxmlformats.org/drawingml/2006/main">
+              <a:ext uri="{FF2B5EF4-FFF2-40B4-BE49-F238E27FC236}">
+                <a16:creationId xmlns:a16="http://schemas.microsoft.com/office/drawing/2014/main" id="{7BE6FCB7-35C5-4563-B3F3-287BEE46C1FF}"/>
+              </a:ext>
+            </a:extLst>
+          </p:cNvPr>
+          <p:cNvSpPr>
+            <a:spLocks xmlns:a="http://schemas.openxmlformats.org/drawingml/2006/main" noGrp="1"/>
+          </p:cNvSpPr>
+          <p:nvPr/>
+        </p:nvSpPr>
+        <p:spPr>
+          <a:xfrm xmlns:a="http://schemas.openxmlformats.org/drawingml/2006/main">
+            <a:off x="6496050" y="4000500"/>
+            <a:ext cx="4895850" cy="1295400"/>
+          </a:xfrm>
+          <a:prstGeom xmlns:a="http://schemas.openxmlformats.org/drawingml/2006/main" prst="rect">
+            <a:avLst/>
+          </a:prstGeom>
+          <a:noFill xmlns:a="http://schemas.openxmlformats.org/drawingml/2006/main"/>
+          <a:ln xmlns:a="http://schemas.openxmlformats.org/drawingml/2006/main" w="0">
+            <a:noFill/>
+          </a:ln>
+        </p:spPr>
+        <p:txBody>
+          <a:bodyPr xmlns:a="http://schemas.openxmlformats.org/drawingml/2006/main" lIns="0" tIns="0" rIns="0" bIns="0" anchor="t">
+            <a:noAutofit/>
+          </a:bodyPr>
+          <a:lstStyle xmlns:a="http://schemas.openxmlformats.org/drawingml/2006/main"/>
+          <a:p xmlns:a="http://schemas.openxmlformats.org/drawingml/2006/main">
+            <a:pPr>
+              <a:lnSpc>
+                <a:spcPct val="118000"/>
+              </a:lnSpc>
+              <a:buNone/>
+              <a:defRPr sz="2100" b="0">
+                <a:solidFill>
+                  <a:srgbClr val="17364D"/>
+                </a:solidFill>
+                <a:latin typeface="Liberation Sans"/>
+                <a:ea typeface="Liberation Sans"/>
+                <a:cs typeface="Liberation Sans"/>
+              </a:defRPr>
+            </a:pPr>
+            <a:r>
+              <a:rPr sz="2100" b="0">
+                <a:solidFill>
+                  <a:srgbClr val="17364D"/>
+                </a:solidFill>
+                <a:latin typeface="Liberation Sans"/>
+                <a:ea typeface="Liberation Sans"/>
+                <a:cs typeface="Liberation Sans"/>
+              </a:rPr>
+              <a:t>Get a new answer tied to that request.</a:t>
+            </a:r>
+          </a:p>
+        </p:txBody>
+      </p:sp>
+      <p:sp>
+        <p:nvSpPr>
+          <p:cNvPr id="8" name="">
+            <a:extLst xmlns:a="http://schemas.openxmlformats.org/drawingml/2006/main">
+              <a:ext uri="{FF2B5EF4-FFF2-40B4-BE49-F238E27FC236}">
+                <a16:creationId xmlns:a16="http://schemas.microsoft.com/office/drawing/2014/main" id="{F77B72B4-2475-456F-9386-7C50C067533B}"/>
+              </a:ext>
+            </a:extLst>
+          </p:cNvPr>
+          <p:cNvSpPr>
+            <a:spLocks xmlns:a="http://schemas.openxmlformats.org/drawingml/2006/main" noGrp="1"/>
+          </p:cNvSpPr>
+          <p:nvPr/>
+        </p:nvSpPr>
+        <p:spPr>
+          <a:xfrm xmlns:a="http://schemas.openxmlformats.org/drawingml/2006/main">
+            <a:off x="685800" y="5505450"/>
+            <a:ext cx="10820400" cy="590550"/>
+          </a:xfrm>
+          <a:prstGeom xmlns:a="http://schemas.openxmlformats.org/drawingml/2006/main" prst="rect">
+            <a:avLst/>
+          </a:prstGeom>
+          <a:noFill xmlns:a="http://schemas.openxmlformats.org/drawingml/2006/main"/>
+          <a:ln xmlns:a="http://schemas.openxmlformats.org/drawingml/2006/main" w="0">
+            <a:noFill/>
+          </a:ln>
+        </p:spPr>
+        <p:txBody>
+          <a:bodyPr xmlns:a="http://schemas.openxmlformats.org/drawingml/2006/main" lIns="0" tIns="0" rIns="0" bIns="0" anchor="t">
+            <a:noAutofit/>
+          </a:bodyPr>
+          <a:lstStyle xmlns:a="http://schemas.openxmlformats.org/drawingml/2006/main"/>
+          <a:p xmlns:a="http://schemas.openxmlformats.org/drawingml/2006/main">
+            <a:pPr>
+              <a:lnSpc>
+                <a:spcPct val="118000"/>
+              </a:lnSpc>
+              <a:buNone/>
+              <a:defRPr sz="1875" b="0">
+                <a:solidFill>
+                  <a:srgbClr val="126C97"/>
+                </a:solidFill>
+                <a:latin typeface="Liberation Sans"/>
+                <a:ea typeface="Liberation Sans"/>
+                <a:cs typeface="Liberation Sans"/>
+              </a:defRPr>
+            </a:pPr>
+            <a:r>
               <a:rPr sz="1875" b="0">
                 <a:solidFill>
-                  <a:srgbClr val="A35A10"/>
+                  <a:srgbClr val="126C97"/>
                 </a:solidFill>
                 <a:latin typeface="Liberation Sans"/>
                 <a:ea typeface="Liberation Sans"/>
                 <a:cs typeface="Liberation Sans"/>
               </a:rPr>
-              <a:t>A contact state does not prove contents, safe operation, or access permission.</a:t>
-            </a:r>
-          </a:p>
-        </p:txBody>
-      </p:sp>
-      <p:pic>
-        <p:nvPicPr>
-          <p:cNvPr id="12" name=""/>
-          <p:cNvPicPr>
-            <a:picLocks xmlns:a="http://schemas.openxmlformats.org/drawingml/2006/main" noChangeAspect="1"/>
-          </p:cNvPicPr>
+              <a:t>Value test: does the check replace a manual check or change a costly decision?</a:t>
+            </a:r>
+          </a:p>
+        </p:txBody>
+      </p:sp>
+      <p:sp>
+        <p:nvSpPr>
+          <p:cNvPr id="9" name="">
+            <a:extLst xmlns:a="http://schemas.openxmlformats.org/drawingml/2006/main">
+              <a:ext uri="{FF2B5EF4-FFF2-40B4-BE49-F238E27FC236}">
+                <a16:creationId xmlns:a16="http://schemas.microsoft.com/office/drawing/2014/main" id="{83F24F17-DEB1-4A9D-8F50-61AC77AE8886}"/>
+              </a:ext>
+            </a:extLst>
+          </p:cNvPr>
+          <p:cNvSpPr>
+            <a:spLocks xmlns:a="http://schemas.openxmlformats.org/drawingml/2006/main" noGrp="1"/>
+          </p:cNvSpPr>
           <p:nvPr/>
-        </p:nvPicPr>
-        <p:blipFill>
-          <a:blip xmlns:r="http://schemas.openxmlformats.org/officeDocument/2006/relationships" xmlns:a="http://schemas.openxmlformats.org/drawingml/2006/main" r:embed="Ra0f015452beb4037"/>
-          <a:stretch xmlns:a="http://schemas.openxmlformats.org/drawingml/2006/main"/>
-        </p:blipFill>
+        </p:nvSpPr>
         <p:spPr>
           <a:xfrm xmlns:a="http://schemas.openxmlformats.org/drawingml/2006/main">
-            <a:off x="7572375" y="2811959"/>
-            <a:ext cx="3857625" cy="948333"/>
+            <a:off x="685800" y="6276975"/>
+            <a:ext cx="10820400" cy="419100"/>
           </a:xfrm>
           <a:prstGeom xmlns:a="http://schemas.openxmlformats.org/drawingml/2006/main" prst="rect">
             <a:avLst/>
           </a:prstGeom>
-        </p:spPr>
-      </p:pic>
+          <a:noFill xmlns:a="http://schemas.openxmlformats.org/drawingml/2006/main"/>
+          <a:ln xmlns:a="http://schemas.openxmlformats.org/drawingml/2006/main" w="0">
+            <a:noFill/>
+          </a:ln>
+        </p:spPr>
+        <p:txBody>
+          <a:bodyPr xmlns:a="http://schemas.openxmlformats.org/drawingml/2006/main" lIns="0" tIns="0" rIns="0" bIns="0" anchor="t">
+            <a:noAutofit/>
+          </a:bodyPr>
+          <a:lstStyle xmlns:a="http://schemas.openxmlformats.org/drawingml/2006/main"/>
+          <a:p xmlns:a="http://schemas.openxmlformats.org/drawingml/2006/main">
+            <a:pPr>
+              <a:lnSpc>
+                <a:spcPct val="118000"/>
+              </a:lnSpc>
+              <a:buNone/>
+              <a:defRPr sz="1350" b="0">
+                <a:solidFill>
+                  <a:srgbClr val="536D80"/>
+                </a:solidFill>
+                <a:latin typeface="Liberation Sans"/>
+                <a:ea typeface="Liberation Sans"/>
+                <a:cs typeface="Liberation Sans"/>
+              </a:defRPr>
+            </a:pPr>
+            <a:r>
+              <a:rPr sz="1350" b="0">
+                <a:solidFill>
+                  <a:srgbClr val="536D80"/>
+                </a:solidFill>
+                <a:latin typeface="Liberation Sans"/>
+                <a:ea typeface="Liberation Sans"/>
+                <a:cs typeface="Liberation Sans"/>
+              </a:rPr>
+              <a:t>02 / Buyer hypothesis. No customer or willingness to pay is validated. Use an existing API when it supplies the answer.</a:t>
+            </a:r>
+          </a:p>
+        </p:txBody>
+      </p:sp>
     </p:spTree>
     <p:extLst>
       <p:ext uri="{BB962C8B-B14F-4D97-AF65-F5344CB8AC3E}">
-        <p14:creationId xmlns:p14="http://schemas.microsoft.com/office/powerpoint/2010/main" val="1982447982"/>
+        <p14:creationId xmlns:p14="http://schemas.microsoft.com/office/powerpoint/2010/main" val="53345973"/>
       </p:ext>
     </p:extLst>
   </p:cSld>
@@ -1999,7 +2261,7 @@
     <p:bg>
       <p:bgPr>
         <a:solidFill xmlns:a="http://schemas.openxmlformats.org/drawingml/2006/main">
-          <a:srgbClr val="F3F3ED"/>
+          <a:srgbClr val="F4FAFF"/>
         </a:solidFill>
       </p:bgPr>
     </p:bg>
@@ -2014,10 +2276,10 @@
       </p:grpSpPr>
       <p:sp>
         <p:nvSpPr>
-          <p:cNvPr id="8" name="">
+          <p:cNvPr id="11" name="">
             <a:extLst xmlns:a="http://schemas.openxmlformats.org/drawingml/2006/main">
               <a:ext uri="{FF2B5EF4-FFF2-40B4-BE49-F238E27FC236}">
-                <a16:creationId xmlns:a16="http://schemas.microsoft.com/office/drawing/2014/main" id="{EACF578E-C54E-4C61-B7E9-D6E8059571D9}"/>
+                <a16:creationId xmlns:a16="http://schemas.microsoft.com/office/drawing/2014/main" id="{06C900AF-428E-4ACE-89D3-DBE9CEDD8674}"/>
               </a:ext>
             </a:extLst>
           </p:cNvPr>
@@ -2028,8 +2290,8 @@
         </p:nvSpPr>
         <p:spPr>
           <a:xfrm xmlns:a="http://schemas.openxmlformats.org/drawingml/2006/main">
-            <a:off x="704850" y="495300"/>
-            <a:ext cx="10668000" cy="704850"/>
+            <a:off x="685800" y="457200"/>
+            <a:ext cx="10820400" cy="857250"/>
           </a:xfrm>
           <a:prstGeom xmlns:a="http://schemas.openxmlformats.org/drawingml/2006/main" prst="rect">
             <a:avLst/>
@@ -2040,15 +2302,19 @@
           </a:ln>
         </p:spPr>
         <p:txBody>
-          <a:bodyPr xmlns:a="http://schemas.openxmlformats.org/drawingml/2006/main">
+          <a:bodyPr xmlns:a="http://schemas.openxmlformats.org/drawingml/2006/main" lIns="0" tIns="0" rIns="0" bIns="0" anchor="t">
             <a:noAutofit/>
           </a:bodyPr>
           <a:lstStyle xmlns:a="http://schemas.openxmlformats.org/drawingml/2006/main"/>
           <a:p xmlns:a="http://schemas.openxmlformats.org/drawingml/2006/main">
             <a:pPr>
-              <a:defRPr sz="3300" b="1">
-                <a:solidFill>
-                  <a:srgbClr val="183146"/>
+              <a:lnSpc>
+                <a:spcPct val="118000"/>
+              </a:lnSpc>
+              <a:buNone/>
+              <a:defRPr sz="3450" b="1">
+                <a:solidFill>
+                  <a:srgbClr val="17364D"/>
                 </a:solidFill>
                 <a:latin typeface="Liberation Sans"/>
                 <a:ea typeface="Liberation Sans"/>
@@ -2056,15 +2322,15 @@
               </a:defRPr>
             </a:pPr>
             <a:r>
-              <a:rPr sz="3300" b="1">
-                <a:solidFill>
-                  <a:srgbClr val="183146"/>
+              <a:rPr sz="3450" b="1">
+                <a:solidFill>
+                  <a:srgbClr val="17364D"/>
                 </a:solidFill>
                 <a:latin typeface="Liberation Sans"/>
                 <a:ea typeface="Liberation Sans"/>
                 <a:cs typeface="Liberation Sans"/>
               </a:rPr>
-              <a:t>One paid observation</a:t>
+              <a:t>What the prototype does</a:t>
             </a:r>
           </a:p>
         </p:txBody>
@@ -2074,7 +2340,7 @@
           <p:cNvPr id="2" name="">
             <a:extLst xmlns:a="http://schemas.openxmlformats.org/drawingml/2006/main">
               <a:ext uri="{FF2B5EF4-FFF2-40B4-BE49-F238E27FC236}">
-                <a16:creationId xmlns:a16="http://schemas.microsoft.com/office/drawing/2014/main" id="{5C87DB04-C622-4F6C-A82B-2B5869543F4F}"/>
+                <a16:creationId xmlns:a16="http://schemas.microsoft.com/office/drawing/2014/main" id="{260C98F7-8B0C-42A1-8ECA-12A1946BB3B4}"/>
               </a:ext>
             </a:extLst>
           </p:cNvPr>
@@ -2085,8 +2351,8 @@
         </p:nvSpPr>
         <p:spPr>
           <a:xfrm xmlns:a="http://schemas.openxmlformats.org/drawingml/2006/main">
-            <a:off x="714375" y="6343650"/>
-            <a:ext cx="4762500" cy="228600"/>
+            <a:off x="685800" y="1790700"/>
+            <a:ext cx="5010150" cy="514350"/>
           </a:xfrm>
           <a:prstGeom xmlns:a="http://schemas.openxmlformats.org/drawingml/2006/main" prst="rect">
             <a:avLst/>
@@ -2097,15 +2363,19 @@
           </a:ln>
         </p:spPr>
         <p:txBody>
-          <a:bodyPr xmlns:a="http://schemas.openxmlformats.org/drawingml/2006/main">
+          <a:bodyPr xmlns:a="http://schemas.openxmlformats.org/drawingml/2006/main" lIns="0" tIns="0" rIns="0" bIns="0" anchor="t">
             <a:noAutofit/>
           </a:bodyPr>
           <a:lstStyle xmlns:a="http://schemas.openxmlformats.org/drawingml/2006/main"/>
           <a:p xmlns:a="http://schemas.openxmlformats.org/drawingml/2006/main">
             <a:pPr>
-              <a:defRPr sz="1125" b="1">
-                <a:solidFill>
-                  <a:srgbClr val="146B8D"/>
+              <a:lnSpc>
+                <a:spcPct val="118000"/>
+              </a:lnSpc>
+              <a:buNone/>
+              <a:defRPr sz="2250" b="1">
+                <a:solidFill>
+                  <a:srgbClr val="126C97"/>
                 </a:solidFill>
                 <a:latin typeface="Liberation Sans"/>
                 <a:ea typeface="Liberation Sans"/>
@@ -2113,15 +2383,15 @@
               </a:defRPr>
             </a:pPr>
             <a:r>
-              <a:rPr sz="1125" b="1">
-                <a:solidFill>
-                  <a:srgbClr val="146B8D"/>
+              <a:rPr sz="2250" b="1">
+                <a:solidFill>
+                  <a:srgbClr val="126C97"/>
                 </a:solidFill>
                 <a:latin typeface="Liberation Sans"/>
                 <a:ea typeface="Liberation Sans"/>
                 <a:cs typeface="Liberation Sans"/>
               </a:rPr>
-              <a:t>FIELDPROOF  /  03</a:t>
+              <a:t>1. Request a check</a:t>
             </a:r>
           </a:p>
         </p:txBody>
@@ -2131,7 +2401,7 @@
           <p:cNvPr id="3" name="">
             <a:extLst xmlns:a="http://schemas.openxmlformats.org/drawingml/2006/main">
               <a:ext uri="{FF2B5EF4-FFF2-40B4-BE49-F238E27FC236}">
-                <a16:creationId xmlns:a16="http://schemas.microsoft.com/office/drawing/2014/main" id="{457D15E2-80DA-4B43-BE62-B211B5BB7E7D}"/>
+                <a16:creationId xmlns:a16="http://schemas.microsoft.com/office/drawing/2014/main" id="{CAD29CF3-2CE0-42C2-B050-C6AFDA61CE16}"/>
               </a:ext>
             </a:extLst>
           </p:cNvPr>
@@ -2142,8 +2412,8 @@
         </p:nvSpPr>
         <p:spPr>
           <a:xfrm xmlns:a="http://schemas.openxmlformats.org/drawingml/2006/main">
-            <a:off x="714375" y="1428750"/>
-            <a:ext cx="5810250" cy="685800"/>
+            <a:off x="685800" y="2409825"/>
+            <a:ext cx="4953000" cy="1257300"/>
           </a:xfrm>
           <a:prstGeom xmlns:a="http://schemas.openxmlformats.org/drawingml/2006/main" prst="rect">
             <a:avLst/>
@@ -2154,15 +2424,19 @@
           </a:ln>
         </p:spPr>
         <p:txBody>
-          <a:bodyPr xmlns:a="http://schemas.openxmlformats.org/drawingml/2006/main">
+          <a:bodyPr xmlns:a="http://schemas.openxmlformats.org/drawingml/2006/main" lIns="0" tIns="0" rIns="0" bIns="0" anchor="t">
             <a:noAutofit/>
           </a:bodyPr>
           <a:lstStyle xmlns:a="http://schemas.openxmlformats.org/drawingml/2006/main"/>
           <a:p xmlns:a="http://schemas.openxmlformats.org/drawingml/2006/main">
             <a:pPr>
-              <a:defRPr sz="2100" b="0">
-                <a:solidFill>
-                  <a:srgbClr val="183146"/>
+              <a:lnSpc>
+                <a:spcPct val="118000"/>
+              </a:lnSpc>
+              <a:buNone/>
+              <a:defRPr sz="2025" b="0">
+                <a:solidFill>
+                  <a:srgbClr val="17364D"/>
                 </a:solidFill>
                 <a:latin typeface="Liberation Sans"/>
                 <a:ea typeface="Liberation Sans"/>
@@ -2170,15 +2444,15 @@
               </a:defRPr>
             </a:pPr>
             <a:r>
-              <a:rPr sz="2100" b="0">
-                <a:solidFill>
-                  <a:srgbClr val="183146"/>
+              <a:rPr sz="2025" b="0">
+                <a:solidFill>
+                  <a:srgbClr val="17364D"/>
                 </a:solidFill>
                 <a:latin typeface="Liberation Sans"/>
                 <a:ea typeface="Liberation Sans"/>
                 <a:cs typeface="Liberation Sans"/>
               </a:rPr>
-              <a:t>Buyer sets provider, question, price, and age limit.</a:t>
+              <a:t>The buyer fixes the contact question, device key, price, and ten-second age limit.</a:t>
             </a:r>
           </a:p>
         </p:txBody>
@@ -2188,7 +2462,7 @@
           <p:cNvPr id="4" name="">
             <a:extLst xmlns:a="http://schemas.openxmlformats.org/drawingml/2006/main">
               <a:ext uri="{FF2B5EF4-FFF2-40B4-BE49-F238E27FC236}">
-                <a16:creationId xmlns:a16="http://schemas.microsoft.com/office/drawing/2014/main" id="{AF7D161A-7A6B-4C9C-AE41-085F2EE0B4F9}"/>
+                <a16:creationId xmlns:a16="http://schemas.microsoft.com/office/drawing/2014/main" id="{DF0EC04A-FC93-46DD-BBC8-05E2B1D8E3D8}"/>
               </a:ext>
             </a:extLst>
           </p:cNvPr>
@@ -2199,8 +2473,8 @@
         </p:nvSpPr>
         <p:spPr>
           <a:xfrm xmlns:a="http://schemas.openxmlformats.org/drawingml/2006/main">
-            <a:off x="714375" y="2381250"/>
-            <a:ext cx="6191250" cy="838200"/>
+            <a:off x="6496050" y="1790700"/>
+            <a:ext cx="5010150" cy="514350"/>
           </a:xfrm>
           <a:prstGeom xmlns:a="http://schemas.openxmlformats.org/drawingml/2006/main" prst="rect">
             <a:avLst/>
@@ -2211,15 +2485,19 @@
           </a:ln>
         </p:spPr>
         <p:txBody>
-          <a:bodyPr xmlns:a="http://schemas.openxmlformats.org/drawingml/2006/main">
+          <a:bodyPr xmlns:a="http://schemas.openxmlformats.org/drawingml/2006/main" lIns="0" tIns="0" rIns="0" bIns="0" anchor="t">
             <a:noAutofit/>
           </a:bodyPr>
           <a:lstStyle xmlns:a="http://schemas.openxmlformats.org/drawingml/2006/main"/>
           <a:p xmlns:a="http://schemas.openxmlformats.org/drawingml/2006/main">
             <a:pPr>
-              <a:defRPr sz="2175" b="1">
-                <a:solidFill>
-                  <a:srgbClr val="146B8D"/>
+              <a:lnSpc>
+                <a:spcPct val="118000"/>
+              </a:lnSpc>
+              <a:buNone/>
+              <a:defRPr sz="2250" b="1">
+                <a:solidFill>
+                  <a:srgbClr val="126C97"/>
                 </a:solidFill>
                 <a:latin typeface="Liberation Sans"/>
                 <a:ea typeface="Liberation Sans"/>
@@ -2227,15 +2505,15 @@
               </a:defRPr>
             </a:pPr>
             <a:r>
-              <a:rPr sz="2175" b="1">
-                <a:solidFill>
-                  <a:srgbClr val="146B8D"/>
+              <a:rPr sz="2250" b="1">
+                <a:solidFill>
+                  <a:srgbClr val="126C97"/>
                 </a:solidFill>
                 <a:latin typeface="Liberation Sans"/>
                 <a:ea typeface="Liberation Sans"/>
                 <a:cs typeface="Liberation Sans"/>
               </a:rPr>
-              <a:t>x402 settles 0.001 Devnet USDC on Solana Devnet before capture.</a:t>
+              <a:t>2. Pay the operator</a:t>
             </a:r>
           </a:p>
         </p:txBody>
@@ -2245,7 +2523,7 @@
           <p:cNvPr id="5" name="">
             <a:extLst xmlns:a="http://schemas.openxmlformats.org/drawingml/2006/main">
               <a:ext uri="{FF2B5EF4-FFF2-40B4-BE49-F238E27FC236}">
-                <a16:creationId xmlns:a16="http://schemas.microsoft.com/office/drawing/2014/main" id="{6A52DFEA-9646-4DE0-AA1D-EE83C91929CA}"/>
+                <a16:creationId xmlns:a16="http://schemas.microsoft.com/office/drawing/2014/main" id="{41C0DCA4-3642-4855-B7DC-9BCB70D235DB}"/>
               </a:ext>
             </a:extLst>
           </p:cNvPr>
@@ -2256,8 +2534,8 @@
         </p:nvSpPr>
         <p:spPr>
           <a:xfrm xmlns:a="http://schemas.openxmlformats.org/drawingml/2006/main">
-            <a:off x="714375" y="3714750"/>
-            <a:ext cx="6191250" cy="895350"/>
+            <a:off x="6496050" y="2409825"/>
+            <a:ext cx="4953000" cy="1257300"/>
           </a:xfrm>
           <a:prstGeom xmlns:a="http://schemas.openxmlformats.org/drawingml/2006/main" prst="rect">
             <a:avLst/>
@@ -2268,15 +2546,19 @@
           </a:ln>
         </p:spPr>
         <p:txBody>
-          <a:bodyPr xmlns:a="http://schemas.openxmlformats.org/drawingml/2006/main">
+          <a:bodyPr xmlns:a="http://schemas.openxmlformats.org/drawingml/2006/main" lIns="0" tIns="0" rIns="0" bIns="0" anchor="t">
             <a:noAutofit/>
           </a:bodyPr>
           <a:lstStyle xmlns:a="http://schemas.openxmlformats.org/drawingml/2006/main"/>
           <a:p xmlns:a="http://schemas.openxmlformats.org/drawingml/2006/main">
             <a:pPr>
-              <a:defRPr sz="2100" b="0">
-                <a:solidFill>
-                  <a:srgbClr val="183146"/>
+              <a:lnSpc>
+                <a:spcPct val="118000"/>
+              </a:lnSpc>
+              <a:buNone/>
+              <a:defRPr sz="2025" b="0">
+                <a:solidFill>
+                  <a:srgbClr val="17364D"/>
                 </a:solidFill>
                 <a:latin typeface="Liberation Sans"/>
                 <a:ea typeface="Liberation Sans"/>
@@ -2284,15 +2566,15 @@
               </a:defRPr>
             </a:pPr>
             <a:r>
-              <a:rPr sz="2100" b="0">
-                <a:solidFill>
-                  <a:srgbClr val="183146"/>
+              <a:rPr sz="2025" b="0">
+                <a:solidFill>
+                  <a:srgbClr val="17364D"/>
                 </a:solidFill>
                 <a:latin typeface="Liberation Sans"/>
                 <a:ea typeface="Liberation Sans"/>
                 <a:cs typeface="Liberation Sans"/>
               </a:rPr>
-              <a:t>ESP32 samples the contact and returns its original P-256 signed receipt.</a:t>
+              <a:t>Solana x402 settles 0.001 test USDC before measurement.</a:t>
             </a:r>
           </a:p>
         </p:txBody>
@@ -2302,7 +2584,7 @@
           <p:cNvPr id="6" name="">
             <a:extLst xmlns:a="http://schemas.openxmlformats.org/drawingml/2006/main">
               <a:ext uri="{FF2B5EF4-FFF2-40B4-BE49-F238E27FC236}">
-                <a16:creationId xmlns:a16="http://schemas.microsoft.com/office/drawing/2014/main" id="{2B74A9B9-B4B3-41D0-A590-E2945882D2ED}"/>
+                <a16:creationId xmlns:a16="http://schemas.microsoft.com/office/drawing/2014/main" id="{290DDFC4-B564-4CAE-BF06-872E6601598F}"/>
               </a:ext>
             </a:extLst>
           </p:cNvPr>
@@ -2313,8 +2595,8 @@
         </p:nvSpPr>
         <p:spPr>
           <a:xfrm xmlns:a="http://schemas.openxmlformats.org/drawingml/2006/main">
-            <a:off x="714375" y="5391150"/>
-            <a:ext cx="6953250" cy="476250"/>
+            <a:off x="685800" y="3810000"/>
+            <a:ext cx="5010150" cy="514350"/>
           </a:xfrm>
           <a:prstGeom xmlns:a="http://schemas.openxmlformats.org/drawingml/2006/main" prst="rect">
             <a:avLst/>
@@ -2325,15 +2607,19 @@
           </a:ln>
         </p:spPr>
         <p:txBody>
-          <a:bodyPr xmlns:a="http://schemas.openxmlformats.org/drawingml/2006/main">
+          <a:bodyPr xmlns:a="http://schemas.openxmlformats.org/drawingml/2006/main" lIns="0" tIns="0" rIns="0" bIns="0" anchor="t">
             <a:noAutofit/>
           </a:bodyPr>
           <a:lstStyle xmlns:a="http://schemas.openxmlformats.org/drawingml/2006/main"/>
           <a:p xmlns:a="http://schemas.openxmlformats.org/drawingml/2006/main">
             <a:pPr>
-              <a:defRPr sz="1500" b="1">
-                <a:solidFill>
-                  <a:srgbClr val="A35A10"/>
+              <a:lnSpc>
+                <a:spcPct val="118000"/>
+              </a:lnSpc>
+              <a:buNone/>
+              <a:defRPr sz="2250" b="1">
+                <a:solidFill>
+                  <a:srgbClr val="126C97"/>
                 </a:solidFill>
                 <a:latin typeface="Liberation Sans"/>
                 <a:ea typeface="Liberation Sans"/>
@@ -2341,45 +2627,267 @@
               </a:defRPr>
             </a:pPr>
             <a:r>
-              <a:rPr sz="1500" b="1">
-                <a:solidFill>
-                  <a:srgbClr val="A35A10"/>
+              <a:rPr sz="2250" b="1">
+                <a:solidFill>
+                  <a:srgbClr val="126C97"/>
                 </a:solidFill>
                 <a:latin typeface="Liberation Sans"/>
                 <a:ea typeface="Liberation Sans"/>
                 <a:cs typeface="Liberation Sans"/>
               </a:rPr>
-              <a:t>peaq identity and linked activity event: INTEGRATION PENDING</a:t>
-            </a:r>
-          </a:p>
-        </p:txBody>
-      </p:sp>
-      <p:pic>
-        <p:nvPicPr>
-          <p:cNvPr id="14" name=""/>
-          <p:cNvPicPr>
-            <a:picLocks xmlns:a="http://schemas.openxmlformats.org/drawingml/2006/main" noChangeAspect="1"/>
-          </p:cNvPicPr>
+              <a:t>3. Measure and sign</a:t>
+            </a:r>
+          </a:p>
+        </p:txBody>
+      </p:sp>
+      <p:sp>
+        <p:nvSpPr>
+          <p:cNvPr id="7" name="">
+            <a:extLst xmlns:a="http://schemas.openxmlformats.org/drawingml/2006/main">
+              <a:ext uri="{FF2B5EF4-FFF2-40B4-BE49-F238E27FC236}">
+                <a16:creationId xmlns:a16="http://schemas.microsoft.com/office/drawing/2014/main" id="{53109F1B-54B3-4D2D-9EB9-C48B5532B918}"/>
+              </a:ext>
+            </a:extLst>
+          </p:cNvPr>
+          <p:cNvSpPr>
+            <a:spLocks xmlns:a="http://schemas.openxmlformats.org/drawingml/2006/main" noGrp="1"/>
+          </p:cNvSpPr>
           <p:nvPr/>
-        </p:nvPicPr>
-        <p:blipFill>
-          <a:blip xmlns:r="http://schemas.openxmlformats.org/officeDocument/2006/relationships" xmlns:a="http://schemas.openxmlformats.org/drawingml/2006/main" r:embed="R1ded3adc633146a5"/>
-          <a:stretch xmlns:a="http://schemas.openxmlformats.org/drawingml/2006/main"/>
-        </p:blipFill>
+        </p:nvSpPr>
         <p:spPr>
           <a:xfrm xmlns:a="http://schemas.openxmlformats.org/drawingml/2006/main">
-            <a:off x="7524750" y="2339538"/>
-            <a:ext cx="3905250" cy="1988423"/>
+            <a:off x="685800" y="4429125"/>
+            <a:ext cx="4953000" cy="1257300"/>
           </a:xfrm>
           <a:prstGeom xmlns:a="http://schemas.openxmlformats.org/drawingml/2006/main" prst="rect">
             <a:avLst/>
           </a:prstGeom>
-        </p:spPr>
-      </p:pic>
+          <a:noFill xmlns:a="http://schemas.openxmlformats.org/drawingml/2006/main"/>
+          <a:ln xmlns:a="http://schemas.openxmlformats.org/drawingml/2006/main" w="0">
+            <a:noFill/>
+          </a:ln>
+        </p:spPr>
+        <p:txBody>
+          <a:bodyPr xmlns:a="http://schemas.openxmlformats.org/drawingml/2006/main" lIns="0" tIns="0" rIns="0" bIns="0" anchor="t">
+            <a:noAutofit/>
+          </a:bodyPr>
+          <a:lstStyle xmlns:a="http://schemas.openxmlformats.org/drawingml/2006/main"/>
+          <a:p xmlns:a="http://schemas.openxmlformats.org/drawingml/2006/main">
+            <a:pPr>
+              <a:lnSpc>
+                <a:spcPct val="118000"/>
+              </a:lnSpc>
+              <a:buNone/>
+              <a:defRPr sz="2025" b="0">
+                <a:solidFill>
+                  <a:srgbClr val="17364D"/>
+                </a:solidFill>
+                <a:latin typeface="Liberation Sans"/>
+                <a:ea typeface="Liberation Sans"/>
+                <a:cs typeface="Liberation Sans"/>
+              </a:defRPr>
+            </a:pPr>
+            <a:r>
+              <a:rPr sz="2025" b="0">
+                <a:solidFill>
+                  <a:srgbClr val="17364D"/>
+                </a:solidFill>
+                <a:latin typeface="Liberation Sans"/>
+                <a:ea typeface="Liberation Sans"/>
+                <a:cs typeface="Liberation Sans"/>
+              </a:rPr>
+              <a:t>The ESP32 reads the physical input and signs a new answer for this request.</a:t>
+            </a:r>
+          </a:p>
+        </p:txBody>
+      </p:sp>
+      <p:sp>
+        <p:nvSpPr>
+          <p:cNvPr id="8" name="">
+            <a:extLst xmlns:a="http://schemas.openxmlformats.org/drawingml/2006/main">
+              <a:ext uri="{FF2B5EF4-FFF2-40B4-BE49-F238E27FC236}">
+                <a16:creationId xmlns:a16="http://schemas.microsoft.com/office/drawing/2014/main" id="{1B98F7FE-2105-4D6E-9CF5-22D676EBE4CC}"/>
+              </a:ext>
+            </a:extLst>
+          </p:cNvPr>
+          <p:cNvSpPr>
+            <a:spLocks xmlns:a="http://schemas.openxmlformats.org/drawingml/2006/main" noGrp="1"/>
+          </p:cNvSpPr>
+          <p:nvPr/>
+        </p:nvSpPr>
+        <p:spPr>
+          <a:xfrm xmlns:a="http://schemas.openxmlformats.org/drawingml/2006/main">
+            <a:off x="6496050" y="3810000"/>
+            <a:ext cx="5010150" cy="514350"/>
+          </a:xfrm>
+          <a:prstGeom xmlns:a="http://schemas.openxmlformats.org/drawingml/2006/main" prst="rect">
+            <a:avLst/>
+          </a:prstGeom>
+          <a:noFill xmlns:a="http://schemas.openxmlformats.org/drawingml/2006/main"/>
+          <a:ln xmlns:a="http://schemas.openxmlformats.org/drawingml/2006/main" w="0">
+            <a:noFill/>
+          </a:ln>
+        </p:spPr>
+        <p:txBody>
+          <a:bodyPr xmlns:a="http://schemas.openxmlformats.org/drawingml/2006/main" lIns="0" tIns="0" rIns="0" bIns="0" anchor="t">
+            <a:noAutofit/>
+          </a:bodyPr>
+          <a:lstStyle xmlns:a="http://schemas.openxmlformats.org/drawingml/2006/main"/>
+          <a:p xmlns:a="http://schemas.openxmlformats.org/drawingml/2006/main">
+            <a:pPr>
+              <a:lnSpc>
+                <a:spcPct val="118000"/>
+              </a:lnSpc>
+              <a:buNone/>
+              <a:defRPr sz="2250" b="1">
+                <a:solidFill>
+                  <a:srgbClr val="126C97"/>
+                </a:solidFill>
+                <a:latin typeface="Liberation Sans"/>
+                <a:ea typeface="Liberation Sans"/>
+                <a:cs typeface="Liberation Sans"/>
+              </a:defRPr>
+            </a:pPr>
+            <a:r>
+              <a:rPr sz="2250" b="1">
+                <a:solidFill>
+                  <a:srgbClr val="126C97"/>
+                </a:solidFill>
+                <a:latin typeface="Liberation Sans"/>
+                <a:ea typeface="Liberation Sans"/>
+                <a:cs typeface="Liberation Sans"/>
+              </a:rPr>
+              <a:t>4. Verify and decide</a:t>
+            </a:r>
+          </a:p>
+        </p:txBody>
+      </p:sp>
+      <p:sp>
+        <p:nvSpPr>
+          <p:cNvPr id="9" name="">
+            <a:extLst xmlns:a="http://schemas.openxmlformats.org/drawingml/2006/main">
+              <a:ext uri="{FF2B5EF4-FFF2-40B4-BE49-F238E27FC236}">
+                <a16:creationId xmlns:a16="http://schemas.microsoft.com/office/drawing/2014/main" id="{826755B0-BC71-4DAF-B01C-EFAAF9ED5003}"/>
+              </a:ext>
+            </a:extLst>
+          </p:cNvPr>
+          <p:cNvSpPr>
+            <a:spLocks xmlns:a="http://schemas.openxmlformats.org/drawingml/2006/main" noGrp="1"/>
+          </p:cNvSpPr>
+          <p:nvPr/>
+        </p:nvSpPr>
+        <p:spPr>
+          <a:xfrm xmlns:a="http://schemas.openxmlformats.org/drawingml/2006/main">
+            <a:off x="6496050" y="4429125"/>
+            <a:ext cx="4953000" cy="1257300"/>
+          </a:xfrm>
+          <a:prstGeom xmlns:a="http://schemas.openxmlformats.org/drawingml/2006/main" prst="rect">
+            <a:avLst/>
+          </a:prstGeom>
+          <a:noFill xmlns:a="http://schemas.openxmlformats.org/drawingml/2006/main"/>
+          <a:ln xmlns:a="http://schemas.openxmlformats.org/drawingml/2006/main" w="0">
+            <a:noFill/>
+          </a:ln>
+        </p:spPr>
+        <p:txBody>
+          <a:bodyPr xmlns:a="http://schemas.openxmlformats.org/drawingml/2006/main" lIns="0" tIns="0" rIns="0" bIns="0" anchor="t">
+            <a:noAutofit/>
+          </a:bodyPr>
+          <a:lstStyle xmlns:a="http://schemas.openxmlformats.org/drawingml/2006/main"/>
+          <a:p xmlns:a="http://schemas.openxmlformats.org/drawingml/2006/main">
+            <a:pPr>
+              <a:lnSpc>
+                <a:spcPct val="118000"/>
+              </a:lnSpc>
+              <a:buNone/>
+              <a:defRPr sz="2025" b="0">
+                <a:solidFill>
+                  <a:srgbClr val="17364D"/>
+                </a:solidFill>
+                <a:latin typeface="Liberation Sans"/>
+                <a:ea typeface="Liberation Sans"/>
+                <a:cs typeface="Liberation Sans"/>
+              </a:defRPr>
+            </a:pPr>
+            <a:r>
+              <a:rPr sz="2025" b="0">
+                <a:solidFill>
+                  <a:srgbClr val="17364D"/>
+                </a:solidFill>
+                <a:latin typeface="Liberation Sans"/>
+                <a:ea typeface="Liberation Sans"/>
+                <a:cs typeface="Liberation Sans"/>
+              </a:rPr>
+              <a:t>The buyer verifies the source, request, signature, and age before its next action.</a:t>
+            </a:r>
+          </a:p>
+        </p:txBody>
+      </p:sp>
+      <p:sp>
+        <p:nvSpPr>
+          <p:cNvPr id="10" name="">
+            <a:extLst xmlns:a="http://schemas.openxmlformats.org/drawingml/2006/main">
+              <a:ext uri="{FF2B5EF4-FFF2-40B4-BE49-F238E27FC236}">
+                <a16:creationId xmlns:a16="http://schemas.microsoft.com/office/drawing/2014/main" id="{7E44799A-1C24-46F1-930B-EC0C3B873D2A}"/>
+              </a:ext>
+            </a:extLst>
+          </p:cNvPr>
+          <p:cNvSpPr>
+            <a:spLocks xmlns:a="http://schemas.openxmlformats.org/drawingml/2006/main" noGrp="1"/>
+          </p:cNvSpPr>
+          <p:nvPr/>
+        </p:nvSpPr>
+        <p:spPr>
+          <a:xfrm xmlns:a="http://schemas.openxmlformats.org/drawingml/2006/main">
+            <a:off x="685800" y="6276975"/>
+            <a:ext cx="10820400" cy="419100"/>
+          </a:xfrm>
+          <a:prstGeom xmlns:a="http://schemas.openxmlformats.org/drawingml/2006/main" prst="rect">
+            <a:avLst/>
+          </a:prstGeom>
+          <a:noFill xmlns:a="http://schemas.openxmlformats.org/drawingml/2006/main"/>
+          <a:ln xmlns:a="http://schemas.openxmlformats.org/drawingml/2006/main" w="0">
+            <a:noFill/>
+          </a:ln>
+        </p:spPr>
+        <p:txBody>
+          <a:bodyPr xmlns:a="http://schemas.openxmlformats.org/drawingml/2006/main" lIns="0" tIns="0" rIns="0" bIns="0" anchor="t">
+            <a:noAutofit/>
+          </a:bodyPr>
+          <a:lstStyle xmlns:a="http://schemas.openxmlformats.org/drawingml/2006/main"/>
+          <a:p xmlns:a="http://schemas.openxmlformats.org/drawingml/2006/main">
+            <a:pPr>
+              <a:lnSpc>
+                <a:spcPct val="118000"/>
+              </a:lnSpc>
+              <a:buNone/>
+              <a:defRPr sz="1350" b="0">
+                <a:solidFill>
+                  <a:srgbClr val="536D80"/>
+                </a:solidFill>
+                <a:latin typeface="Liberation Sans"/>
+                <a:ea typeface="Liberation Sans"/>
+                <a:cs typeface="Liberation Sans"/>
+              </a:defRPr>
+            </a:pPr>
+            <a:r>
+              <a:rPr sz="1350" b="0">
+                <a:solidFill>
+                  <a:srgbClr val="536D80"/>
+                </a:solidFill>
+                <a:latin typeface="Liberation Sans"/>
+                <a:ea typeface="Liberation Sans"/>
+                <a:cs typeface="Liberation Sans"/>
+              </a:rPr>
+              <a:t>03 / OPEN and CLOSED both fulfill the paid check. The operator wallet receives test tokens. The buyer's next action is separate.</a:t>
+            </a:r>
+          </a:p>
+        </p:txBody>
+      </p:sp>
     </p:spTree>
     <p:extLst>
       <p:ext uri="{BB962C8B-B14F-4D97-AF65-F5344CB8AC3E}">
-        <p14:creationId xmlns:p14="http://schemas.microsoft.com/office/powerpoint/2010/main" val="2042307397"/>
+        <p14:creationId xmlns:p14="http://schemas.microsoft.com/office/powerpoint/2010/main" val="1163993222"/>
       </p:ext>
     </p:extLst>
   </p:cSld>
@@ -2392,7 +2900,7 @@
     <p:bg>
       <p:bgPr>
         <a:solidFill xmlns:a="http://schemas.openxmlformats.org/drawingml/2006/main">
-          <a:srgbClr val="F3F3ED"/>
+          <a:srgbClr val="F4FAFF"/>
         </a:solidFill>
       </p:bgPr>
     </p:bg>
@@ -2407,10 +2915,10 @@
       </p:grpSpPr>
       <p:sp>
         <p:nvSpPr>
-          <p:cNvPr id="7" name="">
+          <p:cNvPr id="9" name="">
             <a:extLst xmlns:a="http://schemas.openxmlformats.org/drawingml/2006/main">
               <a:ext uri="{FF2B5EF4-FFF2-40B4-BE49-F238E27FC236}">
-                <a16:creationId xmlns:a16="http://schemas.microsoft.com/office/drawing/2014/main" id="{805D3870-8753-4517-886B-D96BEC9634EA}"/>
+                <a16:creationId xmlns:a16="http://schemas.microsoft.com/office/drawing/2014/main" id="{F1C5EDAA-18D9-4C7D-BA15-B6BDB16D0276}"/>
               </a:ext>
             </a:extLst>
           </p:cNvPr>
@@ -2421,8 +2929,8 @@
         </p:nvSpPr>
         <p:spPr>
           <a:xfrm xmlns:a="http://schemas.openxmlformats.org/drawingml/2006/main">
-            <a:off x="704850" y="495300"/>
-            <a:ext cx="10668000" cy="704850"/>
+            <a:off x="685800" y="457200"/>
+            <a:ext cx="10820400" cy="857250"/>
           </a:xfrm>
           <a:prstGeom xmlns:a="http://schemas.openxmlformats.org/drawingml/2006/main" prst="rect">
             <a:avLst/>
@@ -2433,15 +2941,19 @@
           </a:ln>
         </p:spPr>
         <p:txBody>
-          <a:bodyPr xmlns:a="http://schemas.openxmlformats.org/drawingml/2006/main">
+          <a:bodyPr xmlns:a="http://schemas.openxmlformats.org/drawingml/2006/main" lIns="0" tIns="0" rIns="0" bIns="0" anchor="t">
             <a:noAutofit/>
           </a:bodyPr>
           <a:lstStyle xmlns:a="http://schemas.openxmlformats.org/drawingml/2006/main"/>
           <a:p xmlns:a="http://schemas.openxmlformats.org/drawingml/2006/main">
             <a:pPr>
-              <a:defRPr sz="3300" b="1">
-                <a:solidFill>
-                  <a:srgbClr val="183146"/>
+              <a:lnSpc>
+                <a:spcPct val="118000"/>
+              </a:lnSpc>
+              <a:buNone/>
+              <a:defRPr sz="3450" b="1">
+                <a:solidFill>
+                  <a:srgbClr val="17364D"/>
                 </a:solidFill>
                 <a:latin typeface="Liberation Sans"/>
                 <a:ea typeface="Liberation Sans"/>
@@ -2449,15 +2961,15 @@
               </a:defRPr>
             </a:pPr>
             <a:r>
-              <a:rPr sz="3300" b="1">
-                <a:solidFill>
-                  <a:srgbClr val="183146"/>
+              <a:rPr sz="3450" b="1">
+                <a:solidFill>
+                  <a:srgbClr val="17364D"/>
                 </a:solidFill>
                 <a:latin typeface="Liberation Sans"/>
                 <a:ea typeface="Liberation Sans"/>
                 <a:cs typeface="Liberation Sans"/>
               </a:rPr>
-              <a:t>The buyer accepts fresh evidence</a:t>
+              <a:t>The evidence has limits</a:t>
             </a:r>
           </a:p>
         </p:txBody>
@@ -2467,7 +2979,7 @@
           <p:cNvPr id="2" name="">
             <a:extLst xmlns:a="http://schemas.openxmlformats.org/drawingml/2006/main">
               <a:ext uri="{FF2B5EF4-FFF2-40B4-BE49-F238E27FC236}">
-                <a16:creationId xmlns:a16="http://schemas.microsoft.com/office/drawing/2014/main" id="{74C66CA7-77C1-46D1-BB01-DE082248ED0F}"/>
+                <a16:creationId xmlns:a16="http://schemas.microsoft.com/office/drawing/2014/main" id="{0C291444-DE67-43F7-97E7-2FB9A35743BC}"/>
               </a:ext>
             </a:extLst>
           </p:cNvPr>
@@ -2478,8 +2990,8 @@
         </p:nvSpPr>
         <p:spPr>
           <a:xfrm xmlns:a="http://schemas.openxmlformats.org/drawingml/2006/main">
-            <a:off x="714375" y="6343650"/>
-            <a:ext cx="4762500" cy="228600"/>
+            <a:off x="685800" y="1809750"/>
+            <a:ext cx="5010150" cy="666750"/>
           </a:xfrm>
           <a:prstGeom xmlns:a="http://schemas.openxmlformats.org/drawingml/2006/main" prst="rect">
             <a:avLst/>
@@ -2490,15 +3002,19 @@
           </a:ln>
         </p:spPr>
         <p:txBody>
-          <a:bodyPr xmlns:a="http://schemas.openxmlformats.org/drawingml/2006/main">
+          <a:bodyPr xmlns:a="http://schemas.openxmlformats.org/drawingml/2006/main" lIns="0" tIns="0" rIns="0" bIns="0" anchor="t">
             <a:noAutofit/>
           </a:bodyPr>
           <a:lstStyle xmlns:a="http://schemas.openxmlformats.org/drawingml/2006/main"/>
           <a:p xmlns:a="http://schemas.openxmlformats.org/drawingml/2006/main">
             <a:pPr>
-              <a:defRPr sz="1125" b="1">
-                <a:solidFill>
-                  <a:srgbClr val="146B8D"/>
+              <a:lnSpc>
+                <a:spcPct val="118000"/>
+              </a:lnSpc>
+              <a:buNone/>
+              <a:defRPr sz="2175" b="1">
+                <a:solidFill>
+                  <a:srgbClr val="126C97"/>
                 </a:solidFill>
                 <a:latin typeface="Liberation Sans"/>
                 <a:ea typeface="Liberation Sans"/>
@@ -2506,15 +3022,15 @@
               </a:defRPr>
             </a:pPr>
             <a:r>
-              <a:rPr sz="1125" b="1">
-                <a:solidFill>
-                  <a:srgbClr val="146B8D"/>
+              <a:rPr sz="2175" b="1">
+                <a:solidFill>
+                  <a:srgbClr val="126C97"/>
                 </a:solidFill>
                 <a:latin typeface="Liberation Sans"/>
                 <a:ea typeface="Liberation Sans"/>
                 <a:cs typeface="Liberation Sans"/>
               </a:rPr>
-              <a:t>FIELDPROOF  /  04</a:t>
+              <a:t>The buyer can verify</a:t>
             </a:r>
           </a:p>
         </p:txBody>
@@ -2524,7 +3040,7 @@
           <p:cNvPr id="3" name="">
             <a:extLst xmlns:a="http://schemas.openxmlformats.org/drawingml/2006/main">
               <a:ext uri="{FF2B5EF4-FFF2-40B4-BE49-F238E27FC236}">
-                <a16:creationId xmlns:a16="http://schemas.microsoft.com/office/drawing/2014/main" id="{0D404E9A-36D9-4A7D-9294-A226D7C08D4B}"/>
+                <a16:creationId xmlns:a16="http://schemas.microsoft.com/office/drawing/2014/main" id="{E138EE96-27E1-4C49-8A0C-949AB1B0886B}"/>
               </a:ext>
             </a:extLst>
           </p:cNvPr>
@@ -2535,8 +3051,8 @@
         </p:nvSpPr>
         <p:spPr>
           <a:xfrm xmlns:a="http://schemas.openxmlformats.org/drawingml/2006/main">
-            <a:off x="714375" y="1381125"/>
-            <a:ext cx="6477000" cy="809625"/>
+            <a:off x="685800" y="2647950"/>
+            <a:ext cx="4895850" cy="1162050"/>
           </a:xfrm>
           <a:prstGeom xmlns:a="http://schemas.openxmlformats.org/drawingml/2006/main" prst="rect">
             <a:avLst/>
@@ -2547,15 +3063,19 @@
           </a:ln>
         </p:spPr>
         <p:txBody>
-          <a:bodyPr xmlns:a="http://schemas.openxmlformats.org/drawingml/2006/main">
+          <a:bodyPr xmlns:a="http://schemas.openxmlformats.org/drawingml/2006/main" lIns="0" tIns="0" rIns="0" bIns="0" anchor="t">
             <a:noAutofit/>
           </a:bodyPr>
           <a:lstStyle xmlns:a="http://schemas.openxmlformats.org/drawingml/2006/main"/>
           <a:p xmlns:a="http://schemas.openxmlformats.org/drawingml/2006/main">
             <a:pPr>
-              <a:defRPr sz="2175" b="0">
-                <a:solidFill>
-                  <a:srgbClr val="183146"/>
+              <a:lnSpc>
+                <a:spcPct val="118000"/>
+              </a:lnSpc>
+              <a:buNone/>
+              <a:defRPr sz="2100" b="0">
+                <a:solidFill>
+                  <a:srgbClr val="17364D"/>
                 </a:solidFill>
                 <a:latin typeface="Liberation Sans"/>
                 <a:ea typeface="Liberation Sans"/>
@@ -2563,15 +3083,15 @@
               </a:defRPr>
             </a:pPr>
             <a:r>
-              <a:rPr sz="2175" b="0">
-                <a:solidFill>
-                  <a:srgbClr val="183146"/>
+              <a:rPr sz="2100" b="0">
+                <a:solidFill>
+                  <a:srgbClr val="17364D"/>
                 </a:solidFill>
                 <a:latin typeface="Liberation Sans"/>
                 <a:ea typeface="Liberation Sans"/>
                 <a:cs typeface="Liberation Sans"/>
               </a:rPr>
-              <a:t>Check the selected key, challenge, samples, and signature.</a:t>
+              <a:t>This approved device signed the answer to this request.</a:t>
             </a:r>
           </a:p>
         </p:txBody>
@@ -2581,7 +3101,7 @@
           <p:cNvPr id="4" name="">
             <a:extLst xmlns:a="http://schemas.openxmlformats.org/drawingml/2006/main">
               <a:ext uri="{FF2B5EF4-FFF2-40B4-BE49-F238E27FC236}">
-                <a16:creationId xmlns:a16="http://schemas.microsoft.com/office/drawing/2014/main" id="{CE459C7B-DFA1-4EC5-B765-8711358811A7}"/>
+                <a16:creationId xmlns:a16="http://schemas.microsoft.com/office/drawing/2014/main" id="{6105CFB5-0634-4020-9919-C20B4BE35FB9}"/>
               </a:ext>
             </a:extLst>
           </p:cNvPr>
@@ -2592,8 +3112,8 @@
         </p:nvSpPr>
         <p:spPr>
           <a:xfrm xmlns:a="http://schemas.openxmlformats.org/drawingml/2006/main">
-            <a:off x="714375" y="2571750"/>
-            <a:ext cx="6286500" cy="809625"/>
+            <a:off x="685800" y="4000500"/>
+            <a:ext cx="4895850" cy="1295400"/>
           </a:xfrm>
           <a:prstGeom xmlns:a="http://schemas.openxmlformats.org/drawingml/2006/main" prst="rect">
             <a:avLst/>
@@ -2604,15 +3124,19 @@
           </a:ln>
         </p:spPr>
         <p:txBody>
-          <a:bodyPr xmlns:a="http://schemas.openxmlformats.org/drawingml/2006/main">
+          <a:bodyPr xmlns:a="http://schemas.openxmlformats.org/drawingml/2006/main" lIns="0" tIns="0" rIns="0" bIns="0" anchor="t">
             <a:noAutofit/>
           </a:bodyPr>
           <a:lstStyle xmlns:a="http://schemas.openxmlformats.org/drawingml/2006/main"/>
           <a:p xmlns:a="http://schemas.openxmlformats.org/drawingml/2006/main">
             <a:pPr>
-              <a:defRPr sz="2175" b="1">
-                <a:solidFill>
-                  <a:srgbClr val="146B8D"/>
+              <a:lnSpc>
+                <a:spcPct val="118000"/>
+              </a:lnSpc>
+              <a:buNone/>
+              <a:defRPr sz="2100" b="0">
+                <a:solidFill>
+                  <a:srgbClr val="17364D"/>
                 </a:solidFill>
                 <a:latin typeface="Liberation Sans"/>
                 <a:ea typeface="Liberation Sans"/>
@@ -2620,15 +3144,15 @@
               </a:defRPr>
             </a:pPr>
             <a:r>
-              <a:rPr sz="2175" b="1">
-                <a:solidFill>
-                  <a:srgbClr val="146B8D"/>
+              <a:rPr sz="2100" b="0">
+                <a:solidFill>
+                  <a:srgbClr val="17364D"/>
                 </a:solidFill>
                 <a:latin typeface="Liberation Sans"/>
                 <a:ea typeface="Liberation Sans"/>
                 <a:cs typeface="Liberation Sans"/>
               </a:rPr>
-              <a:t>Then check age against the buyer’s ten-second policy.</a:t>
+              <a:t>An old answer fails the age policy. An edited answer fails signature verification.</a:t>
             </a:r>
           </a:p>
         </p:txBody>
@@ -2638,7 +3162,7 @@
           <p:cNvPr id="5" name="">
             <a:extLst xmlns:a="http://schemas.openxmlformats.org/drawingml/2006/main">
               <a:ext uri="{FF2B5EF4-FFF2-40B4-BE49-F238E27FC236}">
-                <a16:creationId xmlns:a16="http://schemas.microsoft.com/office/drawing/2014/main" id="{514111A4-CD1D-4E8F-BB80-989C7CF9D19C}"/>
+                <a16:creationId xmlns:a16="http://schemas.microsoft.com/office/drawing/2014/main" id="{8B575DDD-3E2E-4576-B350-74F22D4A6112}"/>
               </a:ext>
             </a:extLst>
           </p:cNvPr>
@@ -2649,8 +3173,8 @@
         </p:nvSpPr>
         <p:spPr>
           <a:xfrm xmlns:a="http://schemas.openxmlformats.org/drawingml/2006/main">
-            <a:off x="714375" y="4000500"/>
-            <a:ext cx="6477000" cy="1257300"/>
+            <a:off x="6496050" y="1809750"/>
+            <a:ext cx="5010150" cy="666750"/>
           </a:xfrm>
           <a:prstGeom xmlns:a="http://schemas.openxmlformats.org/drawingml/2006/main" prst="rect">
             <a:avLst/>
@@ -2661,15 +3185,19 @@
           </a:ln>
         </p:spPr>
         <p:txBody>
-          <a:bodyPr xmlns:a="http://schemas.openxmlformats.org/drawingml/2006/main">
+          <a:bodyPr xmlns:a="http://schemas.openxmlformats.org/drawingml/2006/main" lIns="0" tIns="0" rIns="0" bIns="0" anchor="t">
             <a:noAutofit/>
           </a:bodyPr>
           <a:lstStyle xmlns:a="http://schemas.openxmlformats.org/drawingml/2006/main"/>
           <a:p xmlns:a="http://schemas.openxmlformats.org/drawingml/2006/main">
             <a:pPr>
-              <a:defRPr sz="2025" b="0">
-                <a:solidFill>
-                  <a:srgbClr val="183146"/>
+              <a:lnSpc>
+                <a:spcPct val="118000"/>
+              </a:lnSpc>
+              <a:buNone/>
+              <a:defRPr sz="2175" b="1">
+                <a:solidFill>
+                  <a:srgbClr val="126C97"/>
                 </a:solidFill>
                 <a:latin typeface="Liberation Sans"/>
                 <a:ea typeface="Liberation Sans"/>
@@ -2677,45 +3205,206 @@
               </a:defRPr>
             </a:pPr>
             <a:r>
-              <a:rPr sz="2025" b="0">
-                <a:solidFill>
-                  <a:srgbClr val="183146"/>
+              <a:rPr sz="2175" b="1">
+                <a:solidFill>
+                  <a:srgbClr val="126C97"/>
                 </a:solidFill>
                 <a:latin typeface="Liberation Sans"/>
                 <a:ea typeface="Liberation Sans"/>
                 <a:cs typeface="Liberation Sans"/>
               </a:rPr>
-              <a:t>The same valid answer becomes WAIT after expiry. A changed answer fails signature verification.</a:t>
-            </a:r>
-          </a:p>
-        </p:txBody>
-      </p:sp>
-      <p:pic>
-        <p:nvPicPr>
-          <p:cNvPr id="12" name=""/>
-          <p:cNvPicPr>
-            <a:picLocks xmlns:a="http://schemas.openxmlformats.org/drawingml/2006/main" noChangeAspect="1"/>
-          </p:cNvPicPr>
+              <a:t>The physical demonstration</a:t>
+            </a:r>
+          </a:p>
+        </p:txBody>
+      </p:sp>
+      <p:sp>
+        <p:nvSpPr>
+          <p:cNvPr id="6" name="">
+            <a:extLst xmlns:a="http://schemas.openxmlformats.org/drawingml/2006/main">
+              <a:ext uri="{FF2B5EF4-FFF2-40B4-BE49-F238E27FC236}">
+                <a16:creationId xmlns:a16="http://schemas.microsoft.com/office/drawing/2014/main" id="{3B7B2462-008C-4920-B45F-A3B95BC37653}"/>
+              </a:ext>
+            </a:extLst>
+          </p:cNvPr>
+          <p:cNvSpPr>
+            <a:spLocks xmlns:a="http://schemas.openxmlformats.org/drawingml/2006/main" noGrp="1"/>
+          </p:cNvSpPr>
           <p:nvPr/>
-        </p:nvPicPr>
-        <p:blipFill>
-          <a:blip xmlns:r="http://schemas.openxmlformats.org/officeDocument/2006/relationships" xmlns:a="http://schemas.openxmlformats.org/drawingml/2006/main" r:embed="R39ff70feb1cf4592"/>
-          <a:stretch xmlns:a="http://schemas.openxmlformats.org/drawingml/2006/main"/>
-        </p:blipFill>
+        </p:nvSpPr>
         <p:spPr>
           <a:xfrm xmlns:a="http://schemas.openxmlformats.org/drawingml/2006/main">
-            <a:off x="7620000" y="2711291"/>
-            <a:ext cx="3714750" cy="1349693"/>
+            <a:off x="6496050" y="2647950"/>
+            <a:ext cx="4895850" cy="1162050"/>
           </a:xfrm>
           <a:prstGeom xmlns:a="http://schemas.openxmlformats.org/drawingml/2006/main" prst="rect">
             <a:avLst/>
           </a:prstGeom>
-        </p:spPr>
-      </p:pic>
+          <a:noFill xmlns:a="http://schemas.openxmlformats.org/drawingml/2006/main"/>
+          <a:ln xmlns:a="http://schemas.openxmlformats.org/drawingml/2006/main" w="0">
+            <a:noFill/>
+          </a:ln>
+        </p:spPr>
+        <p:txBody>
+          <a:bodyPr xmlns:a="http://schemas.openxmlformats.org/drawingml/2006/main" lIns="0" tIns="0" rIns="0" bIns="0" anchor="t">
+            <a:noAutofit/>
+          </a:bodyPr>
+          <a:lstStyle xmlns:a="http://schemas.openxmlformats.org/drawingml/2006/main"/>
+          <a:p xmlns:a="http://schemas.openxmlformats.org/drawingml/2006/main">
+            <a:pPr>
+              <a:lnSpc>
+                <a:spcPct val="118000"/>
+              </a:lnSpc>
+              <a:buNone/>
+              <a:defRPr sz="2100" b="0">
+                <a:solidFill>
+                  <a:srgbClr val="17364D"/>
+                </a:solidFill>
+                <a:latin typeface="Liberation Sans"/>
+                <a:ea typeface="Liberation Sans"/>
+                <a:cs typeface="Liberation Sans"/>
+              </a:defRPr>
+            </a:pPr>
+            <a:r>
+              <a:rPr sz="2100" b="0">
+                <a:solidFill>
+                  <a:srgbClr val="17364D"/>
+                </a:solidFill>
+                <a:latin typeface="Liberation Sans"/>
+                <a:ea typeface="Liberation Sans"/>
+                <a:cs typeface="Liberation Sans"/>
+              </a:rPr>
+              <a:t>Release or hold BOOT. The contact changes between OPEN and CLOSED.</a:t>
+            </a:r>
+          </a:p>
+        </p:txBody>
+      </p:sp>
+      <p:sp>
+        <p:nvSpPr>
+          <p:cNvPr id="7" name="">
+            <a:extLst xmlns:a="http://schemas.openxmlformats.org/drawingml/2006/main">
+              <a:ext uri="{FF2B5EF4-FFF2-40B4-BE49-F238E27FC236}">
+                <a16:creationId xmlns:a16="http://schemas.microsoft.com/office/drawing/2014/main" id="{46CAAC0C-51D5-4C37-992C-DB849611875C}"/>
+              </a:ext>
+            </a:extLst>
+          </p:cNvPr>
+          <p:cNvSpPr>
+            <a:spLocks xmlns:a="http://schemas.openxmlformats.org/drawingml/2006/main" noGrp="1"/>
+          </p:cNvSpPr>
+          <p:nvPr/>
+        </p:nvSpPr>
+        <p:spPr>
+          <a:xfrm xmlns:a="http://schemas.openxmlformats.org/drawingml/2006/main">
+            <a:off x="6496050" y="4000500"/>
+            <a:ext cx="4895850" cy="1295400"/>
+          </a:xfrm>
+          <a:prstGeom xmlns:a="http://schemas.openxmlformats.org/drawingml/2006/main" prst="rect">
+            <a:avLst/>
+          </a:prstGeom>
+          <a:noFill xmlns:a="http://schemas.openxmlformats.org/drawingml/2006/main"/>
+          <a:ln xmlns:a="http://schemas.openxmlformats.org/drawingml/2006/main" w="0">
+            <a:noFill/>
+          </a:ln>
+        </p:spPr>
+        <p:txBody>
+          <a:bodyPr xmlns:a="http://schemas.openxmlformats.org/drawingml/2006/main" lIns="0" tIns="0" rIns="0" bIns="0" anchor="t">
+            <a:noAutofit/>
+          </a:bodyPr>
+          <a:lstStyle xmlns:a="http://schemas.openxmlformats.org/drawingml/2006/main"/>
+          <a:p xmlns:a="http://schemas.openxmlformats.org/drawingml/2006/main">
+            <a:pPr>
+              <a:lnSpc>
+                <a:spcPct val="118000"/>
+              </a:lnSpc>
+              <a:buNone/>
+              <a:defRPr sz="2100" b="0">
+                <a:solidFill>
+                  <a:srgbClr val="17364D"/>
+                </a:solidFill>
+                <a:latin typeface="Liberation Sans"/>
+                <a:ea typeface="Liberation Sans"/>
+                <a:cs typeface="Liberation Sans"/>
+              </a:defRPr>
+            </a:pPr>
+            <a:r>
+              <a:rPr sz="2100" b="0">
+                <a:solidFill>
+                  <a:srgbClr val="17364D"/>
+                </a:solidFill>
+                <a:latin typeface="Liberation Sans"/>
+                <a:ea typeface="Liberation Sans"/>
+                <a:cs typeface="Liberation Sans"/>
+              </a:rPr>
+              <a:t>The contact does not prove contents, safety, or completed work.</a:t>
+            </a:r>
+          </a:p>
+        </p:txBody>
+      </p:sp>
+      <p:sp>
+        <p:nvSpPr>
+          <p:cNvPr id="8" name="">
+            <a:extLst xmlns:a="http://schemas.openxmlformats.org/drawingml/2006/main">
+              <a:ext uri="{FF2B5EF4-FFF2-40B4-BE49-F238E27FC236}">
+                <a16:creationId xmlns:a16="http://schemas.microsoft.com/office/drawing/2014/main" id="{37AE8637-58F2-48EF-AC21-C78FFFEC24C5}"/>
+              </a:ext>
+            </a:extLst>
+          </p:cNvPr>
+          <p:cNvSpPr>
+            <a:spLocks xmlns:a="http://schemas.openxmlformats.org/drawingml/2006/main" noGrp="1"/>
+          </p:cNvSpPr>
+          <p:nvPr/>
+        </p:nvSpPr>
+        <p:spPr>
+          <a:xfrm xmlns:a="http://schemas.openxmlformats.org/drawingml/2006/main">
+            <a:off x="685800" y="6276975"/>
+            <a:ext cx="10820400" cy="419100"/>
+          </a:xfrm>
+          <a:prstGeom xmlns:a="http://schemas.openxmlformats.org/drawingml/2006/main" prst="rect">
+            <a:avLst/>
+          </a:prstGeom>
+          <a:noFill xmlns:a="http://schemas.openxmlformats.org/drawingml/2006/main"/>
+          <a:ln xmlns:a="http://schemas.openxmlformats.org/drawingml/2006/main" w="0">
+            <a:noFill/>
+          </a:ln>
+        </p:spPr>
+        <p:txBody>
+          <a:bodyPr xmlns:a="http://schemas.openxmlformats.org/drawingml/2006/main" lIns="0" tIns="0" rIns="0" bIns="0" anchor="t">
+            <a:noAutofit/>
+          </a:bodyPr>
+          <a:lstStyle xmlns:a="http://schemas.openxmlformats.org/drawingml/2006/main"/>
+          <a:p xmlns:a="http://schemas.openxmlformats.org/drawingml/2006/main">
+            <a:pPr>
+              <a:lnSpc>
+                <a:spcPct val="118000"/>
+              </a:lnSpc>
+              <a:buNone/>
+              <a:defRPr sz="1350" b="0">
+                <a:solidFill>
+                  <a:srgbClr val="536D80"/>
+                </a:solidFill>
+                <a:latin typeface="Liberation Sans"/>
+                <a:ea typeface="Liberation Sans"/>
+                <a:cs typeface="Liberation Sans"/>
+              </a:defRPr>
+            </a:pPr>
+            <a:r>
+              <a:rPr sz="1350" b="0">
+                <a:solidFill>
+                  <a:srgbClr val="536D80"/>
+                </a:solidFill>
+                <a:latin typeface="Liberation Sans"/>
+                <a:ea typeface="Liberation Sans"/>
+                <a:cs typeface="Liberation Sans"/>
+              </a:rPr>
+              <a:t>04 / BOOT is a contact stand-in. No robot or real entrance is connected. The software buyer can serve an AI agent.</a:t>
+            </a:r>
+          </a:p>
+        </p:txBody>
+      </p:sp>
     </p:spTree>
     <p:extLst>
       <p:ext uri="{BB962C8B-B14F-4D97-AF65-F5344CB8AC3E}">
-        <p14:creationId xmlns:p14="http://schemas.microsoft.com/office/powerpoint/2010/main" val="776046659"/>
+        <p14:creationId xmlns:p14="http://schemas.microsoft.com/office/powerpoint/2010/main" val="264510098"/>
       </p:ext>
     </p:extLst>
   </p:cSld>
@@ -2728,7 +3417,7 @@
     <p:bg>
       <p:bgPr>
         <a:solidFill xmlns:a="http://schemas.openxmlformats.org/drawingml/2006/main">
-          <a:srgbClr val="F3F3ED"/>
+          <a:srgbClr val="F4FAFF"/>
         </a:solidFill>
       </p:bgPr>
     </p:bg>
@@ -2743,10 +3432,10 @@
       </p:grpSpPr>
       <p:sp>
         <p:nvSpPr>
-          <p:cNvPr id="7" name="">
+          <p:cNvPr id="10" name="">
             <a:extLst xmlns:a="http://schemas.openxmlformats.org/drawingml/2006/main">
               <a:ext uri="{FF2B5EF4-FFF2-40B4-BE49-F238E27FC236}">
-                <a16:creationId xmlns:a16="http://schemas.microsoft.com/office/drawing/2014/main" id="{DEB6AA3C-01C6-484D-BEFB-F2DA7A9D580A}"/>
+                <a16:creationId xmlns:a16="http://schemas.microsoft.com/office/drawing/2014/main" id="{487AA1D5-3FF5-4314-979F-DAE2ADCF8E4C}"/>
               </a:ext>
             </a:extLst>
           </p:cNvPr>
@@ -2757,8 +3446,8 @@
         </p:nvSpPr>
         <p:spPr>
           <a:xfrm xmlns:a="http://schemas.openxmlformats.org/drawingml/2006/main">
-            <a:off x="704850" y="495300"/>
-            <a:ext cx="10668000" cy="704850"/>
+            <a:off x="685800" y="457200"/>
+            <a:ext cx="10820400" cy="857250"/>
           </a:xfrm>
           <a:prstGeom xmlns:a="http://schemas.openxmlformats.org/drawingml/2006/main" prst="rect">
             <a:avLst/>
@@ -2769,15 +3458,19 @@
           </a:ln>
         </p:spPr>
         <p:txBody>
-          <a:bodyPr xmlns:a="http://schemas.openxmlformats.org/drawingml/2006/main">
+          <a:bodyPr xmlns:a="http://schemas.openxmlformats.org/drawingml/2006/main" lIns="0" tIns="0" rIns="0" bIns="0" anchor="t">
             <a:noAutofit/>
           </a:bodyPr>
           <a:lstStyle xmlns:a="http://schemas.openxmlformats.org/drawingml/2006/main"/>
           <a:p xmlns:a="http://schemas.openxmlformats.org/drawingml/2006/main">
             <a:pPr>
-              <a:defRPr sz="3300" b="1">
-                <a:solidFill>
-                  <a:srgbClr val="183146"/>
+              <a:lnSpc>
+                <a:spcPct val="118000"/>
+              </a:lnSpc>
+              <a:buNone/>
+              <a:defRPr sz="3450" b="1">
+                <a:solidFill>
+                  <a:srgbClr val="17364D"/>
                 </a:solidFill>
                 <a:latin typeface="Liberation Sans"/>
                 <a:ea typeface="Liberation Sans"/>
@@ -2785,15 +3478,15 @@
               </a:defRPr>
             </a:pPr>
             <a:r>
-              <a:rPr sz="3300" b="1">
-                <a:solidFill>
-                  <a:srgbClr val="183146"/>
+              <a:rPr sz="3450" b="1">
+                <a:solidFill>
+                  <a:srgbClr val="17364D"/>
                 </a:solidFill>
                 <a:latin typeface="Liberation Sans"/>
                 <a:ea typeface="Liberation Sans"/>
                 <a:cs typeface="Liberation Sans"/>
               </a:rPr>
-              <a:t>The first buyer test</a:t>
+              <a:t>peaq's role and the next test</a:t>
             </a:r>
           </a:p>
         </p:txBody>
@@ -2803,7 +3496,7 @@
           <p:cNvPr id="2" name="">
             <a:extLst xmlns:a="http://schemas.openxmlformats.org/drawingml/2006/main">
               <a:ext uri="{FF2B5EF4-FFF2-40B4-BE49-F238E27FC236}">
-                <a16:creationId xmlns:a16="http://schemas.microsoft.com/office/drawing/2014/main" id="{DB8CF02E-D3A5-4C8E-9F83-FB7EED6CE44D}"/>
+                <a16:creationId xmlns:a16="http://schemas.microsoft.com/office/drawing/2014/main" id="{23A01D95-E005-4A16-907B-6205581C7E10}"/>
               </a:ext>
             </a:extLst>
           </p:cNvPr>
@@ -2814,8 +3507,8 @@
         </p:nvSpPr>
         <p:spPr>
           <a:xfrm xmlns:a="http://schemas.openxmlformats.org/drawingml/2006/main">
-            <a:off x="714375" y="6343650"/>
-            <a:ext cx="4762500" cy="228600"/>
+            <a:off x="685800" y="1809750"/>
+            <a:ext cx="5010150" cy="666750"/>
           </a:xfrm>
           <a:prstGeom xmlns:a="http://schemas.openxmlformats.org/drawingml/2006/main" prst="rect">
             <a:avLst/>
@@ -2826,15 +3519,19 @@
           </a:ln>
         </p:spPr>
         <p:txBody>
-          <a:bodyPr xmlns:a="http://schemas.openxmlformats.org/drawingml/2006/main">
+          <a:bodyPr xmlns:a="http://schemas.openxmlformats.org/drawingml/2006/main" lIns="0" tIns="0" rIns="0" bIns="0" anchor="t">
             <a:noAutofit/>
           </a:bodyPr>
           <a:lstStyle xmlns:a="http://schemas.openxmlformats.org/drawingml/2006/main"/>
           <a:p xmlns:a="http://schemas.openxmlformats.org/drawingml/2006/main">
             <a:pPr>
-              <a:defRPr sz="1125" b="1">
-                <a:solidFill>
-                  <a:srgbClr val="146B8D"/>
+              <a:lnSpc>
+                <a:spcPct val="118000"/>
+              </a:lnSpc>
+              <a:buNone/>
+              <a:defRPr sz="2175" b="1">
+                <a:solidFill>
+                  <a:srgbClr val="126C97"/>
                 </a:solidFill>
                 <a:latin typeface="Liberation Sans"/>
                 <a:ea typeface="Liberation Sans"/>
@@ -2842,15 +3539,15 @@
               </a:defRPr>
             </a:pPr>
             <a:r>
-              <a:rPr sz="1125" b="1">
-                <a:solidFill>
-                  <a:srgbClr val="146B8D"/>
+              <a:rPr sz="2175" b="1">
+                <a:solidFill>
+                  <a:srgbClr val="126C97"/>
                 </a:solidFill>
                 <a:latin typeface="Liberation Sans"/>
                 <a:ea typeface="Liberation Sans"/>
                 <a:cs typeface="Liberation Sans"/>
               </a:rPr>
-              <a:t>FIELDPROOF  /  05</a:t>
+              <a:t>Solana: demonstrated</a:t>
             </a:r>
           </a:p>
         </p:txBody>
@@ -2860,7 +3557,7 @@
           <p:cNvPr id="3" name="">
             <a:extLst xmlns:a="http://schemas.openxmlformats.org/drawingml/2006/main">
               <a:ext uri="{FF2B5EF4-FFF2-40B4-BE49-F238E27FC236}">
-                <a16:creationId xmlns:a16="http://schemas.microsoft.com/office/drawing/2014/main" id="{5E0578A7-C9CE-433D-BD61-2CBE466F7525}"/>
+                <a16:creationId xmlns:a16="http://schemas.microsoft.com/office/drawing/2014/main" id="{EFC359E8-16AB-4EE9-AE09-5CD09C3B8F19}"/>
               </a:ext>
             </a:extLst>
           </p:cNvPr>
@@ -2871,8 +3568,8 @@
         </p:nvSpPr>
         <p:spPr>
           <a:xfrm xmlns:a="http://schemas.openxmlformats.org/drawingml/2006/main">
-            <a:off x="714375" y="1428750"/>
-            <a:ext cx="7858125" cy="762000"/>
+            <a:off x="685800" y="2647950"/>
+            <a:ext cx="4895850" cy="1162050"/>
           </a:xfrm>
           <a:prstGeom xmlns:a="http://schemas.openxmlformats.org/drawingml/2006/main" prst="rect">
             <a:avLst/>
@@ -2883,15 +3580,19 @@
           </a:ln>
         </p:spPr>
         <p:txBody>
-          <a:bodyPr xmlns:a="http://schemas.openxmlformats.org/drawingml/2006/main">
+          <a:bodyPr xmlns:a="http://schemas.openxmlformats.org/drawingml/2006/main" lIns="0" tIns="0" rIns="0" bIns="0" anchor="t">
             <a:noAutofit/>
           </a:bodyPr>
           <a:lstStyle xmlns:a="http://schemas.openxmlformats.org/drawingml/2006/main"/>
           <a:p xmlns:a="http://schemas.openxmlformats.org/drawingml/2006/main">
             <a:pPr>
-              <a:defRPr sz="2400" b="1">
-                <a:solidFill>
-                  <a:srgbClr val="146B8D"/>
+              <a:lnSpc>
+                <a:spcPct val="118000"/>
+              </a:lnSpc>
+              <a:buNone/>
+              <a:defRPr sz="2100" b="0">
+                <a:solidFill>
+                  <a:srgbClr val="17364D"/>
                 </a:solidFill>
                 <a:latin typeface="Liberation Sans"/>
                 <a:ea typeface="Liberation Sans"/>
@@ -2899,15 +3600,15 @@
               </a:defRPr>
             </a:pPr>
             <a:r>
-              <a:rPr sz="2400" b="1">
-                <a:solidFill>
-                  <a:srgbClr val="146B8D"/>
+              <a:rPr sz="2100" b="0">
+                <a:solidFill>
+                  <a:srgbClr val="17364D"/>
                 </a:solidFill>
                 <a:latin typeface="Liberation Sans"/>
                 <a:ea typeface="Liberation Sans"/>
                 <a:cs typeface="Liberation Sans"/>
               </a:rPr>
-              <a:t>One AI builder and one authorized equipment operator.</a:t>
+              <a:t>Bounded Devnet payment and an original device-signed answer.</a:t>
             </a:r>
           </a:p>
         </p:txBody>
@@ -2917,7 +3618,7 @@
           <p:cNvPr id="4" name="">
             <a:extLst xmlns:a="http://schemas.openxmlformats.org/drawingml/2006/main">
               <a:ext uri="{FF2B5EF4-FFF2-40B4-BE49-F238E27FC236}">
-                <a16:creationId xmlns:a16="http://schemas.microsoft.com/office/drawing/2014/main" id="{157856DB-5CF7-476C-82B3-7F878B280DD4}"/>
+                <a16:creationId xmlns:a16="http://schemas.microsoft.com/office/drawing/2014/main" id="{B6866D5C-8144-40BA-9A3A-E05D14BE80C8}"/>
               </a:ext>
             </a:extLst>
           </p:cNvPr>
@@ -2928,8 +3629,8 @@
         </p:nvSpPr>
         <p:spPr>
           <a:xfrm xmlns:a="http://schemas.openxmlformats.org/drawingml/2006/main">
-            <a:off x="714375" y="2543175"/>
-            <a:ext cx="8096250" cy="1352550"/>
+            <a:off x="685800" y="4000500"/>
+            <a:ext cx="4895850" cy="1295400"/>
           </a:xfrm>
           <a:prstGeom xmlns:a="http://schemas.openxmlformats.org/drawingml/2006/main" prst="rect">
             <a:avLst/>
@@ -2940,15 +3641,19 @@
           </a:ln>
         </p:spPr>
         <p:txBody>
-          <a:bodyPr xmlns:a="http://schemas.openxmlformats.org/drawingml/2006/main">
+          <a:bodyPr xmlns:a="http://schemas.openxmlformats.org/drawingml/2006/main" lIns="0" tIns="0" rIns="0" bIns="0" anchor="t">
             <a:noAutofit/>
           </a:bodyPr>
           <a:lstStyle xmlns:a="http://schemas.openxmlformats.org/drawingml/2006/main"/>
           <a:p xmlns:a="http://schemas.openxmlformats.org/drawingml/2006/main">
             <a:pPr>
-              <a:defRPr sz="2025" b="0">
-                <a:solidFill>
-                  <a:srgbClr val="183146"/>
+              <a:lnSpc>
+                <a:spcPct val="118000"/>
+              </a:lnSpc>
+              <a:buNone/>
+              <a:defRPr sz="1725" b="0">
+                <a:solidFill>
+                  <a:srgbClr val="536D80"/>
                 </a:solidFill>
                 <a:latin typeface="Liberation Sans"/>
                 <a:ea typeface="Liberation Sans"/>
@@ -2956,15 +3661,15 @@
               </a:defRPr>
             </a:pPr>
             <a:r>
-              <a:rPr sz="2025" b="0">
-                <a:solidFill>
-                  <a:srgbClr val="183146"/>
+              <a:rPr sz="1725" b="0">
+                <a:solidFill>
+                  <a:srgbClr val="536D80"/>
                 </a:solidFill>
                 <a:latin typeface="Liberation Sans"/>
                 <a:ea typeface="Liberation Sans"/>
                 <a:cs typeface="Liberation Sans"/>
               </a:rPr>
-              <a:t>Compare this check with the current API or manual process. Measure useful answers, integration work, failures, and recovery.</a:t>
+              <a:t>The public replay preserves the October 11 transaction and capture time.</a:t>
             </a:r>
           </a:p>
         </p:txBody>
@@ -2974,7 +3679,7 @@
           <p:cNvPr id="5" name="">
             <a:extLst xmlns:a="http://schemas.openxmlformats.org/drawingml/2006/main">
               <a:ext uri="{FF2B5EF4-FFF2-40B4-BE49-F238E27FC236}">
-                <a16:creationId xmlns:a16="http://schemas.microsoft.com/office/drawing/2014/main" id="{8E9AEB6E-86BB-46FD-AB58-275FBB46F8B5}"/>
+                <a16:creationId xmlns:a16="http://schemas.microsoft.com/office/drawing/2014/main" id="{E0B1A7A8-3114-4C37-AA2D-062EFCA0A29F}"/>
               </a:ext>
             </a:extLst>
           </p:cNvPr>
@@ -2985,8 +3690,8 @@
         </p:nvSpPr>
         <p:spPr>
           <a:xfrm xmlns:a="http://schemas.openxmlformats.org/drawingml/2006/main">
-            <a:off x="714375" y="4476750"/>
-            <a:ext cx="8096250" cy="1000125"/>
+            <a:off x="6496050" y="1809750"/>
+            <a:ext cx="5010150" cy="666750"/>
           </a:xfrm>
           <a:prstGeom xmlns:a="http://schemas.openxmlformats.org/drawingml/2006/main" prst="rect">
             <a:avLst/>
@@ -2997,15 +3702,19 @@
           </a:ln>
         </p:spPr>
         <p:txBody>
-          <a:bodyPr xmlns:a="http://schemas.openxmlformats.org/drawingml/2006/main">
+          <a:bodyPr xmlns:a="http://schemas.openxmlformats.org/drawingml/2006/main" lIns="0" tIns="0" rIns="0" bIns="0" anchor="t">
             <a:noAutofit/>
           </a:bodyPr>
           <a:lstStyle xmlns:a="http://schemas.openxmlformats.org/drawingml/2006/main"/>
           <a:p xmlns:a="http://schemas.openxmlformats.org/drawingml/2006/main">
             <a:pPr>
-              <a:defRPr sz="1950" b="0">
-                <a:solidFill>
-                  <a:srgbClr val="183146"/>
+              <a:lnSpc>
+                <a:spcPct val="118000"/>
+              </a:lnSpc>
+              <a:buNone/>
+              <a:defRPr sz="2175" b="1">
+                <a:solidFill>
+                  <a:srgbClr val="9A5617"/>
                 </a:solidFill>
                 <a:latin typeface="Liberation Sans"/>
                 <a:ea typeface="Liberation Sans"/>
@@ -3013,15 +3722,15 @@
               </a:defRPr>
             </a:pPr>
             <a:r>
-              <a:rPr sz="1950" b="0">
-                <a:solidFill>
-                  <a:srgbClr val="183146"/>
+              <a:rPr sz="2175" b="1">
+                <a:solidFill>
+                  <a:srgbClr val="9A5617"/>
                 </a:solidFill>
                 <a:latin typeface="Liberation Sans"/>
                 <a:ea typeface="Liberation Sans"/>
                 <a:cs typeface="Liberation Sans"/>
               </a:rPr>
-              <a:t>Repeat at a second site to test reuse. Paid integration and support remain business hypotheses.</a:t>
+              <a:t>peaq: live integration pending</a:t>
             </a:r>
           </a:p>
         </p:txBody>
@@ -3031,7 +3740,7 @@
           <p:cNvPr id="6" name="">
             <a:extLst xmlns:a="http://schemas.openxmlformats.org/drawingml/2006/main">
               <a:ext uri="{FF2B5EF4-FFF2-40B4-BE49-F238E27FC236}">
-                <a16:creationId xmlns:a16="http://schemas.microsoft.com/office/drawing/2014/main" id="{A89109EC-0B6E-4855-9986-505F0C9E1E63}"/>
+                <a16:creationId xmlns:a16="http://schemas.microsoft.com/office/drawing/2014/main" id="{9336EA76-A7A8-4E94-9F00-1484663200EE}"/>
               </a:ext>
             </a:extLst>
           </p:cNvPr>
@@ -3042,8 +3751,8 @@
         </p:nvSpPr>
         <p:spPr>
           <a:xfrm xmlns:a="http://schemas.openxmlformats.org/drawingml/2006/main">
-            <a:off x="714375" y="5838825"/>
-            <a:ext cx="7143750" cy="304800"/>
+            <a:off x="6496050" y="2647950"/>
+            <a:ext cx="4895850" cy="1162050"/>
           </a:xfrm>
           <a:prstGeom xmlns:a="http://schemas.openxmlformats.org/drawingml/2006/main" prst="rect">
             <a:avLst/>
@@ -3054,15 +3763,19 @@
           </a:ln>
         </p:spPr>
         <p:txBody>
-          <a:bodyPr xmlns:a="http://schemas.openxmlformats.org/drawingml/2006/main">
+          <a:bodyPr xmlns:a="http://schemas.openxmlformats.org/drawingml/2006/main" lIns="0" tIns="0" rIns="0" bIns="0" anchor="t">
             <a:noAutofit/>
           </a:bodyPr>
           <a:lstStyle xmlns:a="http://schemas.openxmlformats.org/drawingml/2006/main"/>
           <a:p xmlns:a="http://schemas.openxmlformats.org/drawingml/2006/main">
             <a:pPr>
-              <a:defRPr sz="1575" b="1">
-                <a:solidFill>
-                  <a:srgbClr val="A35A10"/>
+              <a:lnSpc>
+                <a:spcPct val="118000"/>
+              </a:lnSpc>
+              <a:buNone/>
+              <a:defRPr sz="2100" b="0">
+                <a:solidFill>
+                  <a:srgbClr val="17364D"/>
                 </a:solidFill>
                 <a:latin typeface="Liberation Sans"/>
                 <a:ea typeface="Liberation Sans"/>
@@ -3070,15 +3783,198 @@
               </a:defRPr>
             </a:pPr>
             <a:r>
-              <a:rPr sz="1575" b="1">
-                <a:solidFill>
-                  <a:srgbClr val="A35A10"/>
+              <a:rPr sz="2100" b="0">
+                <a:solidFill>
+                  <a:srgbClr val="17364D"/>
                 </a:solidFill>
                 <a:latin typeface="Liberation Sans"/>
                 <a:ea typeface="Liberation Sans"/>
                 <a:cs typeface="Liberation Sans"/>
               </a:rPr>
-              <a:t>No validated customer or commercial revenue yet.</a:t>
+              <a:t>A machine identity binds the offered service to its device key.</a:t>
+            </a:r>
+          </a:p>
+        </p:txBody>
+      </p:sp>
+      <p:sp>
+        <p:nvSpPr>
+          <p:cNvPr id="7" name="">
+            <a:extLst xmlns:a="http://schemas.openxmlformats.org/drawingml/2006/main">
+              <a:ext uri="{FF2B5EF4-FFF2-40B4-BE49-F238E27FC236}">
+                <a16:creationId xmlns:a16="http://schemas.microsoft.com/office/drawing/2014/main" id="{184D22A4-FA41-4147-943D-B42218C28123}"/>
+              </a:ext>
+            </a:extLst>
+          </p:cNvPr>
+          <p:cNvSpPr>
+            <a:spLocks xmlns:a="http://schemas.openxmlformats.org/drawingml/2006/main" noGrp="1"/>
+          </p:cNvSpPr>
+          <p:nvPr/>
+        </p:nvSpPr>
+        <p:spPr>
+          <a:xfrm xmlns:a="http://schemas.openxmlformats.org/drawingml/2006/main">
+            <a:off x="6496050" y="4000500"/>
+            <a:ext cx="4895850" cy="1295400"/>
+          </a:xfrm>
+          <a:prstGeom xmlns:a="http://schemas.openxmlformats.org/drawingml/2006/main" prst="rect">
+            <a:avLst/>
+          </a:prstGeom>
+          <a:noFill xmlns:a="http://schemas.openxmlformats.org/drawingml/2006/main"/>
+          <a:ln xmlns:a="http://schemas.openxmlformats.org/drawingml/2006/main" w="0">
+            <a:noFill/>
+          </a:ln>
+        </p:spPr>
+        <p:txBody>
+          <a:bodyPr xmlns:a="http://schemas.openxmlformats.org/drawingml/2006/main" lIns="0" tIns="0" rIns="0" bIns="0" anchor="t">
+            <a:noAutofit/>
+          </a:bodyPr>
+          <a:lstStyle xmlns:a="http://schemas.openxmlformats.org/drawingml/2006/main"/>
+          <a:p xmlns:a="http://schemas.openxmlformats.org/drawingml/2006/main">
+            <a:pPr>
+              <a:lnSpc>
+                <a:spcPct val="118000"/>
+              </a:lnSpc>
+              <a:buNone/>
+              <a:defRPr sz="2100" b="0">
+                <a:solidFill>
+                  <a:srgbClr val="17364D"/>
+                </a:solidFill>
+                <a:latin typeface="Liberation Sans"/>
+                <a:ea typeface="Liberation Sans"/>
+                <a:cs typeface="Liberation Sans"/>
+              </a:defRPr>
+            </a:pPr>
+            <a:r>
+              <a:rPr sz="2100" b="0">
+                <a:solidFill>
+                  <a:srgbClr val="17364D"/>
+                </a:solidFill>
+                <a:latin typeface="Liberation Sans"/>
+                <a:ea typeface="Liberation Sans"/>
+                <a:cs typeface="Liberation Sans"/>
+              </a:rPr>
+              <a:t>An activity record links a completed check to payment and evidence.</a:t>
+            </a:r>
+          </a:p>
+        </p:txBody>
+      </p:sp>
+      <p:sp>
+        <p:nvSpPr>
+          <p:cNvPr id="8" name="">
+            <a:extLst xmlns:a="http://schemas.openxmlformats.org/drawingml/2006/main">
+              <a:ext uri="{FF2B5EF4-FFF2-40B4-BE49-F238E27FC236}">
+                <a16:creationId xmlns:a16="http://schemas.microsoft.com/office/drawing/2014/main" id="{C936E732-AE1E-47A4-A0DB-310F008EC72F}"/>
+              </a:ext>
+            </a:extLst>
+          </p:cNvPr>
+          <p:cNvSpPr>
+            <a:spLocks xmlns:a="http://schemas.openxmlformats.org/drawingml/2006/main" noGrp="1"/>
+          </p:cNvSpPr>
+          <p:nvPr/>
+        </p:nvSpPr>
+        <p:spPr>
+          <a:xfrm xmlns:a="http://schemas.openxmlformats.org/drawingml/2006/main">
+            <a:off x="685800" y="5505450"/>
+            <a:ext cx="10820400" cy="590550"/>
+          </a:xfrm>
+          <a:prstGeom xmlns:a="http://schemas.openxmlformats.org/drawingml/2006/main" prst="rect">
+            <a:avLst/>
+          </a:prstGeom>
+          <a:noFill xmlns:a="http://schemas.openxmlformats.org/drawingml/2006/main"/>
+          <a:ln xmlns:a="http://schemas.openxmlformats.org/drawingml/2006/main" w="0">
+            <a:noFill/>
+          </a:ln>
+        </p:spPr>
+        <p:txBody>
+          <a:bodyPr xmlns:a="http://schemas.openxmlformats.org/drawingml/2006/main" lIns="0" tIns="0" rIns="0" bIns="0" anchor="t">
+            <a:noAutofit/>
+          </a:bodyPr>
+          <a:lstStyle xmlns:a="http://schemas.openxmlformats.org/drawingml/2006/main"/>
+          <a:p xmlns:a="http://schemas.openxmlformats.org/drawingml/2006/main">
+            <a:pPr>
+              <a:lnSpc>
+                <a:spcPct val="118000"/>
+              </a:lnSpc>
+              <a:buNone/>
+              <a:defRPr sz="1875" b="0">
+                <a:solidFill>
+                  <a:srgbClr val="126C97"/>
+                </a:solidFill>
+                <a:latin typeface="Liberation Sans"/>
+                <a:ea typeface="Liberation Sans"/>
+                <a:cs typeface="Liberation Sans"/>
+              </a:defRPr>
+            </a:pPr>
+            <a:r>
+              <a:rPr sz="1875" b="0">
+                <a:solidFill>
+                  <a:srgbClr val="126C97"/>
+                </a:solidFill>
+                <a:latin typeface="Liberation Sans"/>
+                <a:ea typeface="Liberation Sans"/>
+                <a:cs typeface="Liberation Sans"/>
+              </a:rPr>
+              <a:t>Next: one authorized operator, one repeated question, and a comparison with its current process.</a:t>
+            </a:r>
+          </a:p>
+        </p:txBody>
+      </p:sp>
+      <p:sp>
+        <p:nvSpPr>
+          <p:cNvPr id="9" name="">
+            <a:extLst xmlns:a="http://schemas.openxmlformats.org/drawingml/2006/main">
+              <a:ext uri="{FF2B5EF4-FFF2-40B4-BE49-F238E27FC236}">
+                <a16:creationId xmlns:a16="http://schemas.microsoft.com/office/drawing/2014/main" id="{CAE80FD8-FA99-4163-ADFD-F3B83690D042}"/>
+              </a:ext>
+            </a:extLst>
+          </p:cNvPr>
+          <p:cNvSpPr>
+            <a:spLocks xmlns:a="http://schemas.openxmlformats.org/drawingml/2006/main" noGrp="1"/>
+          </p:cNvSpPr>
+          <p:nvPr/>
+        </p:nvSpPr>
+        <p:spPr>
+          <a:xfrm xmlns:a="http://schemas.openxmlformats.org/drawingml/2006/main">
+            <a:off x="685800" y="6276975"/>
+            <a:ext cx="10820400" cy="419100"/>
+          </a:xfrm>
+          <a:prstGeom xmlns:a="http://schemas.openxmlformats.org/drawingml/2006/main" prst="rect">
+            <a:avLst/>
+          </a:prstGeom>
+          <a:noFill xmlns:a="http://schemas.openxmlformats.org/drawingml/2006/main"/>
+          <a:ln xmlns:a="http://schemas.openxmlformats.org/drawingml/2006/main" w="0">
+            <a:noFill/>
+          </a:ln>
+        </p:spPr>
+        <p:txBody>
+          <a:bodyPr xmlns:a="http://schemas.openxmlformats.org/drawingml/2006/main" lIns="0" tIns="0" rIns="0" bIns="0" anchor="t">
+            <a:noAutofit/>
+          </a:bodyPr>
+          <a:lstStyle xmlns:a="http://schemas.openxmlformats.org/drawingml/2006/main"/>
+          <a:p xmlns:a="http://schemas.openxmlformats.org/drawingml/2006/main">
+            <a:pPr>
+              <a:lnSpc>
+                <a:spcPct val="118000"/>
+              </a:lnSpc>
+              <a:buNone/>
+              <a:defRPr sz="1350" b="0">
+                <a:solidFill>
+                  <a:srgbClr val="536D80"/>
+                </a:solidFill>
+                <a:latin typeface="Liberation Sans"/>
+                <a:ea typeface="Liberation Sans"/>
+                <a:cs typeface="Liberation Sans"/>
+              </a:defRPr>
+            </a:pPr>
+            <a:r>
+              <a:rPr sz="1350" b="0">
+                <a:solidFill>
+                  <a:srgbClr val="536D80"/>
+                </a:solidFill>
+                <a:latin typeface="Liberation Sans"/>
+                <a:ea typeface="Liberation Sans"/>
+                <a:cs typeface="Liberation Sans"/>
+              </a:rPr>
+              <a:t>05 / peaq code has tests. No live identity or activity event is established. Paid integration and inspection fees remain hypotheses.</a:t>
             </a:r>
           </a:p>
         </p:txBody>
@@ -3086,7 +3982,7 @@
     </p:spTree>
     <p:extLst>
       <p:ext uri="{BB962C8B-B14F-4D97-AF65-F5344CB8AC3E}">
-        <p14:creationId xmlns:p14="http://schemas.microsoft.com/office/powerpoint/2010/main" val="732356088"/>
+        <p14:creationId xmlns:p14="http://schemas.microsoft.com/office/powerpoint/2010/main" val="1105289494"/>
       </p:ext>
     </p:extLst>
   </p:cSld>

</xml_diff>

<commit_message>
feat: publish the verified peaq-linked paid hardware check
</commit_message>
<xml_diff>
--- a/docs/competition/fieldproof-pitch.pptx
+++ b/docs/competition/fieldproof-pitch.pptx
@@ -2,17 +2,17 @@
 <file path=ppt/presentation.xml><?xml version="1.0" encoding="utf-8"?>
 <p:presentation xmlns:p="http://schemas.openxmlformats.org/presentationml/2006/main">
   <p:sldMasterIdLst>
-    <p:sldMasterId xmlns:r="http://schemas.openxmlformats.org/officeDocument/2006/relationships" id="2147483648" r:id="R23ea92e1e26b4a6a"/>
+    <p:sldMasterId xmlns:r="http://schemas.openxmlformats.org/officeDocument/2006/relationships" id="2147483648" r:id="R5e3e9016d05141af"/>
   </p:sldMasterIdLst>
   <p:notesMasterIdLst>
-    <p:notesMasterId xmlns:r="http://schemas.openxmlformats.org/officeDocument/2006/relationships" r:id="R284703bbfa424e91"/>
+    <p:notesMasterId xmlns:r="http://schemas.openxmlformats.org/officeDocument/2006/relationships" r:id="R1ffac5f41aec41bd"/>
   </p:notesMasterIdLst>
   <p:sldIdLst>
-    <p:sldId xmlns:r="http://schemas.openxmlformats.org/officeDocument/2006/relationships" id="256" r:id="R8735ce0ff52a44bc"/>
-    <p:sldId xmlns:r="http://schemas.openxmlformats.org/officeDocument/2006/relationships" id="257" r:id="R442506087e1846b7"/>
-    <p:sldId xmlns:r="http://schemas.openxmlformats.org/officeDocument/2006/relationships" id="258" r:id="R50b15bbfa774469b"/>
-    <p:sldId xmlns:r="http://schemas.openxmlformats.org/officeDocument/2006/relationships" id="259" r:id="Rb9f1aefe962a4d45"/>
-    <p:sldId xmlns:r="http://schemas.openxmlformats.org/officeDocument/2006/relationships" id="260" r:id="Rec604e4503874f26"/>
+    <p:sldId xmlns:r="http://schemas.openxmlformats.org/officeDocument/2006/relationships" id="256" r:id="Rddd7d392dd94452c"/>
+    <p:sldId xmlns:r="http://schemas.openxmlformats.org/officeDocument/2006/relationships" id="257" r:id="R1fca12981e9e4765"/>
+    <p:sldId xmlns:r="http://schemas.openxmlformats.org/officeDocument/2006/relationships" id="258" r:id="R7b8168d628d749e8"/>
+    <p:sldId xmlns:r="http://schemas.openxmlformats.org/officeDocument/2006/relationships" id="259" r:id="R55c44a381eb24a77"/>
+    <p:sldId xmlns:r="http://schemas.openxmlformats.org/officeDocument/2006/relationships" id="260" r:id="Ra2e1ae4c9f6046ec"/>
   </p:sldIdLst>
   <p:sldSz cx="12192000" cy="6858000"/>
   <p:notesSz cx="6858000" cy="9144000"/>
@@ -446,7 +446,7 @@
           <a:lstStyle xmlns:a="http://schemas.openxmlformats.org/drawingml/2006/main"/>
           <a:p xmlns:a="http://schemas.openxmlformats.org/drawingml/2006/main">
             <a:r>
-              <a:t>Content source: docs/competition/slides.html. Implementation and evidence: docs/VERIFICATION.md and docs/evidence/device-signed-purchase-20261011.json. Buyer value and commercial pricing are hypotheses. The Solana transaction uses test tokens. Live peaq activation and event readback remain pending. Slide 1 of 5.</a:t>
+              <a:t>Content source: docs/competition/slides.html. Implementation and evidence: docs/VERIFICATION.md and docs/evidence/device-signed-purchase-20261011.json. Buyer value and commercial pricing are hypotheses. The Solana transaction uses test tokens. Real Agung identity and native Storage work readbacks passed on October 12. No EventRegistry event or credit rating is claimed. Slide 1 of 5.</a:t>
             </a:r>
           </a:p>
         </p:txBody>
@@ -516,7 +516,7 @@
           <a:lstStyle xmlns:a="http://schemas.openxmlformats.org/drawingml/2006/main"/>
           <a:p xmlns:a="http://schemas.openxmlformats.org/drawingml/2006/main">
             <a:r>
-              <a:t>Content source: docs/competition/slides.html. Implementation and evidence: docs/VERIFICATION.md and docs/evidence/device-signed-purchase-20261011.json. Buyer value and commercial pricing are hypotheses. The Solana transaction uses test tokens. Live peaq activation and event readback remain pending. Slide 2 of 5.</a:t>
+              <a:t>Content source: docs/competition/slides.html. Implementation and evidence: docs/VERIFICATION.md and docs/evidence/device-signed-purchase-20261011.json. Buyer value and commercial pricing are hypotheses. The Solana transaction uses test tokens. Real Agung identity and native Storage work readbacks passed on October 12. No EventRegistry event or credit rating is claimed. Slide 2 of 5.</a:t>
             </a:r>
           </a:p>
         </p:txBody>
@@ -586,7 +586,7 @@
           <a:lstStyle xmlns:a="http://schemas.openxmlformats.org/drawingml/2006/main"/>
           <a:p xmlns:a="http://schemas.openxmlformats.org/drawingml/2006/main">
             <a:r>
-              <a:t>Content source: docs/competition/slides.html. Implementation and evidence: docs/VERIFICATION.md and docs/evidence/device-signed-purchase-20261011.json. Buyer value and commercial pricing are hypotheses. The Solana transaction uses test tokens. Live peaq activation and event readback remain pending. Slide 3 of 5.</a:t>
+              <a:t>Content source: docs/competition/slides.html. Implementation and evidence: docs/VERIFICATION.md and docs/evidence/device-signed-purchase-20261011.json. Buyer value and commercial pricing are hypotheses. The Solana transaction uses test tokens. Real Agung identity and native Storage work readbacks passed on October 12. No EventRegistry event or credit rating is claimed. Slide 3 of 5.</a:t>
             </a:r>
           </a:p>
         </p:txBody>
@@ -656,7 +656,7 @@
           <a:lstStyle xmlns:a="http://schemas.openxmlformats.org/drawingml/2006/main"/>
           <a:p xmlns:a="http://schemas.openxmlformats.org/drawingml/2006/main">
             <a:r>
-              <a:t>Content source: docs/competition/slides.html. Implementation and evidence: docs/VERIFICATION.md and docs/evidence/device-signed-purchase-20261011.json. Buyer value and commercial pricing are hypotheses. The Solana transaction uses test tokens. Live peaq activation and event readback remain pending. Slide 4 of 5.</a:t>
+              <a:t>Content source: docs/competition/slides.html. Implementation and evidence: docs/VERIFICATION.md and docs/evidence/device-signed-purchase-20261011.json. Buyer value and commercial pricing are hypotheses. The Solana transaction uses test tokens. Real Agung identity and native Storage work readbacks passed on October 12. No EventRegistry event or credit rating is claimed. Slide 4 of 5.</a:t>
             </a:r>
           </a:p>
         </p:txBody>
@@ -726,7 +726,7 @@
           <a:lstStyle xmlns:a="http://schemas.openxmlformats.org/drawingml/2006/main"/>
           <a:p xmlns:a="http://schemas.openxmlformats.org/drawingml/2006/main">
             <a:r>
-              <a:t>Content source: docs/competition/slides.html. Implementation and evidence: docs/VERIFICATION.md and docs/evidence/device-signed-purchase-20261011.json. Buyer value and commercial pricing are hypotheses. The Solana transaction uses test tokens. Live peaq activation and event readback remain pending. Slide 5 of 5.</a:t>
+              <a:t>Content source: docs/competition/slides.html. Implementation and evidence: docs/VERIFICATION.md and docs/evidence/device-signed-purchase-20261011.json. Buyer value and commercial pricing are hypotheses. The Solana transaction uses test tokens. Real Agung identity and native Storage work readbacks passed on October 12. No EventRegistry event or credit rating is claimed. Slide 5 of 5.</a:t>
             </a:r>
           </a:p>
         </p:txBody>
@@ -794,7 +794,7 @@
   </p:cSld>
   <p:clrMap bg1="lt1" tx1="dk1" bg2="lt2" tx2="dk2" accent1="accent1" accent2="accent2" accent3="accent3" accent4="accent4" accent5="accent5" accent6="accent6" hlink="hlink" folHlink="folHlink"/>
   <p:sldLayoutIdLst>
-    <p:sldLayoutId xmlns:r="http://schemas.openxmlformats.org/officeDocument/2006/relationships" id="2147483649" r:id="Rd55828bcdb86441f"/>
+    <p:sldLayoutId xmlns:r="http://schemas.openxmlformats.org/officeDocument/2006/relationships" id="2147483649" r:id="R043c941cac0c4f89"/>
   </p:sldLayoutIdLst>
   <p:txStyles>
     <p:titleStyle>
@@ -1345,7 +1345,7 @@
           <p:cNvPr id="7" name="">
             <a:extLst xmlns:a="http://schemas.openxmlformats.org/drawingml/2006/main">
               <a:ext uri="{FF2B5EF4-FFF2-40B4-BE49-F238E27FC236}">
-                <a16:creationId xmlns:a16="http://schemas.microsoft.com/office/drawing/2014/main" id="{A02F20DD-196D-424C-8C39-6E842DBD9C4E}"/>
+                <a16:creationId xmlns:a16="http://schemas.microsoft.com/office/drawing/2014/main" id="{DEA8DFB1-E5CA-4677-8019-928C3D8049FE}"/>
               </a:ext>
             </a:extLst>
           </p:cNvPr>
@@ -1406,7 +1406,7 @@
           <p:cNvPr id="2" name="">
             <a:extLst xmlns:a="http://schemas.openxmlformats.org/drawingml/2006/main">
               <a:ext uri="{FF2B5EF4-FFF2-40B4-BE49-F238E27FC236}">
-                <a16:creationId xmlns:a16="http://schemas.microsoft.com/office/drawing/2014/main" id="{F8539FF9-2018-465B-BDA7-FE91098A77BF}"/>
+                <a16:creationId xmlns:a16="http://schemas.microsoft.com/office/drawing/2014/main" id="{9F6C66BA-CEC1-4E06-A466-190FF9C95A15}"/>
               </a:ext>
             </a:extLst>
           </p:cNvPr>
@@ -1467,7 +1467,7 @@
           <p:cNvPr id="3" name="">
             <a:extLst xmlns:a="http://schemas.openxmlformats.org/drawingml/2006/main">
               <a:ext uri="{FF2B5EF4-FFF2-40B4-BE49-F238E27FC236}">
-                <a16:creationId xmlns:a16="http://schemas.microsoft.com/office/drawing/2014/main" id="{8B3635BA-7F43-42FF-805A-A46C8E57D1C8}"/>
+                <a16:creationId xmlns:a16="http://schemas.microsoft.com/office/drawing/2014/main" id="{87EE48BF-3467-4654-AF69-8F6ECAE1E0FB}"/>
               </a:ext>
             </a:extLst>
           </p:cNvPr>
@@ -1528,7 +1528,7 @@
           <p:cNvPr id="4" name="">
             <a:extLst xmlns:a="http://schemas.openxmlformats.org/drawingml/2006/main">
               <a:ext uri="{FF2B5EF4-FFF2-40B4-BE49-F238E27FC236}">
-                <a16:creationId xmlns:a16="http://schemas.microsoft.com/office/drawing/2014/main" id="{DD563C8C-DA1A-4AE3-AB8F-500BBA148273}"/>
+                <a16:creationId xmlns:a16="http://schemas.microsoft.com/office/drawing/2014/main" id="{A514202E-96DB-4A1D-8BB1-1487138184E8}"/>
               </a:ext>
             </a:extLst>
           </p:cNvPr>
@@ -1593,7 +1593,7 @@
           <p:nvPr/>
         </p:nvPicPr>
         <p:blipFill>
-          <a:blip xmlns:r="http://schemas.openxmlformats.org/officeDocument/2006/relationships" xmlns:a="http://schemas.openxmlformats.org/drawingml/2006/main" r:embed="R60a19325875149d5"/>
+          <a:blip xmlns:r="http://schemas.openxmlformats.org/officeDocument/2006/relationships" xmlns:a="http://schemas.openxmlformats.org/drawingml/2006/main" r:embed="Rce9f1a99adde4235"/>
           <a:stretch xmlns:a="http://schemas.openxmlformats.org/drawingml/2006/main"/>
         </p:blipFill>
         <p:spPr>
@@ -1611,7 +1611,7 @@
           <p:cNvPr id="6" name="">
             <a:extLst xmlns:a="http://schemas.openxmlformats.org/drawingml/2006/main">
               <a:ext uri="{FF2B5EF4-FFF2-40B4-BE49-F238E27FC236}">
-                <a16:creationId xmlns:a16="http://schemas.microsoft.com/office/drawing/2014/main" id="{C44AF1B0-FBE7-4FDA-A9C6-A3571D945C4A}"/>
+                <a16:creationId xmlns:a16="http://schemas.microsoft.com/office/drawing/2014/main" id="{CC164124-A2BF-46C2-B731-ACE2E8C84775}"/>
               </a:ext>
             </a:extLst>
           </p:cNvPr>
@@ -1662,7 +1662,7 @@
                 <a:ea typeface="Liberation Sans"/>
                 <a:cs typeface="Liberation Sans"/>
               </a:rPr>
-              <a:t>01 / A device signature authenticates a claim. It does not establish physical truth.</a:t>
+              <a:t>01 / A signature identifies the claim’s source. Physical truth needs separate controls.</a:t>
             </a:r>
           </a:p>
         </p:txBody>
@@ -1670,7 +1670,7 @@
     </p:spTree>
     <p:extLst>
       <p:ext uri="{BB962C8B-B14F-4D97-AF65-F5344CB8AC3E}">
-        <p14:creationId xmlns:p14="http://schemas.microsoft.com/office/powerpoint/2010/main" val="96589454"/>
+        <p14:creationId xmlns:p14="http://schemas.microsoft.com/office/powerpoint/2010/main" val="1400951751"/>
       </p:ext>
     </p:extLst>
   </p:cSld>
@@ -1701,7 +1701,7 @@
           <p:cNvPr id="10" name="">
             <a:extLst xmlns:a="http://schemas.openxmlformats.org/drawingml/2006/main">
               <a:ext uri="{FF2B5EF4-FFF2-40B4-BE49-F238E27FC236}">
-                <a16:creationId xmlns:a16="http://schemas.microsoft.com/office/drawing/2014/main" id="{F4BBBA1B-FAA3-45C6-8D49-15E16E13DC2B}"/>
+                <a16:creationId xmlns:a16="http://schemas.microsoft.com/office/drawing/2014/main" id="{9626C400-F500-4BB9-A44B-5F491EF4682A}"/>
               </a:ext>
             </a:extLst>
           </p:cNvPr>
@@ -1762,7 +1762,7 @@
           <p:cNvPr id="2" name="">
             <a:extLst xmlns:a="http://schemas.openxmlformats.org/drawingml/2006/main">
               <a:ext uri="{FF2B5EF4-FFF2-40B4-BE49-F238E27FC236}">
-                <a16:creationId xmlns:a16="http://schemas.microsoft.com/office/drawing/2014/main" id="{28CFCB66-6A7F-41CD-9A7C-243D85C06425}"/>
+                <a16:creationId xmlns:a16="http://schemas.microsoft.com/office/drawing/2014/main" id="{347A121C-8D91-46A8-A663-BAA8EB4366AD}"/>
               </a:ext>
             </a:extLst>
           </p:cNvPr>
@@ -1823,7 +1823,7 @@
           <p:cNvPr id="3" name="">
             <a:extLst xmlns:a="http://schemas.openxmlformats.org/drawingml/2006/main">
               <a:ext uri="{FF2B5EF4-FFF2-40B4-BE49-F238E27FC236}">
-                <a16:creationId xmlns:a16="http://schemas.microsoft.com/office/drawing/2014/main" id="{7DE2F1E5-6548-4F06-8BC6-C295DFD127CA}"/>
+                <a16:creationId xmlns:a16="http://schemas.microsoft.com/office/drawing/2014/main" id="{D6B07CFF-45EE-4C80-9A47-A90618F96DBA}"/>
               </a:ext>
             </a:extLst>
           </p:cNvPr>
@@ -1884,7 +1884,7 @@
           <p:cNvPr id="4" name="">
             <a:extLst xmlns:a="http://schemas.openxmlformats.org/drawingml/2006/main">
               <a:ext uri="{FF2B5EF4-FFF2-40B4-BE49-F238E27FC236}">
-                <a16:creationId xmlns:a16="http://schemas.microsoft.com/office/drawing/2014/main" id="{62A8D1CD-E793-481F-A881-081E5EAE8823}"/>
+                <a16:creationId xmlns:a16="http://schemas.microsoft.com/office/drawing/2014/main" id="{A4B86E51-DE71-4915-AF2D-4D20ADCAC2A1}"/>
               </a:ext>
             </a:extLst>
           </p:cNvPr>
@@ -1945,7 +1945,7 @@
           <p:cNvPr id="5" name="">
             <a:extLst xmlns:a="http://schemas.openxmlformats.org/drawingml/2006/main">
               <a:ext uri="{FF2B5EF4-FFF2-40B4-BE49-F238E27FC236}">
-                <a16:creationId xmlns:a16="http://schemas.microsoft.com/office/drawing/2014/main" id="{E0834333-BB5F-482B-8284-3329BE3FBD13}"/>
+                <a16:creationId xmlns:a16="http://schemas.microsoft.com/office/drawing/2014/main" id="{C370338D-7AB0-42FE-B2DA-C4E22EA8733F}"/>
               </a:ext>
             </a:extLst>
           </p:cNvPr>
@@ -2006,7 +2006,7 @@
           <p:cNvPr id="6" name="">
             <a:extLst xmlns:a="http://schemas.openxmlformats.org/drawingml/2006/main">
               <a:ext uri="{FF2B5EF4-FFF2-40B4-BE49-F238E27FC236}">
-                <a16:creationId xmlns:a16="http://schemas.microsoft.com/office/drawing/2014/main" id="{9E2F1DFC-9F9C-42CF-B76F-C562E52F80F6}"/>
+                <a16:creationId xmlns:a16="http://schemas.microsoft.com/office/drawing/2014/main" id="{B48DD837-1430-4117-BDA6-4520BAADA121}"/>
               </a:ext>
             </a:extLst>
           </p:cNvPr>
@@ -2067,7 +2067,7 @@
           <p:cNvPr id="7" name="">
             <a:extLst xmlns:a="http://schemas.openxmlformats.org/drawingml/2006/main">
               <a:ext uri="{FF2B5EF4-FFF2-40B4-BE49-F238E27FC236}">
-                <a16:creationId xmlns:a16="http://schemas.microsoft.com/office/drawing/2014/main" id="{7BE6FCB7-35C5-4563-B3F3-287BEE46C1FF}"/>
+                <a16:creationId xmlns:a16="http://schemas.microsoft.com/office/drawing/2014/main" id="{45C897BC-075E-422C-95AD-B6B08EE52B0E}"/>
               </a:ext>
             </a:extLst>
           </p:cNvPr>
@@ -2128,7 +2128,7 @@
           <p:cNvPr id="8" name="">
             <a:extLst xmlns:a="http://schemas.openxmlformats.org/drawingml/2006/main">
               <a:ext uri="{FF2B5EF4-FFF2-40B4-BE49-F238E27FC236}">
-                <a16:creationId xmlns:a16="http://schemas.microsoft.com/office/drawing/2014/main" id="{F77B72B4-2475-456F-9386-7C50C067533B}"/>
+                <a16:creationId xmlns:a16="http://schemas.microsoft.com/office/drawing/2014/main" id="{4DE72AA6-164A-4BBD-90F4-0CC3FE4DD242}"/>
               </a:ext>
             </a:extLst>
           </p:cNvPr>
@@ -2189,7 +2189,7 @@
           <p:cNvPr id="9" name="">
             <a:extLst xmlns:a="http://schemas.openxmlformats.org/drawingml/2006/main">
               <a:ext uri="{FF2B5EF4-FFF2-40B4-BE49-F238E27FC236}">
-                <a16:creationId xmlns:a16="http://schemas.microsoft.com/office/drawing/2014/main" id="{83F24F17-DEB1-4A9D-8F50-61AC77AE8886}"/>
+                <a16:creationId xmlns:a16="http://schemas.microsoft.com/office/drawing/2014/main" id="{86B2106D-EA2A-4163-AB58-A28AD8458EE3}"/>
               </a:ext>
             </a:extLst>
           </p:cNvPr>
@@ -2240,7 +2240,7 @@
                 <a:ea typeface="Liberation Sans"/>
                 <a:cs typeface="Liberation Sans"/>
               </a:rPr>
-              <a:t>02 / Buyer hypothesis. No customer or willingness to pay is validated. Use an existing API when it supplies the answer.</a:t>
+              <a:t>02 / Buyer and pricing remain hypotheses. An existing reliable API can be sufficient.</a:t>
             </a:r>
           </a:p>
         </p:txBody>
@@ -2248,7 +2248,7 @@
     </p:spTree>
     <p:extLst>
       <p:ext uri="{BB962C8B-B14F-4D97-AF65-F5344CB8AC3E}">
-        <p14:creationId xmlns:p14="http://schemas.microsoft.com/office/powerpoint/2010/main" val="53345973"/>
+        <p14:creationId xmlns:p14="http://schemas.microsoft.com/office/powerpoint/2010/main" val="1041157775"/>
       </p:ext>
     </p:extLst>
   </p:cSld>
@@ -2279,7 +2279,7 @@
           <p:cNvPr id="11" name="">
             <a:extLst xmlns:a="http://schemas.openxmlformats.org/drawingml/2006/main">
               <a:ext uri="{FF2B5EF4-FFF2-40B4-BE49-F238E27FC236}">
-                <a16:creationId xmlns:a16="http://schemas.microsoft.com/office/drawing/2014/main" id="{06C900AF-428E-4ACE-89D3-DBE9CEDD8674}"/>
+                <a16:creationId xmlns:a16="http://schemas.microsoft.com/office/drawing/2014/main" id="{655C990A-8EF5-4541-8653-2CB0B5F7A70C}"/>
               </a:ext>
             </a:extLst>
           </p:cNvPr>
@@ -2340,7 +2340,7 @@
           <p:cNvPr id="2" name="">
             <a:extLst xmlns:a="http://schemas.openxmlformats.org/drawingml/2006/main">
               <a:ext uri="{FF2B5EF4-FFF2-40B4-BE49-F238E27FC236}">
-                <a16:creationId xmlns:a16="http://schemas.microsoft.com/office/drawing/2014/main" id="{260C98F7-8B0C-42A1-8ECA-12A1946BB3B4}"/>
+                <a16:creationId xmlns:a16="http://schemas.microsoft.com/office/drawing/2014/main" id="{C939EADB-D828-4CB1-815E-B164D3570066}"/>
               </a:ext>
             </a:extLst>
           </p:cNvPr>
@@ -2401,7 +2401,7 @@
           <p:cNvPr id="3" name="">
             <a:extLst xmlns:a="http://schemas.openxmlformats.org/drawingml/2006/main">
               <a:ext uri="{FF2B5EF4-FFF2-40B4-BE49-F238E27FC236}">
-                <a16:creationId xmlns:a16="http://schemas.microsoft.com/office/drawing/2014/main" id="{CAD29CF3-2CE0-42C2-B050-C6AFDA61CE16}"/>
+                <a16:creationId xmlns:a16="http://schemas.microsoft.com/office/drawing/2014/main" id="{D72B06EA-86A2-4759-B497-D83D8F4BC767}"/>
               </a:ext>
             </a:extLst>
           </p:cNvPr>
@@ -2462,7 +2462,7 @@
           <p:cNvPr id="4" name="">
             <a:extLst xmlns:a="http://schemas.openxmlformats.org/drawingml/2006/main">
               <a:ext uri="{FF2B5EF4-FFF2-40B4-BE49-F238E27FC236}">
-                <a16:creationId xmlns:a16="http://schemas.microsoft.com/office/drawing/2014/main" id="{DF0EC04A-FC93-46DD-BBC8-05E2B1D8E3D8}"/>
+                <a16:creationId xmlns:a16="http://schemas.microsoft.com/office/drawing/2014/main" id="{06E96C98-6CE3-4B49-A17F-92177986D982}"/>
               </a:ext>
             </a:extLst>
           </p:cNvPr>
@@ -2523,7 +2523,7 @@
           <p:cNvPr id="5" name="">
             <a:extLst xmlns:a="http://schemas.openxmlformats.org/drawingml/2006/main">
               <a:ext uri="{FF2B5EF4-FFF2-40B4-BE49-F238E27FC236}">
-                <a16:creationId xmlns:a16="http://schemas.microsoft.com/office/drawing/2014/main" id="{41C0DCA4-3642-4855-B7DC-9BCB70D235DB}"/>
+                <a16:creationId xmlns:a16="http://schemas.microsoft.com/office/drawing/2014/main" id="{6E227CF9-EA9A-433D-8468-51B1709D845E}"/>
               </a:ext>
             </a:extLst>
           </p:cNvPr>
@@ -2584,7 +2584,7 @@
           <p:cNvPr id="6" name="">
             <a:extLst xmlns:a="http://schemas.openxmlformats.org/drawingml/2006/main">
               <a:ext uri="{FF2B5EF4-FFF2-40B4-BE49-F238E27FC236}">
-                <a16:creationId xmlns:a16="http://schemas.microsoft.com/office/drawing/2014/main" id="{290DDFC4-B564-4CAE-BF06-872E6601598F}"/>
+                <a16:creationId xmlns:a16="http://schemas.microsoft.com/office/drawing/2014/main" id="{14545F58-6ABB-4C80-873C-E773E95D3280}"/>
               </a:ext>
             </a:extLst>
           </p:cNvPr>
@@ -2645,7 +2645,7 @@
           <p:cNvPr id="7" name="">
             <a:extLst xmlns:a="http://schemas.openxmlformats.org/drawingml/2006/main">
               <a:ext uri="{FF2B5EF4-FFF2-40B4-BE49-F238E27FC236}">
-                <a16:creationId xmlns:a16="http://schemas.microsoft.com/office/drawing/2014/main" id="{53109F1B-54B3-4D2D-9EB9-C48B5532B918}"/>
+                <a16:creationId xmlns:a16="http://schemas.microsoft.com/office/drawing/2014/main" id="{A79CD3BF-D331-4A21-957B-E6E3DDE77962}"/>
               </a:ext>
             </a:extLst>
           </p:cNvPr>
@@ -2706,7 +2706,7 @@
           <p:cNvPr id="8" name="">
             <a:extLst xmlns:a="http://schemas.openxmlformats.org/drawingml/2006/main">
               <a:ext uri="{FF2B5EF4-FFF2-40B4-BE49-F238E27FC236}">
-                <a16:creationId xmlns:a16="http://schemas.microsoft.com/office/drawing/2014/main" id="{1B98F7FE-2105-4D6E-9CF5-22D676EBE4CC}"/>
+                <a16:creationId xmlns:a16="http://schemas.microsoft.com/office/drawing/2014/main" id="{B65840EE-00C9-4E8B-8C13-4901DC69D951}"/>
               </a:ext>
             </a:extLst>
           </p:cNvPr>
@@ -2767,7 +2767,7 @@
           <p:cNvPr id="9" name="">
             <a:extLst xmlns:a="http://schemas.openxmlformats.org/drawingml/2006/main">
               <a:ext uri="{FF2B5EF4-FFF2-40B4-BE49-F238E27FC236}">
-                <a16:creationId xmlns:a16="http://schemas.microsoft.com/office/drawing/2014/main" id="{826755B0-BC71-4DAF-B01C-EFAAF9ED5003}"/>
+                <a16:creationId xmlns:a16="http://schemas.microsoft.com/office/drawing/2014/main" id="{7794797A-FA9D-41A0-A69F-170A74855D43}"/>
               </a:ext>
             </a:extLst>
           </p:cNvPr>
@@ -2828,7 +2828,7 @@
           <p:cNvPr id="10" name="">
             <a:extLst xmlns:a="http://schemas.openxmlformats.org/drawingml/2006/main">
               <a:ext uri="{FF2B5EF4-FFF2-40B4-BE49-F238E27FC236}">
-                <a16:creationId xmlns:a16="http://schemas.microsoft.com/office/drawing/2014/main" id="{7E44799A-1C24-46F1-930B-EC0C3B873D2A}"/>
+                <a16:creationId xmlns:a16="http://schemas.microsoft.com/office/drawing/2014/main" id="{25EE1B7B-F1CE-4E97-8B7C-CD6A86DCED08}"/>
               </a:ext>
             </a:extLst>
           </p:cNvPr>
@@ -2879,7 +2879,7 @@
                 <a:ea typeface="Liberation Sans"/>
                 <a:cs typeface="Liberation Sans"/>
               </a:rPr>
-              <a:t>03 / OPEN and CLOSED both fulfill the paid check. The operator wallet receives test tokens. The buyer's next action is separate.</a:t>
+              <a:t>03 / Both contact states fulfill the paid check. The operator receives test tokens.</a:t>
             </a:r>
           </a:p>
         </p:txBody>
@@ -2887,7 +2887,7 @@
     </p:spTree>
     <p:extLst>
       <p:ext uri="{BB962C8B-B14F-4D97-AF65-F5344CB8AC3E}">
-        <p14:creationId xmlns:p14="http://schemas.microsoft.com/office/powerpoint/2010/main" val="1163993222"/>
+        <p14:creationId xmlns:p14="http://schemas.microsoft.com/office/powerpoint/2010/main" val="311761918"/>
       </p:ext>
     </p:extLst>
   </p:cSld>
@@ -2918,7 +2918,7 @@
           <p:cNvPr id="9" name="">
             <a:extLst xmlns:a="http://schemas.openxmlformats.org/drawingml/2006/main">
               <a:ext uri="{FF2B5EF4-FFF2-40B4-BE49-F238E27FC236}">
-                <a16:creationId xmlns:a16="http://schemas.microsoft.com/office/drawing/2014/main" id="{F1C5EDAA-18D9-4C7D-BA15-B6BDB16D0276}"/>
+                <a16:creationId xmlns:a16="http://schemas.microsoft.com/office/drawing/2014/main" id="{5730CC44-E194-4465-9290-4ABB54D2A04B}"/>
               </a:ext>
             </a:extLst>
           </p:cNvPr>
@@ -2979,7 +2979,7 @@
           <p:cNvPr id="2" name="">
             <a:extLst xmlns:a="http://schemas.openxmlformats.org/drawingml/2006/main">
               <a:ext uri="{FF2B5EF4-FFF2-40B4-BE49-F238E27FC236}">
-                <a16:creationId xmlns:a16="http://schemas.microsoft.com/office/drawing/2014/main" id="{0C291444-DE67-43F7-97E7-2FB9A35743BC}"/>
+                <a16:creationId xmlns:a16="http://schemas.microsoft.com/office/drawing/2014/main" id="{018CC3A7-E786-4CC1-9C69-74721A8FB110}"/>
               </a:ext>
             </a:extLst>
           </p:cNvPr>
@@ -3040,7 +3040,7 @@
           <p:cNvPr id="3" name="">
             <a:extLst xmlns:a="http://schemas.openxmlformats.org/drawingml/2006/main">
               <a:ext uri="{FF2B5EF4-FFF2-40B4-BE49-F238E27FC236}">
-                <a16:creationId xmlns:a16="http://schemas.microsoft.com/office/drawing/2014/main" id="{E138EE96-27E1-4C49-8A0C-949AB1B0886B}"/>
+                <a16:creationId xmlns:a16="http://schemas.microsoft.com/office/drawing/2014/main" id="{92020722-7F56-4156-80C4-3AC36EA3A367}"/>
               </a:ext>
             </a:extLst>
           </p:cNvPr>
@@ -3101,7 +3101,7 @@
           <p:cNvPr id="4" name="">
             <a:extLst xmlns:a="http://schemas.openxmlformats.org/drawingml/2006/main">
               <a:ext uri="{FF2B5EF4-FFF2-40B4-BE49-F238E27FC236}">
-                <a16:creationId xmlns:a16="http://schemas.microsoft.com/office/drawing/2014/main" id="{6105CFB5-0634-4020-9919-C20B4BE35FB9}"/>
+                <a16:creationId xmlns:a16="http://schemas.microsoft.com/office/drawing/2014/main" id="{7FD7EF97-601E-4BC5-BFBA-C95FD0DD4F74}"/>
               </a:ext>
             </a:extLst>
           </p:cNvPr>
@@ -3162,7 +3162,7 @@
           <p:cNvPr id="5" name="">
             <a:extLst xmlns:a="http://schemas.openxmlformats.org/drawingml/2006/main">
               <a:ext uri="{FF2B5EF4-FFF2-40B4-BE49-F238E27FC236}">
-                <a16:creationId xmlns:a16="http://schemas.microsoft.com/office/drawing/2014/main" id="{8B575DDD-3E2E-4576-B350-74F22D4A6112}"/>
+                <a16:creationId xmlns:a16="http://schemas.microsoft.com/office/drawing/2014/main" id="{5ED12925-5371-4E4A-BD26-D76D70D24C86}"/>
               </a:ext>
             </a:extLst>
           </p:cNvPr>
@@ -3223,7 +3223,7 @@
           <p:cNvPr id="6" name="">
             <a:extLst xmlns:a="http://schemas.openxmlformats.org/drawingml/2006/main">
               <a:ext uri="{FF2B5EF4-FFF2-40B4-BE49-F238E27FC236}">
-                <a16:creationId xmlns:a16="http://schemas.microsoft.com/office/drawing/2014/main" id="{3B7B2462-008C-4920-B45F-A3B95BC37653}"/>
+                <a16:creationId xmlns:a16="http://schemas.microsoft.com/office/drawing/2014/main" id="{E1B3F251-2749-4411-92C3-6B7BB2A5A262}"/>
               </a:ext>
             </a:extLst>
           </p:cNvPr>
@@ -3284,7 +3284,7 @@
           <p:cNvPr id="7" name="">
             <a:extLst xmlns:a="http://schemas.openxmlformats.org/drawingml/2006/main">
               <a:ext uri="{FF2B5EF4-FFF2-40B4-BE49-F238E27FC236}">
-                <a16:creationId xmlns:a16="http://schemas.microsoft.com/office/drawing/2014/main" id="{46CAAC0C-51D5-4C37-992C-DB849611875C}"/>
+                <a16:creationId xmlns:a16="http://schemas.microsoft.com/office/drawing/2014/main" id="{83E7AB47-D984-400A-B4D2-B7CAB8DCEC84}"/>
               </a:ext>
             </a:extLst>
           </p:cNvPr>
@@ -3345,7 +3345,7 @@
           <p:cNvPr id="8" name="">
             <a:extLst xmlns:a="http://schemas.openxmlformats.org/drawingml/2006/main">
               <a:ext uri="{FF2B5EF4-FFF2-40B4-BE49-F238E27FC236}">
-                <a16:creationId xmlns:a16="http://schemas.microsoft.com/office/drawing/2014/main" id="{37AE8637-58F2-48EF-AC21-C78FFFEC24C5}"/>
+                <a16:creationId xmlns:a16="http://schemas.microsoft.com/office/drawing/2014/main" id="{E21B37B1-E47D-447A-9F42-B4DE9184A511}"/>
               </a:ext>
             </a:extLst>
           </p:cNvPr>
@@ -3396,7 +3396,7 @@
                 <a:ea typeface="Liberation Sans"/>
                 <a:cs typeface="Liberation Sans"/>
               </a:rPr>
-              <a:t>04 / BOOT is a contact stand-in. No robot or real entrance is connected. The software buyer can serve an AI agent.</a:t>
+              <a:t>04 / BOOT represents a contact. This software controls no door or robot.</a:t>
             </a:r>
           </a:p>
         </p:txBody>
@@ -3404,7 +3404,7 @@
     </p:spTree>
     <p:extLst>
       <p:ext uri="{BB962C8B-B14F-4D97-AF65-F5344CB8AC3E}">
-        <p14:creationId xmlns:p14="http://schemas.microsoft.com/office/powerpoint/2010/main" val="264510098"/>
+        <p14:creationId xmlns:p14="http://schemas.microsoft.com/office/powerpoint/2010/main" val="1579757540"/>
       </p:ext>
     </p:extLst>
   </p:cSld>
@@ -3435,7 +3435,7 @@
           <p:cNvPr id="10" name="">
             <a:extLst xmlns:a="http://schemas.openxmlformats.org/drawingml/2006/main">
               <a:ext uri="{FF2B5EF4-FFF2-40B4-BE49-F238E27FC236}">
-                <a16:creationId xmlns:a16="http://schemas.microsoft.com/office/drawing/2014/main" id="{487AA1D5-3FF5-4314-979F-DAE2ADCF8E4C}"/>
+                <a16:creationId xmlns:a16="http://schemas.microsoft.com/office/drawing/2014/main" id="{9724F5E4-17EC-41DD-BA2B-F5158BEA951A}"/>
               </a:ext>
             </a:extLst>
           </p:cNvPr>
@@ -3496,7 +3496,7 @@
           <p:cNvPr id="2" name="">
             <a:extLst xmlns:a="http://schemas.openxmlformats.org/drawingml/2006/main">
               <a:ext uri="{FF2B5EF4-FFF2-40B4-BE49-F238E27FC236}">
-                <a16:creationId xmlns:a16="http://schemas.microsoft.com/office/drawing/2014/main" id="{23A01D95-E005-4A16-907B-6205581C7E10}"/>
+                <a16:creationId xmlns:a16="http://schemas.microsoft.com/office/drawing/2014/main" id="{EDB86DF7-06DD-4D5C-9EFE-A598175D4613}"/>
               </a:ext>
             </a:extLst>
           </p:cNvPr>
@@ -3557,7 +3557,7 @@
           <p:cNvPr id="3" name="">
             <a:extLst xmlns:a="http://schemas.openxmlformats.org/drawingml/2006/main">
               <a:ext uri="{FF2B5EF4-FFF2-40B4-BE49-F238E27FC236}">
-                <a16:creationId xmlns:a16="http://schemas.microsoft.com/office/drawing/2014/main" id="{EFC359E8-16AB-4EE9-AE09-5CD09C3B8F19}"/>
+                <a16:creationId xmlns:a16="http://schemas.microsoft.com/office/drawing/2014/main" id="{A2653A6F-76EB-4548-AD77-89CC759E8570}"/>
               </a:ext>
             </a:extLst>
           </p:cNvPr>
@@ -3618,7 +3618,7 @@
           <p:cNvPr id="4" name="">
             <a:extLst xmlns:a="http://schemas.openxmlformats.org/drawingml/2006/main">
               <a:ext uri="{FF2B5EF4-FFF2-40B4-BE49-F238E27FC236}">
-                <a16:creationId xmlns:a16="http://schemas.microsoft.com/office/drawing/2014/main" id="{B6866D5C-8144-40BA-9A3A-E05D14BE80C8}"/>
+                <a16:creationId xmlns:a16="http://schemas.microsoft.com/office/drawing/2014/main" id="{F4AA4F36-7F39-45F1-ABA8-E1A79CB962D8}"/>
               </a:ext>
             </a:extLst>
           </p:cNvPr>
@@ -3669,7 +3669,7 @@
                 <a:ea typeface="Liberation Sans"/>
                 <a:cs typeface="Liberation Sans"/>
               </a:rPr>
-              <a:t>The public replay preserves the October 11 transaction and capture time.</a:t>
+              <a:t>The public replay preserves the October 12 job and its original capture time.</a:t>
             </a:r>
           </a:p>
         </p:txBody>
@@ -3679,7 +3679,7 @@
           <p:cNvPr id="5" name="">
             <a:extLst xmlns:a="http://schemas.openxmlformats.org/drawingml/2006/main">
               <a:ext uri="{FF2B5EF4-FFF2-40B4-BE49-F238E27FC236}">
-                <a16:creationId xmlns:a16="http://schemas.microsoft.com/office/drawing/2014/main" id="{E0B1A7A8-3114-4C37-AA2D-062EFCA0A29F}"/>
+                <a16:creationId xmlns:a16="http://schemas.microsoft.com/office/drawing/2014/main" id="{22C798D7-7D19-415B-AC38-B83C1CE911B0}"/>
               </a:ext>
             </a:extLst>
           </p:cNvPr>
@@ -3714,7 +3714,7 @@
               <a:buNone/>
               <a:defRPr sz="2175" b="1">
                 <a:solidFill>
-                  <a:srgbClr val="9A5617"/>
+                  <a:srgbClr val="126C97"/>
                 </a:solidFill>
                 <a:latin typeface="Liberation Sans"/>
                 <a:ea typeface="Liberation Sans"/>
@@ -3724,13 +3724,13 @@
             <a:r>
               <a:rPr sz="2175" b="1">
                 <a:solidFill>
-                  <a:srgbClr val="9A5617"/>
+                  <a:srgbClr val="126C97"/>
                 </a:solidFill>
                 <a:latin typeface="Liberation Sans"/>
                 <a:ea typeface="Liberation Sans"/>
                 <a:cs typeface="Liberation Sans"/>
               </a:rPr>
-              <a:t>peaq: live integration pending</a:t>
+              <a:t>peaq Agung: verified</a:t>
             </a:r>
           </a:p>
         </p:txBody>
@@ -3740,7 +3740,7 @@
           <p:cNvPr id="6" name="">
             <a:extLst xmlns:a="http://schemas.openxmlformats.org/drawingml/2006/main">
               <a:ext uri="{FF2B5EF4-FFF2-40B4-BE49-F238E27FC236}">
-                <a16:creationId xmlns:a16="http://schemas.microsoft.com/office/drawing/2014/main" id="{9336EA76-A7A8-4E94-9F00-1484663200EE}"/>
+                <a16:creationId xmlns:a16="http://schemas.microsoft.com/office/drawing/2014/main" id="{BA1C4157-4CC7-4145-9603-248218084465}"/>
               </a:ext>
             </a:extLst>
           </p:cNvPr>
@@ -3801,7 +3801,7 @@
           <p:cNvPr id="7" name="">
             <a:extLst xmlns:a="http://schemas.openxmlformats.org/drawingml/2006/main">
               <a:ext uri="{FF2B5EF4-FFF2-40B4-BE49-F238E27FC236}">
-                <a16:creationId xmlns:a16="http://schemas.microsoft.com/office/drawing/2014/main" id="{184D22A4-FA41-4147-943D-B42218C28123}"/>
+                <a16:creationId xmlns:a16="http://schemas.microsoft.com/office/drawing/2014/main" id="{9156A9B7-7967-436E-A82D-BF33D4F6AADE}"/>
               </a:ext>
             </a:extLst>
           </p:cNvPr>
@@ -3852,7 +3852,7 @@
                 <a:ea typeface="Liberation Sans"/>
                 <a:cs typeface="Liberation Sans"/>
               </a:rPr>
-              <a:t>An activity record links a completed check to payment and evidence.</a:t>
+              <a:t>A finalized native Storage record links the unchanged job hash.</a:t>
             </a:r>
           </a:p>
         </p:txBody>
@@ -3862,7 +3862,7 @@
           <p:cNvPr id="8" name="">
             <a:extLst xmlns:a="http://schemas.openxmlformats.org/drawingml/2006/main">
               <a:ext uri="{FF2B5EF4-FFF2-40B4-BE49-F238E27FC236}">
-                <a16:creationId xmlns:a16="http://schemas.microsoft.com/office/drawing/2014/main" id="{C936E732-AE1E-47A4-A0DB-310F008EC72F}"/>
+                <a16:creationId xmlns:a16="http://schemas.microsoft.com/office/drawing/2014/main" id="{FF4D7D35-24C9-40BC-84B6-D5DE0EA65F79}"/>
               </a:ext>
             </a:extLst>
           </p:cNvPr>
@@ -3923,7 +3923,7 @@
           <p:cNvPr id="9" name="">
             <a:extLst xmlns:a="http://schemas.openxmlformats.org/drawingml/2006/main">
               <a:ext uri="{FF2B5EF4-FFF2-40B4-BE49-F238E27FC236}">
-                <a16:creationId xmlns:a16="http://schemas.microsoft.com/office/drawing/2014/main" id="{CAE80FD8-FA99-4163-ADFD-F3B83690D042}"/>
+                <a16:creationId xmlns:a16="http://schemas.microsoft.com/office/drawing/2014/main" id="{DCECA491-FDD6-4553-AB75-D5580F727B6B}"/>
               </a:ext>
             </a:extLst>
           </p:cNvPr>
@@ -3974,7 +3974,7 @@
                 <a:ea typeface="Liberation Sans"/>
                 <a:cs typeface="Liberation Sans"/>
               </a:rPr>
-              <a:t>05 / peaq code has tests. No live identity or activity event is established. Paid integration and inspection fees remain hypotheses.</a:t>
+              <a:t>05 / Real Agung identity and Storage readbacks. Customer demand remains unvalidated.</a:t>
             </a:r>
           </a:p>
         </p:txBody>
@@ -3982,7 +3982,7 @@
     </p:spTree>
     <p:extLst>
       <p:ext uri="{BB962C8B-B14F-4D97-AF65-F5344CB8AC3E}">
-        <p14:creationId xmlns:p14="http://schemas.microsoft.com/office/powerpoint/2010/main" val="1105289494"/>
+        <p14:creationId xmlns:p14="http://schemas.microsoft.com/office/powerpoint/2010/main" val="398696374"/>
       </p:ext>
     </p:extLst>
   </p:cSld>

</xml_diff>

<commit_message>
feat: publish a simple pitch and the real peaq-linked review cut
</commit_message>
<xml_diff>
--- a/docs/competition/fieldproof-pitch.pptx
+++ b/docs/competition/fieldproof-pitch.pptx
@@ -2,17 +2,17 @@
 <file path=ppt/presentation.xml><?xml version="1.0" encoding="utf-8"?>
 <p:presentation xmlns:p="http://schemas.openxmlformats.org/presentationml/2006/main">
   <p:sldMasterIdLst>
-    <p:sldMasterId xmlns:r="http://schemas.openxmlformats.org/officeDocument/2006/relationships" id="2147483648" r:id="R5e3e9016d05141af"/>
+    <p:sldMasterId xmlns:r="http://schemas.openxmlformats.org/officeDocument/2006/relationships" id="2147483648" r:id="Rad932027e67345d1"/>
   </p:sldMasterIdLst>
   <p:notesMasterIdLst>
-    <p:notesMasterId xmlns:r="http://schemas.openxmlformats.org/officeDocument/2006/relationships" r:id="R1ffac5f41aec41bd"/>
+    <p:notesMasterId xmlns:r="http://schemas.openxmlformats.org/officeDocument/2006/relationships" r:id="R9717f12da3ed4360"/>
   </p:notesMasterIdLst>
   <p:sldIdLst>
-    <p:sldId xmlns:r="http://schemas.openxmlformats.org/officeDocument/2006/relationships" id="256" r:id="Rddd7d392dd94452c"/>
-    <p:sldId xmlns:r="http://schemas.openxmlformats.org/officeDocument/2006/relationships" id="257" r:id="R1fca12981e9e4765"/>
-    <p:sldId xmlns:r="http://schemas.openxmlformats.org/officeDocument/2006/relationships" id="258" r:id="R7b8168d628d749e8"/>
-    <p:sldId xmlns:r="http://schemas.openxmlformats.org/officeDocument/2006/relationships" id="259" r:id="R55c44a381eb24a77"/>
-    <p:sldId xmlns:r="http://schemas.openxmlformats.org/officeDocument/2006/relationships" id="260" r:id="Ra2e1ae4c9f6046ec"/>
+    <p:sldId xmlns:r="http://schemas.openxmlformats.org/officeDocument/2006/relationships" id="256" r:id="Ree86c22933ad40f2"/>
+    <p:sldId xmlns:r="http://schemas.openxmlformats.org/officeDocument/2006/relationships" id="257" r:id="R3c0cdab536b44258"/>
+    <p:sldId xmlns:r="http://schemas.openxmlformats.org/officeDocument/2006/relationships" id="258" r:id="Rf269fe350e0442bb"/>
+    <p:sldId xmlns:r="http://schemas.openxmlformats.org/officeDocument/2006/relationships" id="259" r:id="Read9203d2f5443ac"/>
+    <p:sldId xmlns:r="http://schemas.openxmlformats.org/officeDocument/2006/relationships" id="260" r:id="Rff1a3ccf8c0f472f"/>
   </p:sldIdLst>
   <p:sldSz cx="12192000" cy="6858000"/>
   <p:notesSz cx="6858000" cy="9144000"/>
@@ -446,7 +446,7 @@
           <a:lstStyle xmlns:a="http://schemas.openxmlformats.org/drawingml/2006/main"/>
           <a:p xmlns:a="http://schemas.openxmlformats.org/drawingml/2006/main">
             <a:r>
-              <a:t>Content source: docs/competition/slides.html. Implementation and evidence: docs/VERIFICATION.md and docs/evidence/device-signed-purchase-20261011.json. Buyer value and commercial pricing are hypotheses. The Solana transaction uses test tokens. Real Agung identity and native Storage work readbacks passed on October 12. No EventRegistry event or credit rating is claimed. Slide 1 of 5.</a:t>
+              <a:t>Opening and founder context. Explain why software needs a fresh physical answer across device owners. Copy source: docs/competition/slides.html.</a:t>
             </a:r>
           </a:p>
         </p:txBody>
@@ -516,7 +516,7 @@
           <a:lstStyle xmlns:a="http://schemas.openxmlformats.org/drawingml/2006/main"/>
           <a:p xmlns:a="http://schemas.openxmlformats.org/drawingml/2006/main">
             <a:r>
-              <a:t>Content source: docs/competition/slides.html. Implementation and evidence: docs/VERIFICATION.md and docs/evidence/device-signed-purchase-20261011.json. Buyer value and commercial pricing are hypotheses. The Solana transaction uses test tokens. Real Agung identity and native Storage work readbacks passed on October 12. No EventRegistry event or credit rating is claimed. Slide 2 of 5.</a:t>
+              <a:t>Explain a commissioned measurement. Payment buys the check, including an unfavorable answer. A common workflow across independent operators is the product hypothesis. Copy source: docs/competition/slides.html.</a:t>
             </a:r>
           </a:p>
         </p:txBody>
@@ -586,7 +586,7 @@
           <a:lstStyle xmlns:a="http://schemas.openxmlformats.org/drawingml/2006/main"/>
           <a:p xmlns:a="http://schemas.openxmlformats.org/drawingml/2006/main">
             <a:r>
-              <a:t>Content source: docs/competition/slides.html. Implementation and evidence: docs/VERIFICATION.md and docs/evidence/device-signed-purchase-20261011.json. Buyer value and commercial pricing are hypotheses. The Solana transaction uses test tokens. Real Agung identity and native Storage work readbacks passed on October 12. No EventRegistry event or credit rating is claimed. Slide 3 of 5.</a:t>
+              <a:t>Working evidence: docs/evidence/current-job.json and docs/VERIFICATION.md. One real ESP32 provider. Seeker independently verifies receipts. Solana Devnet pays 0.001 test USDC. The buyer resolves the peaq Agung device key before payment. The completed job has a finalized native Storage work record. No EventRegistry or credit rating is claimed. Copy source: docs/competition/slides.html.</a:t>
             </a:r>
           </a:p>
         </p:txBody>
@@ -656,7 +656,7 @@
           <a:lstStyle xmlns:a="http://schemas.openxmlformats.org/drawingml/2006/main"/>
           <a:p xmlns:a="http://schemas.openxmlformats.org/drawingml/2006/main">
             <a:r>
-              <a:t>Content source: docs/competition/slides.html. Implementation and evidence: docs/VERIFICATION.md and docs/evidence/device-signed-purchase-20261011.json. Buyer value and commercial pricing are hypotheses. The Solana transaction uses test tokens. Real Agung identity and native Storage work readbacks passed on October 12. No EventRegistry event or credit rating is claimed. Slide 4 of 5.</a:t>
+              <a:t>The unchanged receipt timestamp expires under the ten-second buyer policy. An edited local copy fails the original signature. A signature authenticates a claim, not physical truth. Copy source: docs/competition/slides.html.</a:t>
             </a:r>
           </a:p>
         </p:txBody>
@@ -726,7 +726,7 @@
           <a:lstStyle xmlns:a="http://schemas.openxmlformats.org/drawingml/2006/main"/>
           <a:p xmlns:a="http://schemas.openxmlformats.org/drawingml/2006/main">
             <a:r>
-              <a:t>Content source: docs/competition/slides.html. Implementation and evidence: docs/VERIFICATION.md and docs/evidence/device-signed-purchase-20261011.json. Buyer value and commercial pricing are hypotheses. The Solana transaction uses test tokens. Real Agung identity and native Storage work readbacks passed on October 12. No EventRegistry event or credit rating is claimed. Slide 5 of 5.</a:t>
+              <a:t>Future network, customer demand, recurring paid use, and reputation remain unvalidated. Start with one authorized operator and one recurring question. Integration and per-check fees are hypotheses. Logo supplied by the founder. Copy source: docs/competition/slides.html.</a:t>
             </a:r>
           </a:p>
         </p:txBody>
@@ -794,7 +794,7 @@
   </p:cSld>
   <p:clrMap bg1="lt1" tx1="dk1" bg2="lt2" tx2="dk2" accent1="accent1" accent2="accent2" accent3="accent3" accent4="accent4" accent5="accent5" accent6="accent6" hlink="hlink" folHlink="folHlink"/>
   <p:sldLayoutIdLst>
-    <p:sldLayoutId xmlns:r="http://schemas.openxmlformats.org/officeDocument/2006/relationships" id="2147483649" r:id="R043c941cac0c4f89"/>
+    <p:sldLayoutId xmlns:r="http://schemas.openxmlformats.org/officeDocument/2006/relationships" id="2147483649" r:id="Rdf191859f87f4955"/>
   </p:sldLayoutIdLst>
   <p:txStyles>
     <p:titleStyle>
@@ -1327,7 +1327,7 @@
     <p:bg>
       <p:bgPr>
         <a:solidFill xmlns:a="http://schemas.openxmlformats.org/drawingml/2006/main">
-          <a:srgbClr val="F4FAFF"/>
+          <a:srgbClr val="FFFFFF"/>
         </a:solidFill>
       </p:bgPr>
     </p:bg>
@@ -1342,10 +1342,10 @@
       </p:grpSpPr>
       <p:sp>
         <p:nvSpPr>
-          <p:cNvPr id="7" name="">
+          <p:cNvPr id="3" name="">
             <a:extLst xmlns:a="http://schemas.openxmlformats.org/drawingml/2006/main">
               <a:ext uri="{FF2B5EF4-FFF2-40B4-BE49-F238E27FC236}">
-                <a16:creationId xmlns:a16="http://schemas.microsoft.com/office/drawing/2014/main" id="{DEA8DFB1-E5CA-4677-8019-928C3D8049FE}"/>
+                <a16:creationId xmlns:a16="http://schemas.microsoft.com/office/drawing/2014/main" id="{CADA974E-C978-43D5-936E-8D128C594A3D}"/>
               </a:ext>
             </a:extLst>
           </p:cNvPr>
@@ -1356,8 +1356,8 @@
         </p:nvSpPr>
         <p:spPr>
           <a:xfrm xmlns:a="http://schemas.openxmlformats.org/drawingml/2006/main">
-            <a:off x="685800" y="457200"/>
-            <a:ext cx="10820400" cy="857250"/>
+            <a:off x="685800" y="2095500"/>
+            <a:ext cx="10820400" cy="476250"/>
           </a:xfrm>
           <a:prstGeom xmlns:a="http://schemas.openxmlformats.org/drawingml/2006/main" prst="rect">
             <a:avLst/>
@@ -1375,12 +1375,12 @@
           <a:p xmlns:a="http://schemas.openxmlformats.org/drawingml/2006/main">
             <a:pPr>
               <a:lnSpc>
-                <a:spcPct val="118000"/>
+                <a:spcPct val="115000"/>
               </a:lnSpc>
               <a:buNone/>
-              <a:defRPr sz="3450" b="1">
-                <a:solidFill>
-                  <a:srgbClr val="17364D"/>
+              <a:defRPr sz="2250" b="0">
+                <a:solidFill>
+                  <a:srgbClr val="111111"/>
                 </a:solidFill>
                 <a:latin typeface="Liberation Sans"/>
                 <a:ea typeface="Liberation Sans"/>
@@ -1388,15 +1388,15 @@
               </a:defRPr>
             </a:pPr>
             <a:r>
-              <a:rPr sz="3450" b="1">
-                <a:solidFill>
-                  <a:srgbClr val="17364D"/>
+              <a:rPr sz="2250" b="0">
+                <a:solidFill>
+                  <a:srgbClr val="111111"/>
                 </a:solidFill>
                 <a:latin typeface="Liberation Sans"/>
                 <a:ea typeface="Liberation Sans"/>
                 <a:cs typeface="Liberation Sans"/>
               </a:rPr>
-              <a:t>FieldProof</a:t>
+              <a:t>FIELDPROOF</a:t>
             </a:r>
           </a:p>
         </p:txBody>
@@ -1406,7 +1406,7 @@
           <p:cNvPr id="2" name="">
             <a:extLst xmlns:a="http://schemas.openxmlformats.org/drawingml/2006/main">
               <a:ext uri="{FF2B5EF4-FFF2-40B4-BE49-F238E27FC236}">
-                <a16:creationId xmlns:a16="http://schemas.microsoft.com/office/drawing/2014/main" id="{9F6C66BA-CEC1-4E06-A466-190FF9C95A15}"/>
+                <a16:creationId xmlns:a16="http://schemas.microsoft.com/office/drawing/2014/main" id="{8179D66A-471E-4F32-9AE0-03E057D0DE4E}"/>
               </a:ext>
             </a:extLst>
           </p:cNvPr>
@@ -1417,8 +1417,8 @@
         </p:nvSpPr>
         <p:spPr>
           <a:xfrm xmlns:a="http://schemas.openxmlformats.org/drawingml/2006/main">
-            <a:off x="685800" y="1752600"/>
-            <a:ext cx="7810500" cy="1314450"/>
+            <a:off x="685800" y="2809875"/>
+            <a:ext cx="10820400" cy="2190750"/>
           </a:xfrm>
           <a:prstGeom xmlns:a="http://schemas.openxmlformats.org/drawingml/2006/main" prst="rect">
             <a:avLst/>
@@ -1436,12 +1436,12 @@
           <a:p xmlns:a="http://schemas.openxmlformats.org/drawingml/2006/main">
             <a:pPr>
               <a:lnSpc>
-                <a:spcPct val="118000"/>
+                <a:spcPct val="115000"/>
               </a:lnSpc>
               <a:buNone/>
-              <a:defRPr sz="3150" b="1">
-                <a:solidFill>
-                  <a:srgbClr val="126C97"/>
+              <a:defRPr sz="5700" b="1">
+                <a:solidFill>
+                  <a:srgbClr val="111111"/>
                 </a:solidFill>
                 <a:latin typeface="Liberation Sans"/>
                 <a:ea typeface="Liberation Sans"/>
@@ -1449,60 +1449,26 @@
               </a:defRPr>
             </a:pPr>
             <a:r>
-              <a:rPr sz="3150" b="1">
-                <a:solidFill>
-                  <a:srgbClr val="126C97"/>
+              <a:rPr sz="5700" b="1">
+                <a:solidFill>
+                  <a:srgbClr val="111111"/>
                 </a:solidFill>
                 <a:latin typeface="Liberation Sans"/>
                 <a:ea typeface="Liberation Sans"/>
                 <a:cs typeface="Liberation Sans"/>
               </a:rPr>
-              <a:t>Software pays for a fresh physical check.</a:t>
-            </a:r>
-          </a:p>
-        </p:txBody>
-      </p:sp>
-      <p:sp>
-        <p:nvSpPr>
-          <p:cNvPr id="3" name="">
-            <a:extLst xmlns:a="http://schemas.openxmlformats.org/drawingml/2006/main">
-              <a:ext uri="{FF2B5EF4-FFF2-40B4-BE49-F238E27FC236}">
-                <a16:creationId xmlns:a16="http://schemas.microsoft.com/office/drawing/2014/main" id="{87EE48BF-3467-4654-AF69-8F6ECAE1E0FB}"/>
-              </a:ext>
-            </a:extLst>
-          </p:cNvPr>
-          <p:cNvSpPr>
-            <a:spLocks xmlns:a="http://schemas.openxmlformats.org/drawingml/2006/main" noGrp="1"/>
-          </p:cNvSpPr>
-          <p:nvPr/>
-        </p:nvSpPr>
-        <p:spPr>
-          <a:xfrm xmlns:a="http://schemas.openxmlformats.org/drawingml/2006/main">
-            <a:off x="685800" y="3333750"/>
-            <a:ext cx="8096250" cy="1409700"/>
-          </a:xfrm>
-          <a:prstGeom xmlns:a="http://schemas.openxmlformats.org/drawingml/2006/main" prst="rect">
-            <a:avLst/>
-          </a:prstGeom>
-          <a:noFill xmlns:a="http://schemas.openxmlformats.org/drawingml/2006/main"/>
-          <a:ln xmlns:a="http://schemas.openxmlformats.org/drawingml/2006/main" w="0">
-            <a:noFill/>
-          </a:ln>
-        </p:spPr>
-        <p:txBody>
-          <a:bodyPr xmlns:a="http://schemas.openxmlformats.org/drawingml/2006/main" lIns="0" tIns="0" rIns="0" bIns="0" anchor="t">
-            <a:noAutofit/>
-          </a:bodyPr>
-          <a:lstStyle xmlns:a="http://schemas.openxmlformats.org/drawingml/2006/main"/>
+              <a:t>BUY FRESH READINGS</a:t>
+            </a:r>
+          </a:p>
           <a:p xmlns:a="http://schemas.openxmlformats.org/drawingml/2006/main">
             <a:pPr>
               <a:lnSpc>
-                <a:spcPct val="118000"/>
+                <a:spcPct val="115000"/>
               </a:lnSpc>
               <a:buNone/>
-              <a:defRPr sz="2250" b="0">
-                <a:solidFill>
-                  <a:srgbClr val="17364D"/>
+              <a:defRPr sz="5700" b="1">
+                <a:solidFill>
+                  <a:srgbClr val="111111"/>
                 </a:solidFill>
                 <a:latin typeface="Liberation Sans"/>
                 <a:ea typeface="Liberation Sans"/>
@@ -1510,159 +1476,15 @@
               </a:defRPr>
             </a:pPr>
             <a:r>
-              <a:rPr sz="2250" b="0">
-                <a:solidFill>
-                  <a:srgbClr val="17364D"/>
+              <a:rPr sz="5700" b="1">
+                <a:solidFill>
+                  <a:srgbClr val="111111"/>
                 </a:solidFill>
                 <a:latin typeface="Liberation Sans"/>
                 <a:ea typeface="Liberation Sans"/>
                 <a:cs typeface="Liberation Sans"/>
               </a:rPr>
-              <a:t>The device signs its answer. The buyer verifies who answered and whether the answer is still fresh.</a:t>
-            </a:r>
-          </a:p>
-        </p:txBody>
-      </p:sp>
-      <p:sp>
-        <p:nvSpPr>
-          <p:cNvPr id="4" name="">
-            <a:extLst xmlns:a="http://schemas.openxmlformats.org/drawingml/2006/main">
-              <a:ext uri="{FF2B5EF4-FFF2-40B4-BE49-F238E27FC236}">
-                <a16:creationId xmlns:a16="http://schemas.microsoft.com/office/drawing/2014/main" id="{A514202E-96DB-4A1D-8BB1-1487138184E8}"/>
-              </a:ext>
-            </a:extLst>
-          </p:cNvPr>
-          <p:cNvSpPr>
-            <a:spLocks xmlns:a="http://schemas.openxmlformats.org/drawingml/2006/main" noGrp="1"/>
-          </p:cNvSpPr>
-          <p:nvPr/>
-        </p:nvSpPr>
-        <p:spPr>
-          <a:xfrm xmlns:a="http://schemas.openxmlformats.org/drawingml/2006/main">
-            <a:off x="685800" y="5257800"/>
-            <a:ext cx="8572500" cy="419100"/>
-          </a:xfrm>
-          <a:prstGeom xmlns:a="http://schemas.openxmlformats.org/drawingml/2006/main" prst="rect">
-            <a:avLst/>
-          </a:prstGeom>
-          <a:noFill xmlns:a="http://schemas.openxmlformats.org/drawingml/2006/main"/>
-          <a:ln xmlns:a="http://schemas.openxmlformats.org/drawingml/2006/main" w="0">
-            <a:noFill/>
-          </a:ln>
-        </p:spPr>
-        <p:txBody>
-          <a:bodyPr xmlns:a="http://schemas.openxmlformats.org/drawingml/2006/main" lIns="0" tIns="0" rIns="0" bIns="0" anchor="t">
-            <a:noAutofit/>
-          </a:bodyPr>
-          <a:lstStyle xmlns:a="http://schemas.openxmlformats.org/drawingml/2006/main"/>
-          <a:p xmlns:a="http://schemas.openxmlformats.org/drawingml/2006/main">
-            <a:pPr>
-              <a:lnSpc>
-                <a:spcPct val="118000"/>
-              </a:lnSpc>
-              <a:buNone/>
-              <a:defRPr sz="1725" b="0">
-                <a:solidFill>
-                  <a:srgbClr val="536D80"/>
-                </a:solidFill>
-                <a:latin typeface="Liberation Sans"/>
-                <a:ea typeface="Liberation Sans"/>
-                <a:cs typeface="Liberation Sans"/>
-              </a:defRPr>
-            </a:pPr>
-            <a:r>
-              <a:rPr sz="1725" b="0">
-                <a:solidFill>
-                  <a:srgbClr val="536D80"/>
-                </a:solidFill>
-                <a:latin typeface="Liberation Sans"/>
-                <a:ea typeface="Liberation Sans"/>
-                <a:cs typeface="Liberation Sans"/>
-              </a:rPr>
-              <a:t>Working prototype: ESP32-C6 and Solana Devnet.</a:t>
-            </a:r>
-          </a:p>
-        </p:txBody>
-      </p:sp>
-      <p:pic>
-        <p:nvPicPr>
-          <p:cNvPr id="11" name=""/>
-          <p:cNvPicPr>
-            <a:picLocks xmlns:a="http://schemas.openxmlformats.org/drawingml/2006/main" noChangeAspect="1"/>
-          </p:cNvPicPr>
-          <p:nvPr/>
-        </p:nvPicPr>
-        <p:blipFill>
-          <a:blip xmlns:r="http://schemas.openxmlformats.org/officeDocument/2006/relationships" xmlns:a="http://schemas.openxmlformats.org/drawingml/2006/main" r:embed="Rce9f1a99adde4235"/>
-          <a:stretch xmlns:a="http://schemas.openxmlformats.org/drawingml/2006/main"/>
-        </p:blipFill>
-        <p:spPr>
-          <a:xfrm xmlns:a="http://schemas.openxmlformats.org/drawingml/2006/main">
-            <a:off x="9144000" y="2000250"/>
-            <a:ext cx="2381250" cy="2381250"/>
-          </a:xfrm>
-          <a:prstGeom xmlns:a="http://schemas.openxmlformats.org/drawingml/2006/main" prst="rect">
-            <a:avLst/>
-          </a:prstGeom>
-        </p:spPr>
-      </p:pic>
-      <p:sp>
-        <p:nvSpPr>
-          <p:cNvPr id="6" name="">
-            <a:extLst xmlns:a="http://schemas.openxmlformats.org/drawingml/2006/main">
-              <a:ext uri="{FF2B5EF4-FFF2-40B4-BE49-F238E27FC236}">
-                <a16:creationId xmlns:a16="http://schemas.microsoft.com/office/drawing/2014/main" id="{CC164124-A2BF-46C2-B731-ACE2E8C84775}"/>
-              </a:ext>
-            </a:extLst>
-          </p:cNvPr>
-          <p:cNvSpPr>
-            <a:spLocks xmlns:a="http://schemas.openxmlformats.org/drawingml/2006/main" noGrp="1"/>
-          </p:cNvSpPr>
-          <p:nvPr/>
-        </p:nvSpPr>
-        <p:spPr>
-          <a:xfrm xmlns:a="http://schemas.openxmlformats.org/drawingml/2006/main">
-            <a:off x="685800" y="6276975"/>
-            <a:ext cx="10820400" cy="419100"/>
-          </a:xfrm>
-          <a:prstGeom xmlns:a="http://schemas.openxmlformats.org/drawingml/2006/main" prst="rect">
-            <a:avLst/>
-          </a:prstGeom>
-          <a:noFill xmlns:a="http://schemas.openxmlformats.org/drawingml/2006/main"/>
-          <a:ln xmlns:a="http://schemas.openxmlformats.org/drawingml/2006/main" w="0">
-            <a:noFill/>
-          </a:ln>
-        </p:spPr>
-        <p:txBody>
-          <a:bodyPr xmlns:a="http://schemas.openxmlformats.org/drawingml/2006/main" lIns="0" tIns="0" rIns="0" bIns="0" anchor="t">
-            <a:noAutofit/>
-          </a:bodyPr>
-          <a:lstStyle xmlns:a="http://schemas.openxmlformats.org/drawingml/2006/main"/>
-          <a:p xmlns:a="http://schemas.openxmlformats.org/drawingml/2006/main">
-            <a:pPr>
-              <a:lnSpc>
-                <a:spcPct val="118000"/>
-              </a:lnSpc>
-              <a:buNone/>
-              <a:defRPr sz="1350" b="0">
-                <a:solidFill>
-                  <a:srgbClr val="536D80"/>
-                </a:solidFill>
-                <a:latin typeface="Liberation Sans"/>
-                <a:ea typeface="Liberation Sans"/>
-                <a:cs typeface="Liberation Sans"/>
-              </a:defRPr>
-            </a:pPr>
-            <a:r>
-              <a:rPr sz="1350" b="0">
-                <a:solidFill>
-                  <a:srgbClr val="536D80"/>
-                </a:solidFill>
-                <a:latin typeface="Liberation Sans"/>
-                <a:ea typeface="Liberation Sans"/>
-                <a:cs typeface="Liberation Sans"/>
-              </a:rPr>
-              <a:t>01 / A signature identifies the claim’s source. Physical truth needs separate controls.</a:t>
+              <a:t>FROM SENSORS</a:t>
             </a:r>
           </a:p>
         </p:txBody>
@@ -1670,7 +1492,7 @@
     </p:spTree>
     <p:extLst>
       <p:ext uri="{BB962C8B-B14F-4D97-AF65-F5344CB8AC3E}">
-        <p14:creationId xmlns:p14="http://schemas.microsoft.com/office/powerpoint/2010/main" val="1400951751"/>
+        <p14:creationId xmlns:p14="http://schemas.microsoft.com/office/powerpoint/2010/main" val="171500543"/>
       </p:ext>
     </p:extLst>
   </p:cSld>
@@ -1683,7 +1505,7 @@
     <p:bg>
       <p:bgPr>
         <a:solidFill xmlns:a="http://schemas.openxmlformats.org/drawingml/2006/main">
-          <a:srgbClr val="F4FAFF"/>
+          <a:srgbClr val="FFFFFF"/>
         </a:solidFill>
       </p:bgPr>
     </p:bg>
@@ -1701,7 +1523,7 @@
           <p:cNvPr id="10" name="">
             <a:extLst xmlns:a="http://schemas.openxmlformats.org/drawingml/2006/main">
               <a:ext uri="{FF2B5EF4-FFF2-40B4-BE49-F238E27FC236}">
-                <a16:creationId xmlns:a16="http://schemas.microsoft.com/office/drawing/2014/main" id="{9626C400-F500-4BB9-A44B-5F491EF4682A}"/>
+                <a16:creationId xmlns:a16="http://schemas.microsoft.com/office/drawing/2014/main" id="{1EFE8D5C-0C7A-4EDB-9B68-CADBC315AEED}"/>
               </a:ext>
             </a:extLst>
           </p:cNvPr>
@@ -1712,8 +1534,8 @@
         </p:nvSpPr>
         <p:spPr>
           <a:xfrm xmlns:a="http://schemas.openxmlformats.org/drawingml/2006/main">
-            <a:off x="685800" y="457200"/>
-            <a:ext cx="10820400" cy="857250"/>
+            <a:off x="685800" y="590550"/>
+            <a:ext cx="10820400" cy="1123950"/>
           </a:xfrm>
           <a:prstGeom xmlns:a="http://schemas.openxmlformats.org/drawingml/2006/main" prst="rect">
             <a:avLst/>
@@ -1731,12 +1553,12 @@
           <a:p xmlns:a="http://schemas.openxmlformats.org/drawingml/2006/main">
             <a:pPr>
               <a:lnSpc>
-                <a:spcPct val="118000"/>
+                <a:spcPct val="115000"/>
               </a:lnSpc>
               <a:buNone/>
-              <a:defRPr sz="3450" b="1">
-                <a:solidFill>
-                  <a:srgbClr val="17364D"/>
+              <a:defRPr sz="3675" b="1">
+                <a:solidFill>
+                  <a:srgbClr val="111111"/>
                 </a:solidFill>
                 <a:latin typeface="Liberation Sans"/>
                 <a:ea typeface="Liberation Sans"/>
@@ -1744,15 +1566,15 @@
               </a:defRPr>
             </a:pPr>
             <a:r>
-              <a:rPr sz="3450" b="1">
-                <a:solidFill>
-                  <a:srgbClr val="17364D"/>
+              <a:rPr sz="3675" b="1">
+                <a:solidFill>
+                  <a:srgbClr val="111111"/>
                 </a:solidFill>
                 <a:latin typeface="Liberation Sans"/>
                 <a:ea typeface="Liberation Sans"/>
                 <a:cs typeface="Liberation Sans"/>
               </a:rPr>
-              <a:t>A remote inspection before a decision</a:t>
+              <a:t>One request, one new reading</a:t>
             </a:r>
           </a:p>
         </p:txBody>
@@ -1762,7 +1584,7 @@
           <p:cNvPr id="2" name="">
             <a:extLst xmlns:a="http://schemas.openxmlformats.org/drawingml/2006/main">
               <a:ext uri="{FF2B5EF4-FFF2-40B4-BE49-F238E27FC236}">
-                <a16:creationId xmlns:a16="http://schemas.microsoft.com/office/drawing/2014/main" id="{347A121C-8D91-46A8-A663-BAA8EB4366AD}"/>
+                <a16:creationId xmlns:a16="http://schemas.microsoft.com/office/drawing/2014/main" id="{8FAC85EC-D51B-47F2-B449-DF69AFD70E3C}"/>
               </a:ext>
             </a:extLst>
           </p:cNvPr>
@@ -1773,8 +1595,8 @@
         </p:nvSpPr>
         <p:spPr>
           <a:xfrm xmlns:a="http://schemas.openxmlformats.org/drawingml/2006/main">
-            <a:off x="685800" y="1809750"/>
-            <a:ext cx="5010150" cy="666750"/>
+            <a:off x="685800" y="2762250"/>
+            <a:ext cx="4000500" cy="523875"/>
           </a:xfrm>
           <a:prstGeom xmlns:a="http://schemas.openxmlformats.org/drawingml/2006/main" prst="rect">
             <a:avLst/>
@@ -1792,12 +1614,12 @@
           <a:p xmlns:a="http://schemas.openxmlformats.org/drawingml/2006/main">
             <a:pPr>
               <a:lnSpc>
-                <a:spcPct val="118000"/>
+                <a:spcPct val="115000"/>
               </a:lnSpc>
               <a:buNone/>
-              <a:defRPr sz="2175" b="1">
-                <a:solidFill>
-                  <a:srgbClr val="126C97"/>
+              <a:defRPr sz="2850" b="1">
+                <a:solidFill>
+                  <a:srgbClr val="111111"/>
                 </a:solidFill>
                 <a:latin typeface="Liberation Sans"/>
                 <a:ea typeface="Liberation Sans"/>
@@ -1805,15 +1627,15 @@
               </a:defRPr>
             </a:pPr>
             <a:r>
-              <a:rPr sz="2175" b="1">
-                <a:solidFill>
-                  <a:srgbClr val="126C97"/>
+              <a:rPr sz="2850" b="1">
+                <a:solidFill>
+                  <a:srgbClr val="111111"/>
                 </a:solidFill>
                 <a:latin typeface="Liberation Sans"/>
                 <a:ea typeface="Liberation Sans"/>
                 <a:cs typeface="Liberation Sans"/>
               </a:rPr>
-              <a:t>Target workflow</a:t>
+              <a:t>Software buyer</a:t>
             </a:r>
           </a:p>
         </p:txBody>
@@ -1823,7 +1645,7 @@
           <p:cNvPr id="3" name="">
             <a:extLst xmlns:a="http://schemas.openxmlformats.org/drawingml/2006/main">
               <a:ext uri="{FF2B5EF4-FFF2-40B4-BE49-F238E27FC236}">
-                <a16:creationId xmlns:a16="http://schemas.microsoft.com/office/drawing/2014/main" id="{D6B07CFF-45EE-4C80-9A47-A90618F96DBA}"/>
+                <a16:creationId xmlns:a16="http://schemas.microsoft.com/office/drawing/2014/main" id="{45DBA91D-C6E1-4188-A6C5-9283E1510A9A}"/>
               </a:ext>
             </a:extLst>
           </p:cNvPr>
@@ -1834,8 +1656,8 @@
         </p:nvSpPr>
         <p:spPr>
           <a:xfrm xmlns:a="http://schemas.openxmlformats.org/drawingml/2006/main">
-            <a:off x="685800" y="2647950"/>
-            <a:ext cx="4895850" cy="1162050"/>
+            <a:off x="685800" y="3333750"/>
+            <a:ext cx="4000500" cy="523875"/>
           </a:xfrm>
           <a:prstGeom xmlns:a="http://schemas.openxmlformats.org/drawingml/2006/main" prst="rect">
             <a:avLst/>
@@ -1853,12 +1675,12 @@
           <a:p xmlns:a="http://schemas.openxmlformats.org/drawingml/2006/main">
             <a:pPr>
               <a:lnSpc>
-                <a:spcPct val="118000"/>
+                <a:spcPct val="115000"/>
               </a:lnSpc>
               <a:buNone/>
-              <a:defRPr sz="2100" b="0">
-                <a:solidFill>
-                  <a:srgbClr val="17364D"/>
+              <a:defRPr sz="1875" b="0">
+                <a:solidFill>
+                  <a:srgbClr val="111111"/>
                 </a:solidFill>
                 <a:latin typeface="Liberation Sans"/>
                 <a:ea typeface="Liberation Sans"/>
@@ -1866,15 +1688,15 @@
               </a:defRPr>
             </a:pPr>
             <a:r>
-              <a:rPr sz="2100" b="0">
-                <a:solidFill>
-                  <a:srgbClr val="17364D"/>
+              <a:rPr sz="1875" b="0">
+                <a:solidFill>
+                  <a:srgbClr val="111111"/>
                 </a:solidFill>
                 <a:latin typeface="Liberation Sans"/>
                 <a:ea typeface="Liberation Sans"/>
                 <a:cs typeface="Liberation Sans"/>
               </a:rPr>
-              <a:t>An operator pays someone to check a physical fact at another site.</a:t>
+              <a:t>Question and budget</a:t>
             </a:r>
           </a:p>
         </p:txBody>
@@ -1884,7 +1706,7 @@
           <p:cNvPr id="4" name="">
             <a:extLst xmlns:a="http://schemas.openxmlformats.org/drawingml/2006/main">
               <a:ext uri="{FF2B5EF4-FFF2-40B4-BE49-F238E27FC236}">
-                <a16:creationId xmlns:a16="http://schemas.microsoft.com/office/drawing/2014/main" id="{A4B86E51-DE71-4915-AF2D-4D20ADCAC2A1}"/>
+                <a16:creationId xmlns:a16="http://schemas.microsoft.com/office/drawing/2014/main" id="{3D3F6296-40C3-4A78-85A0-D543495038C1}"/>
               </a:ext>
             </a:extLst>
           </p:cNvPr>
@@ -1895,8 +1717,8 @@
         </p:nvSpPr>
         <p:spPr>
           <a:xfrm xmlns:a="http://schemas.openxmlformats.org/drawingml/2006/main">
-            <a:off x="685800" y="4000500"/>
-            <a:ext cx="4895850" cy="1295400"/>
+            <a:off x="4572000" y="2600325"/>
+            <a:ext cx="2619375" cy="514350"/>
           </a:xfrm>
           <a:prstGeom xmlns:a="http://schemas.openxmlformats.org/drawingml/2006/main" prst="rect">
             <a:avLst/>
@@ -1914,12 +1736,12 @@
           <a:p xmlns:a="http://schemas.openxmlformats.org/drawingml/2006/main">
             <a:pPr>
               <a:lnSpc>
-                <a:spcPct val="118000"/>
+                <a:spcPct val="115000"/>
               </a:lnSpc>
               <a:buNone/>
-              <a:defRPr sz="2100" b="0">
-                <a:solidFill>
-                  <a:srgbClr val="17364D"/>
+              <a:defRPr sz="1725" b="0">
+                <a:solidFill>
+                  <a:srgbClr val="111111"/>
                 </a:solidFill>
                 <a:latin typeface="Liberation Sans"/>
                 <a:ea typeface="Liberation Sans"/>
@@ -1927,15 +1749,15 @@
               </a:defRPr>
             </a:pPr>
             <a:r>
-              <a:rPr sz="2100" b="0">
-                <a:solidFill>
-                  <a:srgbClr val="17364D"/>
+              <a:rPr sz="1725" b="0">
+                <a:solidFill>
+                  <a:srgbClr val="111111"/>
                 </a:solidFill>
                 <a:latin typeface="Liberation Sans"/>
                 <a:ea typeface="Liberation Sans"/>
                 <a:cs typeface="Liberation Sans"/>
               </a:rPr>
-              <a:t>Its software lacks a reliable answer from an existing API.</a:t>
+              <a:t>Request and payment</a:t>
             </a:r>
           </a:p>
         </p:txBody>
@@ -1945,7 +1767,7 @@
           <p:cNvPr id="5" name="">
             <a:extLst xmlns:a="http://schemas.openxmlformats.org/drawingml/2006/main">
               <a:ext uri="{FF2B5EF4-FFF2-40B4-BE49-F238E27FC236}">
-                <a16:creationId xmlns:a16="http://schemas.microsoft.com/office/drawing/2014/main" id="{C370338D-7AB0-42FE-B2DA-C4E22EA8733F}"/>
+                <a16:creationId xmlns:a16="http://schemas.microsoft.com/office/drawing/2014/main" id="{22339FCC-93E6-4378-8676-FED173C3A20D}"/>
               </a:ext>
             </a:extLst>
           </p:cNvPr>
@@ -1956,8 +1778,8 @@
         </p:nvSpPr>
         <p:spPr>
           <a:xfrm xmlns:a="http://schemas.openxmlformats.org/drawingml/2006/main">
-            <a:off x="6496050" y="1809750"/>
-            <a:ext cx="5010150" cy="666750"/>
+            <a:off x="5334000" y="3114675"/>
+            <a:ext cx="904875" cy="714375"/>
           </a:xfrm>
           <a:prstGeom xmlns:a="http://schemas.openxmlformats.org/drawingml/2006/main" prst="rect">
             <a:avLst/>
@@ -1975,12 +1797,12 @@
           <a:p xmlns:a="http://schemas.openxmlformats.org/drawingml/2006/main">
             <a:pPr>
               <a:lnSpc>
-                <a:spcPct val="118000"/>
+                <a:spcPct val="115000"/>
               </a:lnSpc>
               <a:buNone/>
-              <a:defRPr sz="2175" b="1">
-                <a:solidFill>
-                  <a:srgbClr val="126C97"/>
+              <a:defRPr sz="3900" b="0">
+                <a:solidFill>
+                  <a:srgbClr val="111111"/>
                 </a:solidFill>
                 <a:latin typeface="Liberation Sans"/>
                 <a:ea typeface="Liberation Sans"/>
@@ -1988,15 +1810,15 @@
               </a:defRPr>
             </a:pPr>
             <a:r>
-              <a:rPr sz="2175" b="1">
-                <a:solidFill>
-                  <a:srgbClr val="126C97"/>
+              <a:rPr sz="3900" b="0">
+                <a:solidFill>
+                  <a:srgbClr val="111111"/>
                 </a:solidFill>
                 <a:latin typeface="Liberation Sans"/>
                 <a:ea typeface="Liberation Sans"/>
                 <a:cs typeface="Liberation Sans"/>
               </a:rPr>
-              <a:t>FieldProof proposal</a:t>
+              <a:t>→</a:t>
             </a:r>
           </a:p>
         </p:txBody>
@@ -2006,7 +1828,7 @@
           <p:cNvPr id="6" name="">
             <a:extLst xmlns:a="http://schemas.openxmlformats.org/drawingml/2006/main">
               <a:ext uri="{FF2B5EF4-FFF2-40B4-BE49-F238E27FC236}">
-                <a16:creationId xmlns:a16="http://schemas.microsoft.com/office/drawing/2014/main" id="{B48DD837-1430-4117-BDA6-4520BAADA121}"/>
+                <a16:creationId xmlns:a16="http://schemas.microsoft.com/office/drawing/2014/main" id="{981B916E-0263-46DB-9400-8E8859C10A23}"/>
               </a:ext>
             </a:extLst>
           </p:cNvPr>
@@ -2017,8 +1839,8 @@
         </p:nvSpPr>
         <p:spPr>
           <a:xfrm xmlns:a="http://schemas.openxmlformats.org/drawingml/2006/main">
-            <a:off x="6496050" y="2647950"/>
-            <a:ext cx="4895850" cy="1162050"/>
+            <a:off x="7905750" y="2762250"/>
+            <a:ext cx="3571875" cy="523875"/>
           </a:xfrm>
           <a:prstGeom xmlns:a="http://schemas.openxmlformats.org/drawingml/2006/main" prst="rect">
             <a:avLst/>
@@ -2036,12 +1858,12 @@
           <a:p xmlns:a="http://schemas.openxmlformats.org/drawingml/2006/main">
             <a:pPr>
               <a:lnSpc>
-                <a:spcPct val="118000"/>
+                <a:spcPct val="115000"/>
               </a:lnSpc>
               <a:buNone/>
-              <a:defRPr sz="2100" b="0">
-                <a:solidFill>
-                  <a:srgbClr val="17364D"/>
+              <a:defRPr sz="2850" b="1">
+                <a:solidFill>
+                  <a:srgbClr val="111111"/>
                 </a:solidFill>
                 <a:latin typeface="Liberation Sans"/>
                 <a:ea typeface="Liberation Sans"/>
@@ -2049,15 +1871,15 @@
               </a:defRPr>
             </a:pPr>
             <a:r>
-              <a:rPr sz="2100" b="0">
-                <a:solidFill>
-                  <a:srgbClr val="17364D"/>
+              <a:rPr sz="2850" b="1">
+                <a:solidFill>
+                  <a:srgbClr val="111111"/>
                 </a:solidFill>
                 <a:latin typeface="Liberation Sans"/>
                 <a:ea typeface="Liberation Sans"/>
                 <a:cs typeface="Liberation Sans"/>
               </a:rPr>
-              <a:t>Commission one check from a device already on site.</a:t>
+              <a:t>Device operator</a:t>
             </a:r>
           </a:p>
         </p:txBody>
@@ -2067,7 +1889,7 @@
           <p:cNvPr id="7" name="">
             <a:extLst xmlns:a="http://schemas.openxmlformats.org/drawingml/2006/main">
               <a:ext uri="{FF2B5EF4-FFF2-40B4-BE49-F238E27FC236}">
-                <a16:creationId xmlns:a16="http://schemas.microsoft.com/office/drawing/2014/main" id="{45C897BC-075E-422C-95AD-B6B08EE52B0E}"/>
+                <a16:creationId xmlns:a16="http://schemas.microsoft.com/office/drawing/2014/main" id="{B91B2A95-0B54-4E1E-B32F-A4D4AB4575E3}"/>
               </a:ext>
             </a:extLst>
           </p:cNvPr>
@@ -2078,8 +1900,8 @@
         </p:nvSpPr>
         <p:spPr>
           <a:xfrm xmlns:a="http://schemas.openxmlformats.org/drawingml/2006/main">
-            <a:off x="6496050" y="4000500"/>
-            <a:ext cx="4895850" cy="1295400"/>
+            <a:off x="7905750" y="3333750"/>
+            <a:ext cx="3571875" cy="523875"/>
           </a:xfrm>
           <a:prstGeom xmlns:a="http://schemas.openxmlformats.org/drawingml/2006/main" prst="rect">
             <a:avLst/>
@@ -2097,12 +1919,12 @@
           <a:p xmlns:a="http://schemas.openxmlformats.org/drawingml/2006/main">
             <a:pPr>
               <a:lnSpc>
-                <a:spcPct val="118000"/>
+                <a:spcPct val="115000"/>
               </a:lnSpc>
               <a:buNone/>
-              <a:defRPr sz="2100" b="0">
-                <a:solidFill>
-                  <a:srgbClr val="17364D"/>
+              <a:defRPr sz="1875" b="0">
+                <a:solidFill>
+                  <a:srgbClr val="111111"/>
                 </a:solidFill>
                 <a:latin typeface="Liberation Sans"/>
                 <a:ea typeface="Liberation Sans"/>
@@ -2110,15 +1932,15 @@
               </a:defRPr>
             </a:pPr>
             <a:r>
-              <a:rPr sz="2100" b="0">
-                <a:solidFill>
-                  <a:srgbClr val="17364D"/>
+              <a:rPr sz="1875" b="0">
+                <a:solidFill>
+                  <a:srgbClr val="111111"/>
                 </a:solidFill>
                 <a:latin typeface="Liberation Sans"/>
                 <a:ea typeface="Liberation Sans"/>
                 <a:cs typeface="Liberation Sans"/>
               </a:rPr>
-              <a:t>Get a new answer tied to that request.</a:t>
+              <a:t>New measurement</a:t>
             </a:r>
           </a:p>
         </p:txBody>
@@ -2128,7 +1950,7 @@
           <p:cNvPr id="8" name="">
             <a:extLst xmlns:a="http://schemas.openxmlformats.org/drawingml/2006/main">
               <a:ext uri="{FF2B5EF4-FFF2-40B4-BE49-F238E27FC236}">
-                <a16:creationId xmlns:a16="http://schemas.microsoft.com/office/drawing/2014/main" id="{4DE72AA6-164A-4BBD-90F4-0CC3FE4DD242}"/>
+                <a16:creationId xmlns:a16="http://schemas.microsoft.com/office/drawing/2014/main" id="{1ACCFC56-B1FF-41D0-8ED8-A17F569AE311}"/>
               </a:ext>
             </a:extLst>
           </p:cNvPr>
@@ -2139,8 +1961,8 @@
         </p:nvSpPr>
         <p:spPr>
           <a:xfrm xmlns:a="http://schemas.openxmlformats.org/drawingml/2006/main">
-            <a:off x="685800" y="5505450"/>
-            <a:ext cx="10820400" cy="590550"/>
+            <a:off x="685800" y="4572000"/>
+            <a:ext cx="10820400" cy="619125"/>
           </a:xfrm>
           <a:prstGeom xmlns:a="http://schemas.openxmlformats.org/drawingml/2006/main" prst="rect">
             <a:avLst/>
@@ -2158,12 +1980,12 @@
           <a:p xmlns:a="http://schemas.openxmlformats.org/drawingml/2006/main">
             <a:pPr>
               <a:lnSpc>
-                <a:spcPct val="118000"/>
+                <a:spcPct val="115000"/>
               </a:lnSpc>
               <a:buNone/>
-              <a:defRPr sz="1875" b="0">
-                <a:solidFill>
-                  <a:srgbClr val="126C97"/>
+              <a:defRPr sz="2400" b="0">
+                <a:solidFill>
+                  <a:srgbClr val="111111"/>
                 </a:solidFill>
                 <a:latin typeface="Liberation Sans"/>
                 <a:ea typeface="Liberation Sans"/>
@@ -2171,15 +1993,15 @@
               </a:defRPr>
             </a:pPr>
             <a:r>
-              <a:rPr sz="1875" b="0">
-                <a:solidFill>
-                  <a:srgbClr val="126C97"/>
+              <a:rPr sz="2400" b="0">
+                <a:solidFill>
+                  <a:srgbClr val="111111"/>
                 </a:solidFill>
                 <a:latin typeface="Liberation Sans"/>
                 <a:ea typeface="Liberation Sans"/>
                 <a:cs typeface="Liberation Sans"/>
               </a:rPr>
-              <a:t>Value test: does the check replace a manual check or change a costly decision?</a:t>
+              <a:t>A signed answer returns to the buyer.</a:t>
             </a:r>
           </a:p>
         </p:txBody>
@@ -2189,7 +2011,7 @@
           <p:cNvPr id="9" name="">
             <a:extLst xmlns:a="http://schemas.openxmlformats.org/drawingml/2006/main">
               <a:ext uri="{FF2B5EF4-FFF2-40B4-BE49-F238E27FC236}">
-                <a16:creationId xmlns:a16="http://schemas.microsoft.com/office/drawing/2014/main" id="{86B2106D-EA2A-4163-AB58-A28AD8458EE3}"/>
+                <a16:creationId xmlns:a16="http://schemas.microsoft.com/office/drawing/2014/main" id="{EA8C6E58-C6AD-4C71-9E82-2566CEEFF812}"/>
               </a:ext>
             </a:extLst>
           </p:cNvPr>
@@ -2200,8 +2022,8 @@
         </p:nvSpPr>
         <p:spPr>
           <a:xfrm xmlns:a="http://schemas.openxmlformats.org/drawingml/2006/main">
-            <a:off x="685800" y="6276975"/>
-            <a:ext cx="10820400" cy="419100"/>
+            <a:off x="685800" y="5791200"/>
+            <a:ext cx="10820400" cy="571500"/>
           </a:xfrm>
           <a:prstGeom xmlns:a="http://schemas.openxmlformats.org/drawingml/2006/main" prst="rect">
             <a:avLst/>
@@ -2219,12 +2041,12 @@
           <a:p xmlns:a="http://schemas.openxmlformats.org/drawingml/2006/main">
             <a:pPr>
               <a:lnSpc>
-                <a:spcPct val="118000"/>
+                <a:spcPct val="115000"/>
               </a:lnSpc>
               <a:buNone/>
-              <a:defRPr sz="1350" b="0">
-                <a:solidFill>
-                  <a:srgbClr val="536D80"/>
+              <a:defRPr sz="1575" b="0">
+                <a:solidFill>
+                  <a:srgbClr val="555555"/>
                 </a:solidFill>
                 <a:latin typeface="Liberation Sans"/>
                 <a:ea typeface="Liberation Sans"/>
@@ -2232,15 +2054,15 @@
               </a:defRPr>
             </a:pPr>
             <a:r>
-              <a:rPr sz="1350" b="0">
-                <a:solidFill>
-                  <a:srgbClr val="536D80"/>
+              <a:rPr sz="1575" b="0">
+                <a:solidFill>
+                  <a:srgbClr val="555555"/>
                 </a:solidFill>
                 <a:latin typeface="Liberation Sans"/>
                 <a:ea typeface="Liberation Sans"/>
                 <a:cs typeface="Liberation Sans"/>
               </a:rPr>
-              <a:t>02 / Buyer and pricing remain hypotheses. An existing reliable API can be sufficient.</a:t>
+              <a:t>A common workflow across different device owners is the product hypothesis.</a:t>
             </a:r>
           </a:p>
         </p:txBody>
@@ -2248,7 +2070,7 @@
     </p:spTree>
     <p:extLst>
       <p:ext uri="{BB962C8B-B14F-4D97-AF65-F5344CB8AC3E}">
-        <p14:creationId xmlns:p14="http://schemas.microsoft.com/office/powerpoint/2010/main" val="1041157775"/>
+        <p14:creationId xmlns:p14="http://schemas.microsoft.com/office/powerpoint/2010/main" val="2126693891"/>
       </p:ext>
     </p:extLst>
   </p:cSld>
@@ -2261,7 +2083,7 @@
     <p:bg>
       <p:bgPr>
         <a:solidFill xmlns:a="http://schemas.openxmlformats.org/drawingml/2006/main">
-          <a:srgbClr val="F4FAFF"/>
+          <a:srgbClr val="FFFFFF"/>
         </a:solidFill>
       </p:bgPr>
     </p:bg>
@@ -2276,10 +2098,10 @@
       </p:grpSpPr>
       <p:sp>
         <p:nvSpPr>
-          <p:cNvPr id="11" name="">
+          <p:cNvPr id="14" name="">
             <a:extLst xmlns:a="http://schemas.openxmlformats.org/drawingml/2006/main">
               <a:ext uri="{FF2B5EF4-FFF2-40B4-BE49-F238E27FC236}">
-                <a16:creationId xmlns:a16="http://schemas.microsoft.com/office/drawing/2014/main" id="{655C990A-8EF5-4541-8653-2CB0B5F7A70C}"/>
+                <a16:creationId xmlns:a16="http://schemas.microsoft.com/office/drawing/2014/main" id="{6B93A88D-F65A-4738-9ED7-09A3B56EF016}"/>
               </a:ext>
             </a:extLst>
           </p:cNvPr>
@@ -2290,8 +2112,8 @@
         </p:nvSpPr>
         <p:spPr>
           <a:xfrm xmlns:a="http://schemas.openxmlformats.org/drawingml/2006/main">
-            <a:off x="685800" y="457200"/>
-            <a:ext cx="10820400" cy="857250"/>
+            <a:off x="685800" y="590550"/>
+            <a:ext cx="10820400" cy="1123950"/>
           </a:xfrm>
           <a:prstGeom xmlns:a="http://schemas.openxmlformats.org/drawingml/2006/main" prst="rect">
             <a:avLst/>
@@ -2309,12 +2131,12 @@
           <a:p xmlns:a="http://schemas.openxmlformats.org/drawingml/2006/main">
             <a:pPr>
               <a:lnSpc>
-                <a:spcPct val="118000"/>
+                <a:spcPct val="115000"/>
               </a:lnSpc>
               <a:buNone/>
-              <a:defRPr sz="3450" b="1">
-                <a:solidFill>
-                  <a:srgbClr val="17364D"/>
+              <a:defRPr sz="3675" b="1">
+                <a:solidFill>
+                  <a:srgbClr val="111111"/>
                 </a:solidFill>
                 <a:latin typeface="Liberation Sans"/>
                 <a:ea typeface="Liberation Sans"/>
@@ -2322,25 +2144,47 @@
               </a:defRPr>
             </a:pPr>
             <a:r>
-              <a:rPr sz="3450" b="1">
-                <a:solidFill>
-                  <a:srgbClr val="17364D"/>
+              <a:rPr sz="3675" b="1">
+                <a:solidFill>
+                  <a:srgbClr val="111111"/>
                 </a:solidFill>
                 <a:latin typeface="Liberation Sans"/>
                 <a:ea typeface="Liberation Sans"/>
                 <a:cs typeface="Liberation Sans"/>
               </a:rPr>
-              <a:t>What the prototype does</a:t>
-            </a:r>
-          </a:p>
-        </p:txBody>
-      </p:sp>
-      <p:sp>
-        <p:nvSpPr>
-          <p:cNvPr id="2" name="">
+              <a:t>A working three-device prototype</a:t>
+            </a:r>
+          </a:p>
+        </p:txBody>
+      </p:sp>
+      <p:pic>
+        <p:nvPicPr>
+          <p:cNvPr id="15" name=""/>
+          <p:cNvPicPr>
+            <a:picLocks xmlns:a="http://schemas.openxmlformats.org/drawingml/2006/main" noChangeAspect="1"/>
+          </p:cNvPicPr>
+          <p:nvPr/>
+        </p:nvPicPr>
+        <p:blipFill>
+          <a:blip xmlns:r="http://schemas.openxmlformats.org/officeDocument/2006/relationships" xmlns:a="http://schemas.openxmlformats.org/drawingml/2006/main" r:embed="Rb662421ab2fb429e"/>
+          <a:stretch xmlns:a="http://schemas.openxmlformats.org/drawingml/2006/main"/>
+        </p:blipFill>
+        <p:spPr>
+          <a:xfrm xmlns:a="http://schemas.openxmlformats.org/drawingml/2006/main">
+            <a:off x="685800" y="1878211"/>
+            <a:ext cx="3905250" cy="2196703"/>
+          </a:xfrm>
+          <a:prstGeom xmlns:a="http://schemas.openxmlformats.org/drawingml/2006/main" prst="rect">
+            <a:avLst/>
+          </a:prstGeom>
+        </p:spPr>
+      </p:pic>
+      <p:sp>
+        <p:nvSpPr>
+          <p:cNvPr id="3" name="">
             <a:extLst xmlns:a="http://schemas.openxmlformats.org/drawingml/2006/main">
               <a:ext uri="{FF2B5EF4-FFF2-40B4-BE49-F238E27FC236}">
-                <a16:creationId xmlns:a16="http://schemas.microsoft.com/office/drawing/2014/main" id="{C939EADB-D828-4CB1-815E-B164D3570066}"/>
+                <a16:creationId xmlns:a16="http://schemas.microsoft.com/office/drawing/2014/main" id="{60FE2999-A2AC-4FB0-8947-8FDDD1A4C774}"/>
               </a:ext>
             </a:extLst>
           </p:cNvPr>
@@ -2351,8 +2195,8 @@
         </p:nvSpPr>
         <p:spPr>
           <a:xfrm xmlns:a="http://schemas.openxmlformats.org/drawingml/2006/main">
-            <a:off x="685800" y="1790700"/>
-            <a:ext cx="5010150" cy="514350"/>
+            <a:off x="685800" y="4210050"/>
+            <a:ext cx="4095750" cy="762000"/>
           </a:xfrm>
           <a:prstGeom xmlns:a="http://schemas.openxmlformats.org/drawingml/2006/main" prst="rect">
             <a:avLst/>
@@ -2370,12 +2214,12 @@
           <a:p xmlns:a="http://schemas.openxmlformats.org/drawingml/2006/main">
             <a:pPr>
               <a:lnSpc>
-                <a:spcPct val="118000"/>
+                <a:spcPct val="115000"/>
               </a:lnSpc>
               <a:buNone/>
-              <a:defRPr sz="2250" b="1">
-                <a:solidFill>
-                  <a:srgbClr val="126C97"/>
+              <a:defRPr sz="1575" b="0">
+                <a:solidFill>
+                  <a:srgbClr val="555555"/>
                 </a:solidFill>
                 <a:latin typeface="Liberation Sans"/>
                 <a:ea typeface="Liberation Sans"/>
@@ -2383,25 +2227,25 @@
               </a:defRPr>
             </a:pPr>
             <a:r>
-              <a:rPr sz="2250" b="1">
-                <a:solidFill>
-                  <a:srgbClr val="126C97"/>
+              <a:rPr sz="1575" b="0">
+                <a:solidFill>
+                  <a:srgbClr val="555555"/>
                 </a:solidFill>
                 <a:latin typeface="Liberation Sans"/>
                 <a:ea typeface="Liberation Sans"/>
                 <a:cs typeface="Liberation Sans"/>
               </a:rPr>
-              <a:t>1. Request a check</a:t>
-            </a:r>
-          </a:p>
-        </p:txBody>
-      </p:sp>
-      <p:sp>
-        <p:nvSpPr>
-          <p:cNvPr id="3" name="">
+              <a:t>ESP32 contact input. BOOT represents the contact.</a:t>
+            </a:r>
+          </a:p>
+        </p:txBody>
+      </p:sp>
+      <p:sp>
+        <p:nvSpPr>
+          <p:cNvPr id="4" name="">
             <a:extLst xmlns:a="http://schemas.openxmlformats.org/drawingml/2006/main">
               <a:ext uri="{FF2B5EF4-FFF2-40B4-BE49-F238E27FC236}">
-                <a16:creationId xmlns:a16="http://schemas.microsoft.com/office/drawing/2014/main" id="{D72B06EA-86A2-4759-B497-D83D8F4BC767}"/>
+                <a16:creationId xmlns:a16="http://schemas.microsoft.com/office/drawing/2014/main" id="{EBFEC9CF-DE00-4EAA-9A69-2B0B182A0DC9}"/>
               </a:ext>
             </a:extLst>
           </p:cNvPr>
@@ -2412,8 +2256,8 @@
         </p:nvSpPr>
         <p:spPr>
           <a:xfrm xmlns:a="http://schemas.openxmlformats.org/drawingml/2006/main">
-            <a:off x="685800" y="2409825"/>
-            <a:ext cx="4953000" cy="1257300"/>
+            <a:off x="5219700" y="1838325"/>
+            <a:ext cx="6191250" cy="361950"/>
           </a:xfrm>
           <a:prstGeom xmlns:a="http://schemas.openxmlformats.org/drawingml/2006/main" prst="rect">
             <a:avLst/>
@@ -2431,12 +2275,12 @@
           <a:p xmlns:a="http://schemas.openxmlformats.org/drawingml/2006/main">
             <a:pPr>
               <a:lnSpc>
-                <a:spcPct val="118000"/>
+                <a:spcPct val="115000"/>
               </a:lnSpc>
               <a:buNone/>
-              <a:defRPr sz="2025" b="0">
-                <a:solidFill>
-                  <a:srgbClr val="17364D"/>
+              <a:defRPr sz="2025" b="1">
+                <a:solidFill>
+                  <a:srgbClr val="111111"/>
                 </a:solidFill>
                 <a:latin typeface="Liberation Sans"/>
                 <a:ea typeface="Liberation Sans"/>
@@ -2444,25 +2288,25 @@
               </a:defRPr>
             </a:pPr>
             <a:r>
-              <a:rPr sz="2025" b="0">
-                <a:solidFill>
-                  <a:srgbClr val="17364D"/>
+              <a:rPr sz="2025" b="1">
+                <a:solidFill>
+                  <a:srgbClr val="111111"/>
                 </a:solidFill>
                 <a:latin typeface="Liberation Sans"/>
                 <a:ea typeface="Liberation Sans"/>
                 <a:cs typeface="Liberation Sans"/>
               </a:rPr>
-              <a:t>The buyer fixes the contact question, device key, price, and ten-second age limit.</a:t>
-            </a:r>
-          </a:p>
-        </p:txBody>
-      </p:sp>
-      <p:sp>
-        <p:nvSpPr>
-          <p:cNvPr id="4" name="">
+              <a:t>ESP32</a:t>
+            </a:r>
+          </a:p>
+        </p:txBody>
+      </p:sp>
+      <p:sp>
+        <p:nvSpPr>
+          <p:cNvPr id="5" name="">
             <a:extLst xmlns:a="http://schemas.openxmlformats.org/drawingml/2006/main">
               <a:ext uri="{FF2B5EF4-FFF2-40B4-BE49-F238E27FC236}">
-                <a16:creationId xmlns:a16="http://schemas.microsoft.com/office/drawing/2014/main" id="{06E96C98-6CE3-4B49-A17F-92177986D982}"/>
+                <a16:creationId xmlns:a16="http://schemas.microsoft.com/office/drawing/2014/main" id="{D3C8118A-DFBE-4712-ADC8-CC89117EE287}"/>
               </a:ext>
             </a:extLst>
           </p:cNvPr>
@@ -2473,8 +2317,8 @@
         </p:nvSpPr>
         <p:spPr>
           <a:xfrm xmlns:a="http://schemas.openxmlformats.org/drawingml/2006/main">
-            <a:off x="6496050" y="1790700"/>
-            <a:ext cx="5010150" cy="514350"/>
+            <a:off x="5219700" y="2209800"/>
+            <a:ext cx="6191250" cy="466725"/>
           </a:xfrm>
           <a:prstGeom xmlns:a="http://schemas.openxmlformats.org/drawingml/2006/main" prst="rect">
             <a:avLst/>
@@ -2492,12 +2336,12 @@
           <a:p xmlns:a="http://schemas.openxmlformats.org/drawingml/2006/main">
             <a:pPr>
               <a:lnSpc>
-                <a:spcPct val="118000"/>
+                <a:spcPct val="115000"/>
               </a:lnSpc>
               <a:buNone/>
-              <a:defRPr sz="2250" b="1">
-                <a:solidFill>
-                  <a:srgbClr val="126C97"/>
+              <a:defRPr sz="2175" b="0">
+                <a:solidFill>
+                  <a:srgbClr val="111111"/>
                 </a:solidFill>
                 <a:latin typeface="Liberation Sans"/>
                 <a:ea typeface="Liberation Sans"/>
@@ -2505,25 +2349,25 @@
               </a:defRPr>
             </a:pPr>
             <a:r>
-              <a:rPr sz="2250" b="1">
-                <a:solidFill>
-                  <a:srgbClr val="126C97"/>
+              <a:rPr sz="2175" b="0">
+                <a:solidFill>
+                  <a:srgbClr val="111111"/>
                 </a:solidFill>
                 <a:latin typeface="Liberation Sans"/>
                 <a:ea typeface="Liberation Sans"/>
                 <a:cs typeface="Liberation Sans"/>
               </a:rPr>
-              <a:t>2. Pay the operator</a:t>
-            </a:r>
-          </a:p>
-        </p:txBody>
-      </p:sp>
-      <p:sp>
-        <p:nvSpPr>
-          <p:cNvPr id="5" name="">
+              <a:t>Measures and signs</a:t>
+            </a:r>
+          </a:p>
+        </p:txBody>
+      </p:sp>
+      <p:sp>
+        <p:nvSpPr>
+          <p:cNvPr id="6" name="">
             <a:extLst xmlns:a="http://schemas.openxmlformats.org/drawingml/2006/main">
               <a:ext uri="{FF2B5EF4-FFF2-40B4-BE49-F238E27FC236}">
-                <a16:creationId xmlns:a16="http://schemas.microsoft.com/office/drawing/2014/main" id="{6E227CF9-EA9A-433D-8468-51B1709D845E}"/>
+                <a16:creationId xmlns:a16="http://schemas.microsoft.com/office/drawing/2014/main" id="{E4F936DB-D85D-4A73-9FFD-D3291DB50EEE}"/>
               </a:ext>
             </a:extLst>
           </p:cNvPr>
@@ -2534,8 +2378,8 @@
         </p:nvSpPr>
         <p:spPr>
           <a:xfrm xmlns:a="http://schemas.openxmlformats.org/drawingml/2006/main">
-            <a:off x="6496050" y="2409825"/>
-            <a:ext cx="4953000" cy="1257300"/>
+            <a:off x="5219700" y="2781300"/>
+            <a:ext cx="6191250" cy="361950"/>
           </a:xfrm>
           <a:prstGeom xmlns:a="http://schemas.openxmlformats.org/drawingml/2006/main" prst="rect">
             <a:avLst/>
@@ -2553,12 +2397,12 @@
           <a:p xmlns:a="http://schemas.openxmlformats.org/drawingml/2006/main">
             <a:pPr>
               <a:lnSpc>
-                <a:spcPct val="118000"/>
+                <a:spcPct val="115000"/>
               </a:lnSpc>
               <a:buNone/>
-              <a:defRPr sz="2025" b="0">
-                <a:solidFill>
-                  <a:srgbClr val="17364D"/>
+              <a:defRPr sz="2025" b="1">
+                <a:solidFill>
+                  <a:srgbClr val="111111"/>
                 </a:solidFill>
                 <a:latin typeface="Liberation Sans"/>
                 <a:ea typeface="Liberation Sans"/>
@@ -2566,25 +2410,25 @@
               </a:defRPr>
             </a:pPr>
             <a:r>
-              <a:rPr sz="2025" b="0">
-                <a:solidFill>
-                  <a:srgbClr val="17364D"/>
+              <a:rPr sz="2025" b="1">
+                <a:solidFill>
+                  <a:srgbClr val="111111"/>
                 </a:solidFill>
                 <a:latin typeface="Liberation Sans"/>
                 <a:ea typeface="Liberation Sans"/>
                 <a:cs typeface="Liberation Sans"/>
               </a:rPr>
-              <a:t>Solana x402 settles 0.001 test USDC before measurement.</a:t>
-            </a:r>
-          </a:p>
-        </p:txBody>
-      </p:sp>
-      <p:sp>
-        <p:nvSpPr>
-          <p:cNvPr id="6" name="">
+              <a:t>Laptop</a:t>
+            </a:r>
+          </a:p>
+        </p:txBody>
+      </p:sp>
+      <p:sp>
+        <p:nvSpPr>
+          <p:cNvPr id="7" name="">
             <a:extLst xmlns:a="http://schemas.openxmlformats.org/drawingml/2006/main">
               <a:ext uri="{FF2B5EF4-FFF2-40B4-BE49-F238E27FC236}">
-                <a16:creationId xmlns:a16="http://schemas.microsoft.com/office/drawing/2014/main" id="{14545F58-6ABB-4C80-873C-E773E95D3280}"/>
+                <a16:creationId xmlns:a16="http://schemas.microsoft.com/office/drawing/2014/main" id="{2D3EECA0-3BB1-43D5-BCE3-B77975A2F35D}"/>
               </a:ext>
             </a:extLst>
           </p:cNvPr>
@@ -2595,8 +2439,8 @@
         </p:nvSpPr>
         <p:spPr>
           <a:xfrm xmlns:a="http://schemas.openxmlformats.org/drawingml/2006/main">
-            <a:off x="685800" y="3810000"/>
-            <a:ext cx="5010150" cy="514350"/>
+            <a:off x="5219700" y="3152775"/>
+            <a:ext cx="6191250" cy="466725"/>
           </a:xfrm>
           <a:prstGeom xmlns:a="http://schemas.openxmlformats.org/drawingml/2006/main" prst="rect">
             <a:avLst/>
@@ -2614,12 +2458,12 @@
           <a:p xmlns:a="http://schemas.openxmlformats.org/drawingml/2006/main">
             <a:pPr>
               <a:lnSpc>
-                <a:spcPct val="118000"/>
+                <a:spcPct val="115000"/>
               </a:lnSpc>
               <a:buNone/>
-              <a:defRPr sz="2250" b="1">
-                <a:solidFill>
-                  <a:srgbClr val="126C97"/>
+              <a:defRPr sz="2175" b="0">
+                <a:solidFill>
+                  <a:srgbClr val="111111"/>
                 </a:solidFill>
                 <a:latin typeface="Liberation Sans"/>
                 <a:ea typeface="Liberation Sans"/>
@@ -2627,25 +2471,25 @@
               </a:defRPr>
             </a:pPr>
             <a:r>
-              <a:rPr sz="2250" b="1">
-                <a:solidFill>
-                  <a:srgbClr val="126C97"/>
+              <a:rPr sz="2175" b="0">
+                <a:solidFill>
+                  <a:srgbClr val="111111"/>
                 </a:solidFill>
                 <a:latin typeface="Liberation Sans"/>
                 <a:ea typeface="Liberation Sans"/>
                 <a:cs typeface="Liberation Sans"/>
               </a:rPr>
-              <a:t>3. Measure and sign</a:t>
-            </a:r>
-          </a:p>
-        </p:txBody>
-      </p:sp>
-      <p:sp>
-        <p:nvSpPr>
-          <p:cNvPr id="7" name="">
+              <a:t>Buys a new reading</a:t>
+            </a:r>
+          </a:p>
+        </p:txBody>
+      </p:sp>
+      <p:sp>
+        <p:nvSpPr>
+          <p:cNvPr id="8" name="">
             <a:extLst xmlns:a="http://schemas.openxmlformats.org/drawingml/2006/main">
               <a:ext uri="{FF2B5EF4-FFF2-40B4-BE49-F238E27FC236}">
-                <a16:creationId xmlns:a16="http://schemas.microsoft.com/office/drawing/2014/main" id="{A79CD3BF-D331-4A21-957B-E6E3DDE77962}"/>
+                <a16:creationId xmlns:a16="http://schemas.microsoft.com/office/drawing/2014/main" id="{F8AFA449-06A4-433A-BCA0-B7EECD7012EF}"/>
               </a:ext>
             </a:extLst>
           </p:cNvPr>
@@ -2656,8 +2500,8 @@
         </p:nvSpPr>
         <p:spPr>
           <a:xfrm xmlns:a="http://schemas.openxmlformats.org/drawingml/2006/main">
-            <a:off x="685800" y="4429125"/>
-            <a:ext cx="4953000" cy="1257300"/>
+            <a:off x="5219700" y="3724275"/>
+            <a:ext cx="6191250" cy="361950"/>
           </a:xfrm>
           <a:prstGeom xmlns:a="http://schemas.openxmlformats.org/drawingml/2006/main" prst="rect">
             <a:avLst/>
@@ -2675,12 +2519,12 @@
           <a:p xmlns:a="http://schemas.openxmlformats.org/drawingml/2006/main">
             <a:pPr>
               <a:lnSpc>
-                <a:spcPct val="118000"/>
+                <a:spcPct val="115000"/>
               </a:lnSpc>
               <a:buNone/>
-              <a:defRPr sz="2025" b="0">
-                <a:solidFill>
-                  <a:srgbClr val="17364D"/>
+              <a:defRPr sz="2025" b="1">
+                <a:solidFill>
+                  <a:srgbClr val="111111"/>
                 </a:solidFill>
                 <a:latin typeface="Liberation Sans"/>
                 <a:ea typeface="Liberation Sans"/>
@@ -2688,25 +2532,25 @@
               </a:defRPr>
             </a:pPr>
             <a:r>
-              <a:rPr sz="2025" b="0">
-                <a:solidFill>
-                  <a:srgbClr val="17364D"/>
+              <a:rPr sz="2025" b="1">
+                <a:solidFill>
+                  <a:srgbClr val="111111"/>
                 </a:solidFill>
                 <a:latin typeface="Liberation Sans"/>
                 <a:ea typeface="Liberation Sans"/>
                 <a:cs typeface="Liberation Sans"/>
               </a:rPr>
-              <a:t>The ESP32 reads the physical input and signs a new answer for this request.</a:t>
-            </a:r>
-          </a:p>
-        </p:txBody>
-      </p:sp>
-      <p:sp>
-        <p:nvSpPr>
-          <p:cNvPr id="8" name="">
+              <a:t>Seeker</a:t>
+            </a:r>
+          </a:p>
+        </p:txBody>
+      </p:sp>
+      <p:sp>
+        <p:nvSpPr>
+          <p:cNvPr id="9" name="">
             <a:extLst xmlns:a="http://schemas.openxmlformats.org/drawingml/2006/main">
               <a:ext uri="{FF2B5EF4-FFF2-40B4-BE49-F238E27FC236}">
-                <a16:creationId xmlns:a16="http://schemas.microsoft.com/office/drawing/2014/main" id="{B65840EE-00C9-4E8B-8C13-4901DC69D951}"/>
+                <a16:creationId xmlns:a16="http://schemas.microsoft.com/office/drawing/2014/main" id="{932110BF-403E-453A-A8C8-D49FF69165C5}"/>
               </a:ext>
             </a:extLst>
           </p:cNvPr>
@@ -2717,8 +2561,8 @@
         </p:nvSpPr>
         <p:spPr>
           <a:xfrm xmlns:a="http://schemas.openxmlformats.org/drawingml/2006/main">
-            <a:off x="6496050" y="3810000"/>
-            <a:ext cx="5010150" cy="514350"/>
+            <a:off x="5219700" y="4095750"/>
+            <a:ext cx="6191250" cy="466725"/>
           </a:xfrm>
           <a:prstGeom xmlns:a="http://schemas.openxmlformats.org/drawingml/2006/main" prst="rect">
             <a:avLst/>
@@ -2736,12 +2580,12 @@
           <a:p xmlns:a="http://schemas.openxmlformats.org/drawingml/2006/main">
             <a:pPr>
               <a:lnSpc>
-                <a:spcPct val="118000"/>
+                <a:spcPct val="115000"/>
               </a:lnSpc>
               <a:buNone/>
-              <a:defRPr sz="2250" b="1">
-                <a:solidFill>
-                  <a:srgbClr val="126C97"/>
+              <a:defRPr sz="2175" b="0">
+                <a:solidFill>
+                  <a:srgbClr val="111111"/>
                 </a:solidFill>
                 <a:latin typeface="Liberation Sans"/>
                 <a:ea typeface="Liberation Sans"/>
@@ -2749,25 +2593,25 @@
               </a:defRPr>
             </a:pPr>
             <a:r>
-              <a:rPr sz="2250" b="1">
-                <a:solidFill>
-                  <a:srgbClr val="126C97"/>
+              <a:rPr sz="2175" b="0">
+                <a:solidFill>
+                  <a:srgbClr val="111111"/>
                 </a:solidFill>
                 <a:latin typeface="Liberation Sans"/>
                 <a:ea typeface="Liberation Sans"/>
                 <a:cs typeface="Liberation Sans"/>
               </a:rPr>
-              <a:t>4. Verify and decide</a:t>
-            </a:r>
-          </a:p>
-        </p:txBody>
-      </p:sp>
-      <p:sp>
-        <p:nvSpPr>
-          <p:cNvPr id="9" name="">
+              <a:t>Independently verifies the receipt</a:t>
+            </a:r>
+          </a:p>
+        </p:txBody>
+      </p:sp>
+      <p:sp>
+        <p:nvSpPr>
+          <p:cNvPr id="10" name="">
             <a:extLst xmlns:a="http://schemas.openxmlformats.org/drawingml/2006/main">
               <a:ext uri="{FF2B5EF4-FFF2-40B4-BE49-F238E27FC236}">
-                <a16:creationId xmlns:a16="http://schemas.microsoft.com/office/drawing/2014/main" id="{7794797A-FA9D-41A0-A69F-170A74855D43}"/>
+                <a16:creationId xmlns:a16="http://schemas.microsoft.com/office/drawing/2014/main" id="{C435BA18-3AD8-49F8-A2BE-40BB9F26A5AD}"/>
               </a:ext>
             </a:extLst>
           </p:cNvPr>
@@ -2778,8 +2622,8 @@
         </p:nvSpPr>
         <p:spPr>
           <a:xfrm xmlns:a="http://schemas.openxmlformats.org/drawingml/2006/main">
-            <a:off x="6496050" y="4429125"/>
-            <a:ext cx="4953000" cy="1257300"/>
+            <a:off x="685800" y="5381625"/>
+            <a:ext cx="5010150" cy="400050"/>
           </a:xfrm>
           <a:prstGeom xmlns:a="http://schemas.openxmlformats.org/drawingml/2006/main" prst="rect">
             <a:avLst/>
@@ -2797,12 +2641,12 @@
           <a:p xmlns:a="http://schemas.openxmlformats.org/drawingml/2006/main">
             <a:pPr>
               <a:lnSpc>
-                <a:spcPct val="118000"/>
+                <a:spcPct val="115000"/>
               </a:lnSpc>
               <a:buNone/>
-              <a:defRPr sz="2025" b="0">
-                <a:solidFill>
-                  <a:srgbClr val="17364D"/>
+              <a:defRPr sz="2100" b="1">
+                <a:solidFill>
+                  <a:srgbClr val="111111"/>
                 </a:solidFill>
                 <a:latin typeface="Liberation Sans"/>
                 <a:ea typeface="Liberation Sans"/>
@@ -2810,25 +2654,25 @@
               </a:defRPr>
             </a:pPr>
             <a:r>
-              <a:rPr sz="2025" b="0">
-                <a:solidFill>
-                  <a:srgbClr val="17364D"/>
+              <a:rPr sz="2100" b="1">
+                <a:solidFill>
+                  <a:srgbClr val="111111"/>
                 </a:solidFill>
                 <a:latin typeface="Liberation Sans"/>
                 <a:ea typeface="Liberation Sans"/>
                 <a:cs typeface="Liberation Sans"/>
               </a:rPr>
-              <a:t>The buyer verifies the source, request, signature, and age before its next action.</a:t>
-            </a:r>
-          </a:p>
-        </p:txBody>
-      </p:sp>
-      <p:sp>
-        <p:nvSpPr>
-          <p:cNvPr id="10" name="">
+              <a:t>Solana Devnet</a:t>
+            </a:r>
+          </a:p>
+        </p:txBody>
+      </p:sp>
+      <p:sp>
+        <p:nvSpPr>
+          <p:cNvPr id="11" name="">
             <a:extLst xmlns:a="http://schemas.openxmlformats.org/drawingml/2006/main">
               <a:ext uri="{FF2B5EF4-FFF2-40B4-BE49-F238E27FC236}">
-                <a16:creationId xmlns:a16="http://schemas.microsoft.com/office/drawing/2014/main" id="{25EE1B7B-F1CE-4E97-8B7C-CD6A86DCED08}"/>
+                <a16:creationId xmlns:a16="http://schemas.microsoft.com/office/drawing/2014/main" id="{2E6706D0-EFA4-42D3-9B2A-BE3012318E08}"/>
               </a:ext>
             </a:extLst>
           </p:cNvPr>
@@ -2839,8 +2683,8 @@
         </p:nvSpPr>
         <p:spPr>
           <a:xfrm xmlns:a="http://schemas.openxmlformats.org/drawingml/2006/main">
-            <a:off x="685800" y="6276975"/>
-            <a:ext cx="10820400" cy="419100"/>
+            <a:off x="685800" y="5810250"/>
+            <a:ext cx="5010150" cy="781050"/>
           </a:xfrm>
           <a:prstGeom xmlns:a="http://schemas.openxmlformats.org/drawingml/2006/main" prst="rect">
             <a:avLst/>
@@ -2858,12 +2702,12 @@
           <a:p xmlns:a="http://schemas.openxmlformats.org/drawingml/2006/main">
             <a:pPr>
               <a:lnSpc>
-                <a:spcPct val="118000"/>
+                <a:spcPct val="115000"/>
               </a:lnSpc>
               <a:buNone/>
-              <a:defRPr sz="1350" b="0">
-                <a:solidFill>
-                  <a:srgbClr val="536D80"/>
+              <a:defRPr sz="1800" b="0">
+                <a:solidFill>
+                  <a:srgbClr val="111111"/>
                 </a:solidFill>
                 <a:latin typeface="Liberation Sans"/>
                 <a:ea typeface="Liberation Sans"/>
@@ -2871,15 +2715,137 @@
               </a:defRPr>
             </a:pPr>
             <a:r>
-              <a:rPr sz="1350" b="0">
-                <a:solidFill>
-                  <a:srgbClr val="536D80"/>
+              <a:rPr sz="1800" b="0">
+                <a:solidFill>
+                  <a:srgbClr val="111111"/>
                 </a:solidFill>
                 <a:latin typeface="Liberation Sans"/>
                 <a:ea typeface="Liberation Sans"/>
                 <a:cs typeface="Liberation Sans"/>
               </a:rPr>
-              <a:t>03 / Both contact states fulfill the paid check. The operator receives test tokens.</a:t>
+              <a:t>0.001 test USDC to the operator</a:t>
+            </a:r>
+          </a:p>
+        </p:txBody>
+      </p:sp>
+      <p:sp>
+        <p:nvSpPr>
+          <p:cNvPr id="12" name="">
+            <a:extLst xmlns:a="http://schemas.openxmlformats.org/drawingml/2006/main">
+              <a:ext uri="{FF2B5EF4-FFF2-40B4-BE49-F238E27FC236}">
+                <a16:creationId xmlns:a16="http://schemas.microsoft.com/office/drawing/2014/main" id="{6697C91D-DE4B-4266-A966-8E8EC22255B4}"/>
+              </a:ext>
+            </a:extLst>
+          </p:cNvPr>
+          <p:cNvSpPr>
+            <a:spLocks xmlns:a="http://schemas.openxmlformats.org/drawingml/2006/main" noGrp="1"/>
+          </p:cNvSpPr>
+          <p:nvPr/>
+        </p:nvSpPr>
+        <p:spPr>
+          <a:xfrm xmlns:a="http://schemas.openxmlformats.org/drawingml/2006/main">
+            <a:off x="6496050" y="5381625"/>
+            <a:ext cx="5010150" cy="400050"/>
+          </a:xfrm>
+          <a:prstGeom xmlns:a="http://schemas.openxmlformats.org/drawingml/2006/main" prst="rect">
+            <a:avLst/>
+          </a:prstGeom>
+          <a:noFill xmlns:a="http://schemas.openxmlformats.org/drawingml/2006/main"/>
+          <a:ln xmlns:a="http://schemas.openxmlformats.org/drawingml/2006/main" w="0">
+            <a:noFill/>
+          </a:ln>
+        </p:spPr>
+        <p:txBody>
+          <a:bodyPr xmlns:a="http://schemas.openxmlformats.org/drawingml/2006/main" lIns="0" tIns="0" rIns="0" bIns="0" anchor="t">
+            <a:noAutofit/>
+          </a:bodyPr>
+          <a:lstStyle xmlns:a="http://schemas.openxmlformats.org/drawingml/2006/main"/>
+          <a:p xmlns:a="http://schemas.openxmlformats.org/drawingml/2006/main">
+            <a:pPr>
+              <a:lnSpc>
+                <a:spcPct val="115000"/>
+              </a:lnSpc>
+              <a:buNone/>
+              <a:defRPr sz="2100" b="1">
+                <a:solidFill>
+                  <a:srgbClr val="111111"/>
+                </a:solidFill>
+                <a:latin typeface="Liberation Sans"/>
+                <a:ea typeface="Liberation Sans"/>
+                <a:cs typeface="Liberation Sans"/>
+              </a:defRPr>
+            </a:pPr>
+            <a:r>
+              <a:rPr sz="2100" b="1">
+                <a:solidFill>
+                  <a:srgbClr val="111111"/>
+                </a:solidFill>
+                <a:latin typeface="Liberation Sans"/>
+                <a:ea typeface="Liberation Sans"/>
+                <a:cs typeface="Liberation Sans"/>
+              </a:rPr>
+              <a:t>peaq Agung</a:t>
+            </a:r>
+          </a:p>
+        </p:txBody>
+      </p:sp>
+      <p:sp>
+        <p:nvSpPr>
+          <p:cNvPr id="13" name="">
+            <a:extLst xmlns:a="http://schemas.openxmlformats.org/drawingml/2006/main">
+              <a:ext uri="{FF2B5EF4-FFF2-40B4-BE49-F238E27FC236}">
+                <a16:creationId xmlns:a16="http://schemas.microsoft.com/office/drawing/2014/main" id="{7009E01F-8162-4D20-92B9-FB0ACAE4F808}"/>
+              </a:ext>
+            </a:extLst>
+          </p:cNvPr>
+          <p:cNvSpPr>
+            <a:spLocks xmlns:a="http://schemas.openxmlformats.org/drawingml/2006/main" noGrp="1"/>
+          </p:cNvSpPr>
+          <p:nvPr/>
+        </p:nvSpPr>
+        <p:spPr>
+          <a:xfrm xmlns:a="http://schemas.openxmlformats.org/drawingml/2006/main">
+            <a:off x="6496050" y="5810250"/>
+            <a:ext cx="5010150" cy="781050"/>
+          </a:xfrm>
+          <a:prstGeom xmlns:a="http://schemas.openxmlformats.org/drawingml/2006/main" prst="rect">
+            <a:avLst/>
+          </a:prstGeom>
+          <a:noFill xmlns:a="http://schemas.openxmlformats.org/drawingml/2006/main"/>
+          <a:ln xmlns:a="http://schemas.openxmlformats.org/drawingml/2006/main" w="0">
+            <a:noFill/>
+          </a:ln>
+        </p:spPr>
+        <p:txBody>
+          <a:bodyPr xmlns:a="http://schemas.openxmlformats.org/drawingml/2006/main" lIns="0" tIns="0" rIns="0" bIns="0" anchor="t">
+            <a:noAutofit/>
+          </a:bodyPr>
+          <a:lstStyle xmlns:a="http://schemas.openxmlformats.org/drawingml/2006/main"/>
+          <a:p xmlns:a="http://schemas.openxmlformats.org/drawingml/2006/main">
+            <a:pPr>
+              <a:lnSpc>
+                <a:spcPct val="115000"/>
+              </a:lnSpc>
+              <a:buNone/>
+              <a:defRPr sz="1800" b="0">
+                <a:solidFill>
+                  <a:srgbClr val="111111"/>
+                </a:solidFill>
+                <a:latin typeface="Liberation Sans"/>
+                <a:ea typeface="Liberation Sans"/>
+                <a:cs typeface="Liberation Sans"/>
+              </a:defRPr>
+            </a:pPr>
+            <a:r>
+              <a:rPr sz="1800" b="0">
+                <a:solidFill>
+                  <a:srgbClr val="111111"/>
+                </a:solidFill>
+                <a:latin typeface="Liberation Sans"/>
+                <a:ea typeface="Liberation Sans"/>
+                <a:cs typeface="Liberation Sans"/>
+              </a:rPr>
+              <a:t>Registered device key and linked work record</a:t>
             </a:r>
           </a:p>
         </p:txBody>
@@ -2887,7 +2853,7 @@
     </p:spTree>
     <p:extLst>
       <p:ext uri="{BB962C8B-B14F-4D97-AF65-F5344CB8AC3E}">
-        <p14:creationId xmlns:p14="http://schemas.microsoft.com/office/powerpoint/2010/main" val="311761918"/>
+        <p14:creationId xmlns:p14="http://schemas.microsoft.com/office/powerpoint/2010/main" val="357328579"/>
       </p:ext>
     </p:extLst>
   </p:cSld>
@@ -2900,7 +2866,7 @@
     <p:bg>
       <p:bgPr>
         <a:solidFill xmlns:a="http://schemas.openxmlformats.org/drawingml/2006/main">
-          <a:srgbClr val="F4FAFF"/>
+          <a:srgbClr val="FFFFFF"/>
         </a:solidFill>
       </p:bgPr>
     </p:bg>
@@ -2915,10 +2881,10 @@
       </p:grpSpPr>
       <p:sp>
         <p:nvSpPr>
-          <p:cNvPr id="9" name="">
+          <p:cNvPr id="8" name="">
             <a:extLst xmlns:a="http://schemas.openxmlformats.org/drawingml/2006/main">
               <a:ext uri="{FF2B5EF4-FFF2-40B4-BE49-F238E27FC236}">
-                <a16:creationId xmlns:a16="http://schemas.microsoft.com/office/drawing/2014/main" id="{5730CC44-E194-4465-9290-4ABB54D2A04B}"/>
+                <a16:creationId xmlns:a16="http://schemas.microsoft.com/office/drawing/2014/main" id="{731457B2-1DC3-4836-8A1D-979681C611D8}"/>
               </a:ext>
             </a:extLst>
           </p:cNvPr>
@@ -2929,8 +2895,8 @@
         </p:nvSpPr>
         <p:spPr>
           <a:xfrm xmlns:a="http://schemas.openxmlformats.org/drawingml/2006/main">
-            <a:off x="685800" y="457200"/>
-            <a:ext cx="10820400" cy="857250"/>
+            <a:off x="685800" y="590550"/>
+            <a:ext cx="10820400" cy="1123950"/>
           </a:xfrm>
           <a:prstGeom xmlns:a="http://schemas.openxmlformats.org/drawingml/2006/main" prst="rect">
             <a:avLst/>
@@ -2948,12 +2914,12 @@
           <a:p xmlns:a="http://schemas.openxmlformats.org/drawingml/2006/main">
             <a:pPr>
               <a:lnSpc>
-                <a:spcPct val="118000"/>
+                <a:spcPct val="115000"/>
               </a:lnSpc>
               <a:buNone/>
-              <a:defRPr sz="3450" b="1">
-                <a:solidFill>
-                  <a:srgbClr val="17364D"/>
+              <a:defRPr sz="3675" b="1">
+                <a:solidFill>
+                  <a:srgbClr val="111111"/>
                 </a:solidFill>
                 <a:latin typeface="Liberation Sans"/>
                 <a:ea typeface="Liberation Sans"/>
@@ -2961,15 +2927,15 @@
               </a:defRPr>
             </a:pPr>
             <a:r>
-              <a:rPr sz="3450" b="1">
-                <a:solidFill>
-                  <a:srgbClr val="17364D"/>
+              <a:rPr sz="3675" b="1">
+                <a:solidFill>
+                  <a:srgbClr val="111111"/>
                 </a:solidFill>
                 <a:latin typeface="Liberation Sans"/>
                 <a:ea typeface="Liberation Sans"/>
                 <a:cs typeface="Liberation Sans"/>
               </a:rPr>
-              <a:t>The evidence has limits</a:t>
+              <a:t>Payment stays final. Answers expire.</a:t>
             </a:r>
           </a:p>
         </p:txBody>
@@ -2979,7 +2945,7 @@
           <p:cNvPr id="2" name="">
             <a:extLst xmlns:a="http://schemas.openxmlformats.org/drawingml/2006/main">
               <a:ext uri="{FF2B5EF4-FFF2-40B4-BE49-F238E27FC236}">
-                <a16:creationId xmlns:a16="http://schemas.microsoft.com/office/drawing/2014/main" id="{018CC3A7-E786-4CC1-9C69-74721A8FB110}"/>
+                <a16:creationId xmlns:a16="http://schemas.microsoft.com/office/drawing/2014/main" id="{15B3A513-AD3D-40E4-B2F8-5E794AB80444}"/>
               </a:ext>
             </a:extLst>
           </p:cNvPr>
@@ -2990,8 +2956,8 @@
         </p:nvSpPr>
         <p:spPr>
           <a:xfrm xmlns:a="http://schemas.openxmlformats.org/drawingml/2006/main">
-            <a:off x="685800" y="1809750"/>
-            <a:ext cx="5010150" cy="666750"/>
+            <a:off x="685800" y="2667000"/>
+            <a:ext cx="5010150" cy="571500"/>
           </a:xfrm>
           <a:prstGeom xmlns:a="http://schemas.openxmlformats.org/drawingml/2006/main" prst="rect">
             <a:avLst/>
@@ -3009,12 +2975,12 @@
           <a:p xmlns:a="http://schemas.openxmlformats.org/drawingml/2006/main">
             <a:pPr>
               <a:lnSpc>
-                <a:spcPct val="118000"/>
+                <a:spcPct val="115000"/>
               </a:lnSpc>
               <a:buNone/>
-              <a:defRPr sz="2175" b="1">
-                <a:solidFill>
-                  <a:srgbClr val="126C97"/>
+              <a:defRPr sz="3150" b="1">
+                <a:solidFill>
+                  <a:srgbClr val="111111"/>
                 </a:solidFill>
                 <a:latin typeface="Liberation Sans"/>
                 <a:ea typeface="Liberation Sans"/>
@@ -3022,15 +2988,15 @@
               </a:defRPr>
             </a:pPr>
             <a:r>
-              <a:rPr sz="2175" b="1">
-                <a:solidFill>
-                  <a:srgbClr val="126C97"/>
+              <a:rPr sz="3150" b="1">
+                <a:solidFill>
+                  <a:srgbClr val="111111"/>
                 </a:solidFill>
                 <a:latin typeface="Liberation Sans"/>
                 <a:ea typeface="Liberation Sans"/>
                 <a:cs typeface="Liberation Sans"/>
               </a:rPr>
-              <a:t>The buyer can verify</a:t>
+              <a:t>Payment</a:t>
             </a:r>
           </a:p>
         </p:txBody>
@@ -3040,7 +3006,7 @@
           <p:cNvPr id="3" name="">
             <a:extLst xmlns:a="http://schemas.openxmlformats.org/drawingml/2006/main">
               <a:ext uri="{FF2B5EF4-FFF2-40B4-BE49-F238E27FC236}">
-                <a16:creationId xmlns:a16="http://schemas.microsoft.com/office/drawing/2014/main" id="{92020722-7F56-4156-80C4-3AC36EA3A367}"/>
+                <a16:creationId xmlns:a16="http://schemas.microsoft.com/office/drawing/2014/main" id="{17631251-6971-49BF-B434-68942F09FEA4}"/>
               </a:ext>
             </a:extLst>
           </p:cNvPr>
@@ -3051,8 +3017,8 @@
         </p:nvSpPr>
         <p:spPr>
           <a:xfrm xmlns:a="http://schemas.openxmlformats.org/drawingml/2006/main">
-            <a:off x="685800" y="2647950"/>
-            <a:ext cx="4895850" cy="1162050"/>
+            <a:off x="685800" y="3343275"/>
+            <a:ext cx="4857750" cy="1000125"/>
           </a:xfrm>
           <a:prstGeom xmlns:a="http://schemas.openxmlformats.org/drawingml/2006/main" prst="rect">
             <a:avLst/>
@@ -3070,12 +3036,12 @@
           <a:p xmlns:a="http://schemas.openxmlformats.org/drawingml/2006/main">
             <a:pPr>
               <a:lnSpc>
-                <a:spcPct val="118000"/>
+                <a:spcPct val="115000"/>
               </a:lnSpc>
               <a:buNone/>
-              <a:defRPr sz="2100" b="0">
-                <a:solidFill>
-                  <a:srgbClr val="17364D"/>
+              <a:defRPr sz="2175" b="0">
+                <a:solidFill>
+                  <a:srgbClr val="111111"/>
                 </a:solidFill>
                 <a:latin typeface="Liberation Sans"/>
                 <a:ea typeface="Liberation Sans"/>
@@ -3083,15 +3049,15 @@
               </a:defRPr>
             </a:pPr>
             <a:r>
-              <a:rPr sz="2100" b="0">
-                <a:solidFill>
-                  <a:srgbClr val="17364D"/>
+              <a:rPr sz="2175" b="0">
+                <a:solidFill>
+                  <a:srgbClr val="111111"/>
                 </a:solidFill>
                 <a:latin typeface="Liberation Sans"/>
                 <a:ea typeface="Liberation Sans"/>
                 <a:cs typeface="Liberation Sans"/>
               </a:rPr>
-              <a:t>This approved device signed the answer to this request.</a:t>
+              <a:t>The operator keeps the test payment.</a:t>
             </a:r>
           </a:p>
         </p:txBody>
@@ -3101,7 +3067,7 @@
           <p:cNvPr id="4" name="">
             <a:extLst xmlns:a="http://schemas.openxmlformats.org/drawingml/2006/main">
               <a:ext uri="{FF2B5EF4-FFF2-40B4-BE49-F238E27FC236}">
-                <a16:creationId xmlns:a16="http://schemas.microsoft.com/office/drawing/2014/main" id="{7FD7EF97-601E-4BC5-BFBA-C95FD0DD4F74}"/>
+                <a16:creationId xmlns:a16="http://schemas.microsoft.com/office/drawing/2014/main" id="{8B64E3F7-68A9-4125-9C2F-6F574AB785CA}"/>
               </a:ext>
             </a:extLst>
           </p:cNvPr>
@@ -3112,8 +3078,8 @@
         </p:nvSpPr>
         <p:spPr>
           <a:xfrm xmlns:a="http://schemas.openxmlformats.org/drawingml/2006/main">
-            <a:off x="685800" y="4000500"/>
-            <a:ext cx="4895850" cy="1295400"/>
+            <a:off x="6496050" y="2667000"/>
+            <a:ext cx="5010150" cy="571500"/>
           </a:xfrm>
           <a:prstGeom xmlns:a="http://schemas.openxmlformats.org/drawingml/2006/main" prst="rect">
             <a:avLst/>
@@ -3131,12 +3097,12 @@
           <a:p xmlns:a="http://schemas.openxmlformats.org/drawingml/2006/main">
             <a:pPr>
               <a:lnSpc>
-                <a:spcPct val="118000"/>
+                <a:spcPct val="115000"/>
               </a:lnSpc>
               <a:buNone/>
-              <a:defRPr sz="2100" b="0">
-                <a:solidFill>
-                  <a:srgbClr val="17364D"/>
+              <a:defRPr sz="3150" b="1">
+                <a:solidFill>
+                  <a:srgbClr val="111111"/>
                 </a:solidFill>
                 <a:latin typeface="Liberation Sans"/>
                 <a:ea typeface="Liberation Sans"/>
@@ -3144,15 +3110,15 @@
               </a:defRPr>
             </a:pPr>
             <a:r>
-              <a:rPr sz="2100" b="0">
-                <a:solidFill>
-                  <a:srgbClr val="17364D"/>
+              <a:rPr sz="3150" b="1">
+                <a:solidFill>
+                  <a:srgbClr val="111111"/>
                 </a:solidFill>
                 <a:latin typeface="Liberation Sans"/>
                 <a:ea typeface="Liberation Sans"/>
                 <a:cs typeface="Liberation Sans"/>
               </a:rPr>
-              <a:t>An old answer fails the age policy. An edited answer fails signature verification.</a:t>
+              <a:t>Physical answer</a:t>
             </a:r>
           </a:p>
         </p:txBody>
@@ -3162,7 +3128,7 @@
           <p:cNvPr id="5" name="">
             <a:extLst xmlns:a="http://schemas.openxmlformats.org/drawingml/2006/main">
               <a:ext uri="{FF2B5EF4-FFF2-40B4-BE49-F238E27FC236}">
-                <a16:creationId xmlns:a16="http://schemas.microsoft.com/office/drawing/2014/main" id="{5ED12925-5371-4E4A-BD26-D76D70D24C86}"/>
+                <a16:creationId xmlns:a16="http://schemas.microsoft.com/office/drawing/2014/main" id="{082FB663-A12C-46E6-B7C5-336951FB6991}"/>
               </a:ext>
             </a:extLst>
           </p:cNvPr>
@@ -3173,8 +3139,8 @@
         </p:nvSpPr>
         <p:spPr>
           <a:xfrm xmlns:a="http://schemas.openxmlformats.org/drawingml/2006/main">
-            <a:off x="6496050" y="1809750"/>
-            <a:ext cx="5010150" cy="666750"/>
+            <a:off x="6496050" y="3343275"/>
+            <a:ext cx="4857750" cy="1000125"/>
           </a:xfrm>
           <a:prstGeom xmlns:a="http://schemas.openxmlformats.org/drawingml/2006/main" prst="rect">
             <a:avLst/>
@@ -3192,12 +3158,12 @@
           <a:p xmlns:a="http://schemas.openxmlformats.org/drawingml/2006/main">
             <a:pPr>
               <a:lnSpc>
-                <a:spcPct val="118000"/>
+                <a:spcPct val="115000"/>
               </a:lnSpc>
               <a:buNone/>
-              <a:defRPr sz="2175" b="1">
-                <a:solidFill>
-                  <a:srgbClr val="126C97"/>
+              <a:defRPr sz="2175" b="0">
+                <a:solidFill>
+                  <a:srgbClr val="111111"/>
                 </a:solidFill>
                 <a:latin typeface="Liberation Sans"/>
                 <a:ea typeface="Liberation Sans"/>
@@ -3205,15 +3171,15 @@
               </a:defRPr>
             </a:pPr>
             <a:r>
-              <a:rPr sz="2175" b="1">
-                <a:solidFill>
-                  <a:srgbClr val="126C97"/>
+              <a:rPr sz="2175" b="0">
+                <a:solidFill>
+                  <a:srgbClr val="111111"/>
                 </a:solidFill>
                 <a:latin typeface="Liberation Sans"/>
                 <a:ea typeface="Liberation Sans"/>
                 <a:cs typeface="Liberation Sans"/>
               </a:rPr>
-              <a:t>The physical demonstration</a:t>
+              <a:t>The buyer needs a new check after ten seconds.</a:t>
             </a:r>
           </a:p>
         </p:txBody>
@@ -3223,7 +3189,7 @@
           <p:cNvPr id="6" name="">
             <a:extLst xmlns:a="http://schemas.openxmlformats.org/drawingml/2006/main">
               <a:ext uri="{FF2B5EF4-FFF2-40B4-BE49-F238E27FC236}">
-                <a16:creationId xmlns:a16="http://schemas.microsoft.com/office/drawing/2014/main" id="{E1B3F251-2749-4411-92C3-6B7BB2A5A262}"/>
+                <a16:creationId xmlns:a16="http://schemas.microsoft.com/office/drawing/2014/main" id="{D0CDAC81-40C3-4C33-8737-281E3A7248AE}"/>
               </a:ext>
             </a:extLst>
           </p:cNvPr>
@@ -3234,8 +3200,8 @@
         </p:nvSpPr>
         <p:spPr>
           <a:xfrm xmlns:a="http://schemas.openxmlformats.org/drawingml/2006/main">
-            <a:off x="6496050" y="2647950"/>
-            <a:ext cx="4895850" cy="1162050"/>
+            <a:off x="685800" y="4648200"/>
+            <a:ext cx="10820400" cy="762000"/>
           </a:xfrm>
           <a:prstGeom xmlns:a="http://schemas.openxmlformats.org/drawingml/2006/main" prst="rect">
             <a:avLst/>
@@ -3253,12 +3219,12 @@
           <a:p xmlns:a="http://schemas.openxmlformats.org/drawingml/2006/main">
             <a:pPr>
               <a:lnSpc>
-                <a:spcPct val="118000"/>
+                <a:spcPct val="115000"/>
               </a:lnSpc>
               <a:buNone/>
-              <a:defRPr sz="2100" b="0">
-                <a:solidFill>
-                  <a:srgbClr val="17364D"/>
+              <a:defRPr sz="2400" b="0">
+                <a:solidFill>
+                  <a:srgbClr val="111111"/>
                 </a:solidFill>
                 <a:latin typeface="Liberation Sans"/>
                 <a:ea typeface="Liberation Sans"/>
@@ -3266,15 +3232,15 @@
               </a:defRPr>
             </a:pPr>
             <a:r>
-              <a:rPr sz="2100" b="0">
-                <a:solidFill>
-                  <a:srgbClr val="17364D"/>
+              <a:rPr sz="2400" b="0">
+                <a:solidFill>
+                  <a:srgbClr val="111111"/>
                 </a:solidFill>
                 <a:latin typeface="Liberation Sans"/>
                 <a:ea typeface="Liberation Sans"/>
                 <a:cs typeface="Liberation Sans"/>
               </a:rPr>
-              <a:t>Release or hold BOOT. The contact changes between OPEN and CLOSED.</a:t>
+              <a:t>An edited answer fails signature verification.</a:t>
             </a:r>
           </a:p>
         </p:txBody>
@@ -3284,7 +3250,7 @@
           <p:cNvPr id="7" name="">
             <a:extLst xmlns:a="http://schemas.openxmlformats.org/drawingml/2006/main">
               <a:ext uri="{FF2B5EF4-FFF2-40B4-BE49-F238E27FC236}">
-                <a16:creationId xmlns:a16="http://schemas.microsoft.com/office/drawing/2014/main" id="{83E7AB47-D984-400A-B4D2-B7CAB8DCEC84}"/>
+                <a16:creationId xmlns:a16="http://schemas.microsoft.com/office/drawing/2014/main" id="{D28E698F-3BB4-4A02-B51B-1BF48CCE2CA3}"/>
               </a:ext>
             </a:extLst>
           </p:cNvPr>
@@ -3295,8 +3261,8 @@
         </p:nvSpPr>
         <p:spPr>
           <a:xfrm xmlns:a="http://schemas.openxmlformats.org/drawingml/2006/main">
-            <a:off x="6496050" y="4000500"/>
-            <a:ext cx="4895850" cy="1295400"/>
+            <a:off x="685800" y="5791200"/>
+            <a:ext cx="10820400" cy="590550"/>
           </a:xfrm>
           <a:prstGeom xmlns:a="http://schemas.openxmlformats.org/drawingml/2006/main" prst="rect">
             <a:avLst/>
@@ -3314,12 +3280,12 @@
           <a:p xmlns:a="http://schemas.openxmlformats.org/drawingml/2006/main">
             <a:pPr>
               <a:lnSpc>
-                <a:spcPct val="118000"/>
+                <a:spcPct val="115000"/>
               </a:lnSpc>
               <a:buNone/>
-              <a:defRPr sz="2100" b="0">
-                <a:solidFill>
-                  <a:srgbClr val="17364D"/>
+              <a:defRPr sz="1575" b="0">
+                <a:solidFill>
+                  <a:srgbClr val="555555"/>
                 </a:solidFill>
                 <a:latin typeface="Liberation Sans"/>
                 <a:ea typeface="Liberation Sans"/>
@@ -3327,76 +3293,15 @@
               </a:defRPr>
             </a:pPr>
             <a:r>
-              <a:rPr sz="2100" b="0">
-                <a:solidFill>
-                  <a:srgbClr val="17364D"/>
+              <a:rPr sz="1575" b="0">
+                <a:solidFill>
+                  <a:srgbClr val="555555"/>
                 </a:solidFill>
                 <a:latin typeface="Liberation Sans"/>
                 <a:ea typeface="Liberation Sans"/>
                 <a:cs typeface="Liberation Sans"/>
               </a:rPr>
-              <a:t>The contact does not prove contents, safety, or completed work.</a:t>
-            </a:r>
-          </a:p>
-        </p:txBody>
-      </p:sp>
-      <p:sp>
-        <p:nvSpPr>
-          <p:cNvPr id="8" name="">
-            <a:extLst xmlns:a="http://schemas.openxmlformats.org/drawingml/2006/main">
-              <a:ext uri="{FF2B5EF4-FFF2-40B4-BE49-F238E27FC236}">
-                <a16:creationId xmlns:a16="http://schemas.microsoft.com/office/drawing/2014/main" id="{E21B37B1-E47D-447A-9F42-B4DE9184A511}"/>
-              </a:ext>
-            </a:extLst>
-          </p:cNvPr>
-          <p:cNvSpPr>
-            <a:spLocks xmlns:a="http://schemas.openxmlformats.org/drawingml/2006/main" noGrp="1"/>
-          </p:cNvSpPr>
-          <p:nvPr/>
-        </p:nvSpPr>
-        <p:spPr>
-          <a:xfrm xmlns:a="http://schemas.openxmlformats.org/drawingml/2006/main">
-            <a:off x="685800" y="6276975"/>
-            <a:ext cx="10820400" cy="419100"/>
-          </a:xfrm>
-          <a:prstGeom xmlns:a="http://schemas.openxmlformats.org/drawingml/2006/main" prst="rect">
-            <a:avLst/>
-          </a:prstGeom>
-          <a:noFill xmlns:a="http://schemas.openxmlformats.org/drawingml/2006/main"/>
-          <a:ln xmlns:a="http://schemas.openxmlformats.org/drawingml/2006/main" w="0">
-            <a:noFill/>
-          </a:ln>
-        </p:spPr>
-        <p:txBody>
-          <a:bodyPr xmlns:a="http://schemas.openxmlformats.org/drawingml/2006/main" lIns="0" tIns="0" rIns="0" bIns="0" anchor="t">
-            <a:noAutofit/>
-          </a:bodyPr>
-          <a:lstStyle xmlns:a="http://schemas.openxmlformats.org/drawingml/2006/main"/>
-          <a:p xmlns:a="http://schemas.openxmlformats.org/drawingml/2006/main">
-            <a:pPr>
-              <a:lnSpc>
-                <a:spcPct val="118000"/>
-              </a:lnSpc>
-              <a:buNone/>
-              <a:defRPr sz="1350" b="0">
-                <a:solidFill>
-                  <a:srgbClr val="536D80"/>
-                </a:solidFill>
-                <a:latin typeface="Liberation Sans"/>
-                <a:ea typeface="Liberation Sans"/>
-                <a:cs typeface="Liberation Sans"/>
-              </a:defRPr>
-            </a:pPr>
-            <a:r>
-              <a:rPr sz="1350" b="0">
-                <a:solidFill>
-                  <a:srgbClr val="536D80"/>
-                </a:solidFill>
-                <a:latin typeface="Liberation Sans"/>
-                <a:ea typeface="Liberation Sans"/>
-                <a:cs typeface="Liberation Sans"/>
-              </a:rPr>
-              <a:t>04 / BOOT represents a contact. This software controls no door or robot.</a:t>
+              <a:t>A signature identifies a claim's source. Physical truth needs separate controls.</a:t>
             </a:r>
           </a:p>
         </p:txBody>
@@ -3404,7 +3309,7 @@
     </p:spTree>
     <p:extLst>
       <p:ext uri="{BB962C8B-B14F-4D97-AF65-F5344CB8AC3E}">
-        <p14:creationId xmlns:p14="http://schemas.microsoft.com/office/powerpoint/2010/main" val="1579757540"/>
+        <p14:creationId xmlns:p14="http://schemas.microsoft.com/office/powerpoint/2010/main" val="727731073"/>
       </p:ext>
     </p:extLst>
   </p:cSld>
@@ -3417,7 +3322,7 @@
     <p:bg>
       <p:bgPr>
         <a:solidFill xmlns:a="http://schemas.openxmlformats.org/drawingml/2006/main">
-          <a:srgbClr val="F4FAFF"/>
+          <a:srgbClr val="FFFFFF"/>
         </a:solidFill>
       </p:bgPr>
     </p:bg>
@@ -3432,10 +3337,10 @@
       </p:grpSpPr>
       <p:sp>
         <p:nvSpPr>
-          <p:cNvPr id="10" name="">
+          <p:cNvPr id="8" name="">
             <a:extLst xmlns:a="http://schemas.openxmlformats.org/drawingml/2006/main">
               <a:ext uri="{FF2B5EF4-FFF2-40B4-BE49-F238E27FC236}">
-                <a16:creationId xmlns:a16="http://schemas.microsoft.com/office/drawing/2014/main" id="{9724F5E4-17EC-41DD-BA2B-F5158BEA951A}"/>
+                <a16:creationId xmlns:a16="http://schemas.microsoft.com/office/drawing/2014/main" id="{A0A62E7C-731B-4431-A937-EA8D87FE8199}"/>
               </a:ext>
             </a:extLst>
           </p:cNvPr>
@@ -3446,8 +3351,8 @@
         </p:nvSpPr>
         <p:spPr>
           <a:xfrm xmlns:a="http://schemas.openxmlformats.org/drawingml/2006/main">
-            <a:off x="685800" y="457200"/>
-            <a:ext cx="10820400" cy="857250"/>
+            <a:off x="685800" y="590550"/>
+            <a:ext cx="9715500" cy="1123950"/>
           </a:xfrm>
           <a:prstGeom xmlns:a="http://schemas.openxmlformats.org/drawingml/2006/main" prst="rect">
             <a:avLst/>
@@ -3465,12 +3370,12 @@
           <a:p xmlns:a="http://schemas.openxmlformats.org/drawingml/2006/main">
             <a:pPr>
               <a:lnSpc>
-                <a:spcPct val="118000"/>
+                <a:spcPct val="115000"/>
               </a:lnSpc>
               <a:buNone/>
-              <a:defRPr sz="3450" b="1">
-                <a:solidFill>
-                  <a:srgbClr val="17364D"/>
+              <a:defRPr sz="3675" b="1">
+                <a:solidFill>
+                  <a:srgbClr val="111111"/>
                 </a:solidFill>
                 <a:latin typeface="Liberation Sans"/>
                 <a:ea typeface="Liberation Sans"/>
@@ -3478,25 +3383,47 @@
               </a:defRPr>
             </a:pPr>
             <a:r>
-              <a:rPr sz="3450" b="1">
-                <a:solidFill>
-                  <a:srgbClr val="17364D"/>
+              <a:rPr sz="3675" b="1">
+                <a:solidFill>
+                  <a:srgbClr val="111111"/>
                 </a:solidFill>
                 <a:latin typeface="Liberation Sans"/>
                 <a:ea typeface="Liberation Sans"/>
                 <a:cs typeface="Liberation Sans"/>
               </a:rPr>
-              <a:t>peaq's role and the next test</a:t>
-            </a:r>
-          </a:p>
-        </p:txBody>
-      </p:sp>
-      <p:sp>
-        <p:nvSpPr>
-          <p:cNvPr id="2" name="">
+              <a:t>One useful check. Then a network.</a:t>
+            </a:r>
+          </a:p>
+        </p:txBody>
+      </p:sp>
+      <p:pic>
+        <p:nvPicPr>
+          <p:cNvPr id="9" name=""/>
+          <p:cNvPicPr>
+            <a:picLocks xmlns:a="http://schemas.openxmlformats.org/drawingml/2006/main" noChangeAspect="1"/>
+          </p:cNvPicPr>
+          <p:nvPr/>
+        </p:nvPicPr>
+        <p:blipFill>
+          <a:blip xmlns:r="http://schemas.openxmlformats.org/officeDocument/2006/relationships" xmlns:a="http://schemas.openxmlformats.org/drawingml/2006/main" r:embed="Rbeac64cf91f04a6b"/>
+          <a:stretch xmlns:a="http://schemas.openxmlformats.org/drawingml/2006/main"/>
+        </p:blipFill>
+        <p:spPr>
+          <a:xfrm xmlns:a="http://schemas.openxmlformats.org/drawingml/2006/main">
+            <a:off x="10620375" y="428625"/>
+            <a:ext cx="952500" cy="952500"/>
+          </a:xfrm>
+          <a:prstGeom xmlns:a="http://schemas.openxmlformats.org/drawingml/2006/main" prst="rect">
+            <a:avLst/>
+          </a:prstGeom>
+        </p:spPr>
+      </p:pic>
+      <p:sp>
+        <p:nvSpPr>
+          <p:cNvPr id="3" name="">
             <a:extLst xmlns:a="http://schemas.openxmlformats.org/drawingml/2006/main">
               <a:ext uri="{FF2B5EF4-FFF2-40B4-BE49-F238E27FC236}">
-                <a16:creationId xmlns:a16="http://schemas.microsoft.com/office/drawing/2014/main" id="{EDB86DF7-06DD-4D5C-9EFE-A598175D4613}"/>
+                <a16:creationId xmlns:a16="http://schemas.microsoft.com/office/drawing/2014/main" id="{00B0CF48-A0F2-4292-9DD5-2F562C57270F}"/>
               </a:ext>
             </a:extLst>
           </p:cNvPr>
@@ -3507,8 +3434,8 @@
         </p:nvSpPr>
         <p:spPr>
           <a:xfrm xmlns:a="http://schemas.openxmlformats.org/drawingml/2006/main">
-            <a:off x="685800" y="1809750"/>
-            <a:ext cx="5010150" cy="666750"/>
+            <a:off x="685800" y="2095500"/>
+            <a:ext cx="10820400" cy="762000"/>
           </a:xfrm>
           <a:prstGeom xmlns:a="http://schemas.openxmlformats.org/drawingml/2006/main" prst="rect">
             <a:avLst/>
@@ -3526,12 +3453,12 @@
           <a:p xmlns:a="http://schemas.openxmlformats.org/drawingml/2006/main">
             <a:pPr>
               <a:lnSpc>
-                <a:spcPct val="118000"/>
+                <a:spcPct val="115000"/>
               </a:lnSpc>
               <a:buNone/>
-              <a:defRPr sz="2175" b="1">
-                <a:solidFill>
-                  <a:srgbClr val="126C97"/>
+              <a:defRPr sz="3225" b="1">
+                <a:solidFill>
+                  <a:srgbClr val="111111"/>
                 </a:solidFill>
                 <a:latin typeface="Liberation Sans"/>
                 <a:ea typeface="Liberation Sans"/>
@@ -3539,25 +3466,25 @@
               </a:defRPr>
             </a:pPr>
             <a:r>
-              <a:rPr sz="2175" b="1">
-                <a:solidFill>
-                  <a:srgbClr val="126C97"/>
+              <a:rPr sz="3225" b="1">
+                <a:solidFill>
+                  <a:srgbClr val="111111"/>
                 </a:solidFill>
                 <a:latin typeface="Liberation Sans"/>
                 <a:ea typeface="Liberation Sans"/>
                 <a:cs typeface="Liberation Sans"/>
               </a:rPr>
-              <a:t>Solana: demonstrated</a:t>
-            </a:r>
-          </a:p>
-        </p:txBody>
-      </p:sp>
-      <p:sp>
-        <p:nvSpPr>
-          <p:cNvPr id="3" name="">
+              <a:t>Will a buyer pay repeatedly?</a:t>
+            </a:r>
+          </a:p>
+        </p:txBody>
+      </p:sp>
+      <p:sp>
+        <p:nvSpPr>
+          <p:cNvPr id="4" name="">
             <a:extLst xmlns:a="http://schemas.openxmlformats.org/drawingml/2006/main">
               <a:ext uri="{FF2B5EF4-FFF2-40B4-BE49-F238E27FC236}">
-                <a16:creationId xmlns:a16="http://schemas.microsoft.com/office/drawing/2014/main" id="{A2653A6F-76EB-4548-AD77-89CC759E8570}"/>
+                <a16:creationId xmlns:a16="http://schemas.microsoft.com/office/drawing/2014/main" id="{2507821C-7DFB-42E6-9668-7EBEE2FDB4CC}"/>
               </a:ext>
             </a:extLst>
           </p:cNvPr>
@@ -3568,8 +3495,8 @@
         </p:nvSpPr>
         <p:spPr>
           <a:xfrm xmlns:a="http://schemas.openxmlformats.org/drawingml/2006/main">
-            <a:off x="685800" y="2647950"/>
-            <a:ext cx="4895850" cy="1162050"/>
+            <a:off x="685800" y="3152775"/>
+            <a:ext cx="10668000" cy="876300"/>
           </a:xfrm>
           <a:prstGeom xmlns:a="http://schemas.openxmlformats.org/drawingml/2006/main" prst="rect">
             <a:avLst/>
@@ -3587,12 +3514,12 @@
           <a:p xmlns:a="http://schemas.openxmlformats.org/drawingml/2006/main">
             <a:pPr>
               <a:lnSpc>
-                <a:spcPct val="118000"/>
+                <a:spcPct val="115000"/>
               </a:lnSpc>
               <a:buNone/>
-              <a:defRPr sz="2100" b="0">
-                <a:solidFill>
-                  <a:srgbClr val="17364D"/>
+              <a:defRPr sz="2175" b="0">
+                <a:solidFill>
+                  <a:srgbClr val="111111"/>
                 </a:solidFill>
                 <a:latin typeface="Liberation Sans"/>
                 <a:ea typeface="Liberation Sans"/>
@@ -3600,25 +3527,25 @@
               </a:defRPr>
             </a:pPr>
             <a:r>
-              <a:rPr sz="2100" b="0">
-                <a:solidFill>
-                  <a:srgbClr val="17364D"/>
+              <a:rPr sz="2175" b="0">
+                <a:solidFill>
+                  <a:srgbClr val="111111"/>
                 </a:solidFill>
                 <a:latin typeface="Liberation Sans"/>
                 <a:ea typeface="Liberation Sans"/>
                 <a:cs typeface="Liberation Sans"/>
               </a:rPr>
-              <a:t>Bounded Devnet payment and an original device-signed answer.</a:t>
-            </a:r>
-          </a:p>
-        </p:txBody>
-      </p:sp>
-      <p:sp>
-        <p:nvSpPr>
-          <p:cNvPr id="4" name="">
+              <a:t>Buyer hypothesis: software teams that already pay for remote checks.</a:t>
+            </a:r>
+          </a:p>
+        </p:txBody>
+      </p:sp>
+      <p:sp>
+        <p:nvSpPr>
+          <p:cNvPr id="5" name="">
             <a:extLst xmlns:a="http://schemas.openxmlformats.org/drawingml/2006/main">
               <a:ext uri="{FF2B5EF4-FFF2-40B4-BE49-F238E27FC236}">
-                <a16:creationId xmlns:a16="http://schemas.microsoft.com/office/drawing/2014/main" id="{F4AA4F36-7F39-45F1-ABA8-E1A79CB962D8}"/>
+                <a16:creationId xmlns:a16="http://schemas.microsoft.com/office/drawing/2014/main" id="{DDA3EAA3-70C0-4ED5-8C65-4A8263B5FE4B}"/>
               </a:ext>
             </a:extLst>
           </p:cNvPr>
@@ -3629,8 +3556,8 @@
         </p:nvSpPr>
         <p:spPr>
           <a:xfrm xmlns:a="http://schemas.openxmlformats.org/drawingml/2006/main">
-            <a:off x="685800" y="4000500"/>
-            <a:ext cx="4895850" cy="1295400"/>
+            <a:off x="685800" y="4181475"/>
+            <a:ext cx="10820400" cy="619125"/>
           </a:xfrm>
           <a:prstGeom xmlns:a="http://schemas.openxmlformats.org/drawingml/2006/main" prst="rect">
             <a:avLst/>
@@ -3648,12 +3575,12 @@
           <a:p xmlns:a="http://schemas.openxmlformats.org/drawingml/2006/main">
             <a:pPr>
               <a:lnSpc>
-                <a:spcPct val="118000"/>
+                <a:spcPct val="115000"/>
               </a:lnSpc>
               <a:buNone/>
-              <a:defRPr sz="1725" b="0">
-                <a:solidFill>
-                  <a:srgbClr val="536D80"/>
+              <a:defRPr sz="2175" b="0">
+                <a:solidFill>
+                  <a:srgbClr val="111111"/>
                 </a:solidFill>
                 <a:latin typeface="Liberation Sans"/>
                 <a:ea typeface="Liberation Sans"/>
@@ -3661,25 +3588,25 @@
               </a:defRPr>
             </a:pPr>
             <a:r>
-              <a:rPr sz="1725" b="0">
-                <a:solidFill>
-                  <a:srgbClr val="536D80"/>
+              <a:rPr sz="2175" b="0">
+                <a:solidFill>
+                  <a:srgbClr val="111111"/>
                 </a:solidFill>
                 <a:latin typeface="Liberation Sans"/>
                 <a:ea typeface="Liberation Sans"/>
                 <a:cs typeface="Liberation Sans"/>
               </a:rPr>
-              <a:t>The public replay preserves the October 12 job and its original capture time.</a:t>
-            </a:r>
-          </a:p>
-        </p:txBody>
-      </p:sp>
-      <p:sp>
-        <p:nvSpPr>
-          <p:cNvPr id="5" name="">
+              <a:t>Next test: one operator and one recurring question.</a:t>
+            </a:r>
+          </a:p>
+        </p:txBody>
+      </p:sp>
+      <p:sp>
+        <p:nvSpPr>
+          <p:cNvPr id="6" name="">
             <a:extLst xmlns:a="http://schemas.openxmlformats.org/drawingml/2006/main">
               <a:ext uri="{FF2B5EF4-FFF2-40B4-BE49-F238E27FC236}">
-                <a16:creationId xmlns:a16="http://schemas.microsoft.com/office/drawing/2014/main" id="{22C798D7-7D19-415B-AC38-B83C1CE911B0}"/>
+                <a16:creationId xmlns:a16="http://schemas.microsoft.com/office/drawing/2014/main" id="{DFE4E6FE-BE33-4BF3-9D70-DF62CD7C65B1}"/>
               </a:ext>
             </a:extLst>
           </p:cNvPr>
@@ -3690,8 +3617,8 @@
         </p:nvSpPr>
         <p:spPr>
           <a:xfrm xmlns:a="http://schemas.openxmlformats.org/drawingml/2006/main">
-            <a:off x="6496050" y="1809750"/>
-            <a:ext cx="5010150" cy="666750"/>
+            <a:off x="685800" y="4933950"/>
+            <a:ext cx="10820400" cy="619125"/>
           </a:xfrm>
           <a:prstGeom xmlns:a="http://schemas.openxmlformats.org/drawingml/2006/main" prst="rect">
             <a:avLst/>
@@ -3709,12 +3636,12 @@
           <a:p xmlns:a="http://schemas.openxmlformats.org/drawingml/2006/main">
             <a:pPr>
               <a:lnSpc>
-                <a:spcPct val="118000"/>
+                <a:spcPct val="115000"/>
               </a:lnSpc>
               <a:buNone/>
-              <a:defRPr sz="2175" b="1">
-                <a:solidFill>
-                  <a:srgbClr val="126C97"/>
+              <a:defRPr sz="2175" b="0">
+                <a:solidFill>
+                  <a:srgbClr val="111111"/>
                 </a:solidFill>
                 <a:latin typeface="Liberation Sans"/>
                 <a:ea typeface="Liberation Sans"/>
@@ -3722,25 +3649,25 @@
               </a:defRPr>
             </a:pPr>
             <a:r>
-              <a:rPr sz="2175" b="1">
-                <a:solidFill>
-                  <a:srgbClr val="126C97"/>
+              <a:rPr sz="2175" b="0">
+                <a:solidFill>
+                  <a:srgbClr val="111111"/>
                 </a:solidFill>
                 <a:latin typeface="Liberation Sans"/>
                 <a:ea typeface="Liberation Sans"/>
                 <a:cs typeface="Liberation Sans"/>
               </a:rPr>
-              <a:t>peaq Agung: verified</a:t>
-            </a:r>
-          </a:p>
-        </p:txBody>
-      </p:sp>
-      <p:sp>
-        <p:nvSpPr>
-          <p:cNvPr id="6" name="">
+              <a:t>Revenue hypothesis: integration and per-check fees.</a:t>
+            </a:r>
+          </a:p>
+        </p:txBody>
+      </p:sp>
+      <p:sp>
+        <p:nvSpPr>
+          <p:cNvPr id="7" name="">
             <a:extLst xmlns:a="http://schemas.openxmlformats.org/drawingml/2006/main">
               <a:ext uri="{FF2B5EF4-FFF2-40B4-BE49-F238E27FC236}">
-                <a16:creationId xmlns:a16="http://schemas.microsoft.com/office/drawing/2014/main" id="{BA1C4157-4CC7-4145-9603-248218084465}"/>
+                <a16:creationId xmlns:a16="http://schemas.microsoft.com/office/drawing/2014/main" id="{85AA6EB4-76EF-43A6-AD4F-62663A18A756}"/>
               </a:ext>
             </a:extLst>
           </p:cNvPr>
@@ -3751,8 +3678,8 @@
         </p:nvSpPr>
         <p:spPr>
           <a:xfrm xmlns:a="http://schemas.openxmlformats.org/drawingml/2006/main">
-            <a:off x="6496050" y="2647950"/>
-            <a:ext cx="4895850" cy="1162050"/>
+            <a:off x="685800" y="5886450"/>
+            <a:ext cx="10820400" cy="523875"/>
           </a:xfrm>
           <a:prstGeom xmlns:a="http://schemas.openxmlformats.org/drawingml/2006/main" prst="rect">
             <a:avLst/>
@@ -3770,12 +3697,12 @@
           <a:p xmlns:a="http://schemas.openxmlformats.org/drawingml/2006/main">
             <a:pPr>
               <a:lnSpc>
-                <a:spcPct val="118000"/>
+                <a:spcPct val="115000"/>
               </a:lnSpc>
               <a:buNone/>
-              <a:defRPr sz="2100" b="0">
-                <a:solidFill>
-                  <a:srgbClr val="17364D"/>
+              <a:defRPr sz="1575" b="0">
+                <a:solidFill>
+                  <a:srgbClr val="555555"/>
                 </a:solidFill>
                 <a:latin typeface="Liberation Sans"/>
                 <a:ea typeface="Liberation Sans"/>
@@ -3783,198 +3710,15 @@
               </a:defRPr>
             </a:pPr>
             <a:r>
-              <a:rPr sz="2100" b="0">
-                <a:solidFill>
-                  <a:srgbClr val="17364D"/>
+              <a:rPr sz="1575" b="0">
+                <a:solidFill>
+                  <a:srgbClr val="555555"/>
                 </a:solidFill>
                 <a:latin typeface="Liberation Sans"/>
                 <a:ea typeface="Liberation Sans"/>
                 <a:cs typeface="Liberation Sans"/>
               </a:rPr>
-              <a:t>A machine identity binds the offered service to its device key.</a:t>
-            </a:r>
-          </a:p>
-        </p:txBody>
-      </p:sp>
-      <p:sp>
-        <p:nvSpPr>
-          <p:cNvPr id="7" name="">
-            <a:extLst xmlns:a="http://schemas.openxmlformats.org/drawingml/2006/main">
-              <a:ext uri="{FF2B5EF4-FFF2-40B4-BE49-F238E27FC236}">
-                <a16:creationId xmlns:a16="http://schemas.microsoft.com/office/drawing/2014/main" id="{9156A9B7-7967-436E-A82D-BF33D4F6AADE}"/>
-              </a:ext>
-            </a:extLst>
-          </p:cNvPr>
-          <p:cNvSpPr>
-            <a:spLocks xmlns:a="http://schemas.openxmlformats.org/drawingml/2006/main" noGrp="1"/>
-          </p:cNvSpPr>
-          <p:nvPr/>
-        </p:nvSpPr>
-        <p:spPr>
-          <a:xfrm xmlns:a="http://schemas.openxmlformats.org/drawingml/2006/main">
-            <a:off x="6496050" y="4000500"/>
-            <a:ext cx="4895850" cy="1295400"/>
-          </a:xfrm>
-          <a:prstGeom xmlns:a="http://schemas.openxmlformats.org/drawingml/2006/main" prst="rect">
-            <a:avLst/>
-          </a:prstGeom>
-          <a:noFill xmlns:a="http://schemas.openxmlformats.org/drawingml/2006/main"/>
-          <a:ln xmlns:a="http://schemas.openxmlformats.org/drawingml/2006/main" w="0">
-            <a:noFill/>
-          </a:ln>
-        </p:spPr>
-        <p:txBody>
-          <a:bodyPr xmlns:a="http://schemas.openxmlformats.org/drawingml/2006/main" lIns="0" tIns="0" rIns="0" bIns="0" anchor="t">
-            <a:noAutofit/>
-          </a:bodyPr>
-          <a:lstStyle xmlns:a="http://schemas.openxmlformats.org/drawingml/2006/main"/>
-          <a:p xmlns:a="http://schemas.openxmlformats.org/drawingml/2006/main">
-            <a:pPr>
-              <a:lnSpc>
-                <a:spcPct val="118000"/>
-              </a:lnSpc>
-              <a:buNone/>
-              <a:defRPr sz="2100" b="0">
-                <a:solidFill>
-                  <a:srgbClr val="17364D"/>
-                </a:solidFill>
-                <a:latin typeface="Liberation Sans"/>
-                <a:ea typeface="Liberation Sans"/>
-                <a:cs typeface="Liberation Sans"/>
-              </a:defRPr>
-            </a:pPr>
-            <a:r>
-              <a:rPr sz="2100" b="0">
-                <a:solidFill>
-                  <a:srgbClr val="17364D"/>
-                </a:solidFill>
-                <a:latin typeface="Liberation Sans"/>
-                <a:ea typeface="Liberation Sans"/>
-                <a:cs typeface="Liberation Sans"/>
-              </a:rPr>
-              <a:t>A finalized native Storage record links the unchanged job hash.</a:t>
-            </a:r>
-          </a:p>
-        </p:txBody>
-      </p:sp>
-      <p:sp>
-        <p:nvSpPr>
-          <p:cNvPr id="8" name="">
-            <a:extLst xmlns:a="http://schemas.openxmlformats.org/drawingml/2006/main">
-              <a:ext uri="{FF2B5EF4-FFF2-40B4-BE49-F238E27FC236}">
-                <a16:creationId xmlns:a16="http://schemas.microsoft.com/office/drawing/2014/main" id="{FF4D7D35-24C9-40BC-84B6-D5DE0EA65F79}"/>
-              </a:ext>
-            </a:extLst>
-          </p:cNvPr>
-          <p:cNvSpPr>
-            <a:spLocks xmlns:a="http://schemas.openxmlformats.org/drawingml/2006/main" noGrp="1"/>
-          </p:cNvSpPr>
-          <p:nvPr/>
-        </p:nvSpPr>
-        <p:spPr>
-          <a:xfrm xmlns:a="http://schemas.openxmlformats.org/drawingml/2006/main">
-            <a:off x="685800" y="5505450"/>
-            <a:ext cx="10820400" cy="590550"/>
-          </a:xfrm>
-          <a:prstGeom xmlns:a="http://schemas.openxmlformats.org/drawingml/2006/main" prst="rect">
-            <a:avLst/>
-          </a:prstGeom>
-          <a:noFill xmlns:a="http://schemas.openxmlformats.org/drawingml/2006/main"/>
-          <a:ln xmlns:a="http://schemas.openxmlformats.org/drawingml/2006/main" w="0">
-            <a:noFill/>
-          </a:ln>
-        </p:spPr>
-        <p:txBody>
-          <a:bodyPr xmlns:a="http://schemas.openxmlformats.org/drawingml/2006/main" lIns="0" tIns="0" rIns="0" bIns="0" anchor="t">
-            <a:noAutofit/>
-          </a:bodyPr>
-          <a:lstStyle xmlns:a="http://schemas.openxmlformats.org/drawingml/2006/main"/>
-          <a:p xmlns:a="http://schemas.openxmlformats.org/drawingml/2006/main">
-            <a:pPr>
-              <a:lnSpc>
-                <a:spcPct val="118000"/>
-              </a:lnSpc>
-              <a:buNone/>
-              <a:defRPr sz="1875" b="0">
-                <a:solidFill>
-                  <a:srgbClr val="126C97"/>
-                </a:solidFill>
-                <a:latin typeface="Liberation Sans"/>
-                <a:ea typeface="Liberation Sans"/>
-                <a:cs typeface="Liberation Sans"/>
-              </a:defRPr>
-            </a:pPr>
-            <a:r>
-              <a:rPr sz="1875" b="0">
-                <a:solidFill>
-                  <a:srgbClr val="126C97"/>
-                </a:solidFill>
-                <a:latin typeface="Liberation Sans"/>
-                <a:ea typeface="Liberation Sans"/>
-                <a:cs typeface="Liberation Sans"/>
-              </a:rPr>
-              <a:t>Next: one authorized operator, one repeated question, and a comparison with its current process.</a:t>
-            </a:r>
-          </a:p>
-        </p:txBody>
-      </p:sp>
-      <p:sp>
-        <p:nvSpPr>
-          <p:cNvPr id="9" name="">
-            <a:extLst xmlns:a="http://schemas.openxmlformats.org/drawingml/2006/main">
-              <a:ext uri="{FF2B5EF4-FFF2-40B4-BE49-F238E27FC236}">
-                <a16:creationId xmlns:a16="http://schemas.microsoft.com/office/drawing/2014/main" id="{DCECA491-FDD6-4553-AB75-D5580F727B6B}"/>
-              </a:ext>
-            </a:extLst>
-          </p:cNvPr>
-          <p:cNvSpPr>
-            <a:spLocks xmlns:a="http://schemas.openxmlformats.org/drawingml/2006/main" noGrp="1"/>
-          </p:cNvSpPr>
-          <p:nvPr/>
-        </p:nvSpPr>
-        <p:spPr>
-          <a:xfrm xmlns:a="http://schemas.openxmlformats.org/drawingml/2006/main">
-            <a:off x="685800" y="6276975"/>
-            <a:ext cx="10820400" cy="419100"/>
-          </a:xfrm>
-          <a:prstGeom xmlns:a="http://schemas.openxmlformats.org/drawingml/2006/main" prst="rect">
-            <a:avLst/>
-          </a:prstGeom>
-          <a:noFill xmlns:a="http://schemas.openxmlformats.org/drawingml/2006/main"/>
-          <a:ln xmlns:a="http://schemas.openxmlformats.org/drawingml/2006/main" w="0">
-            <a:noFill/>
-          </a:ln>
-        </p:spPr>
-        <p:txBody>
-          <a:bodyPr xmlns:a="http://schemas.openxmlformats.org/drawingml/2006/main" lIns="0" tIns="0" rIns="0" bIns="0" anchor="t">
-            <a:noAutofit/>
-          </a:bodyPr>
-          <a:lstStyle xmlns:a="http://schemas.openxmlformats.org/drawingml/2006/main"/>
-          <a:p xmlns:a="http://schemas.openxmlformats.org/drawingml/2006/main">
-            <a:pPr>
-              <a:lnSpc>
-                <a:spcPct val="118000"/>
-              </a:lnSpc>
-              <a:buNone/>
-              <a:defRPr sz="1350" b="0">
-                <a:solidFill>
-                  <a:srgbClr val="536D80"/>
-                </a:solidFill>
-                <a:latin typeface="Liberation Sans"/>
-                <a:ea typeface="Liberation Sans"/>
-                <a:cs typeface="Liberation Sans"/>
-              </a:defRPr>
-            </a:pPr>
-            <a:r>
-              <a:rPr sz="1350" b="0">
-                <a:solidFill>
-                  <a:srgbClr val="536D80"/>
-                </a:solidFill>
-                <a:latin typeface="Liberation Sans"/>
-                <a:ea typeface="Liberation Sans"/>
-                <a:cs typeface="Liberation Sans"/>
-              </a:rPr>
-              <a:t>05 / Real Agung identity and Storage readbacks. Customer demand remains unvalidated.</a:t>
+              <a:t>The network, customer demand, and reputation remain unvalidated.</a:t>
             </a:r>
           </a:p>
         </p:txBody>
@@ -3982,7 +3726,7 @@
     </p:spTree>
     <p:extLst>
       <p:ext uri="{BB962C8B-B14F-4D97-AF65-F5344CB8AC3E}">
-        <p14:creationId xmlns:p14="http://schemas.microsoft.com/office/powerpoint/2010/main" val="398696374"/>
+        <p14:creationId xmlns:p14="http://schemas.microsoft.com/office/powerpoint/2010/main" val="139742060"/>
       </p:ext>
     </p:extLst>
   </p:cSld>

</xml_diff>

<commit_message>
copy: state the pilot plan clearly in the pitch and review
</commit_message>
<xml_diff>
--- a/docs/competition/fieldproof-pitch.pptx
+++ b/docs/competition/fieldproof-pitch.pptx
@@ -2,17 +2,17 @@
 <file path=ppt/presentation.xml><?xml version="1.0" encoding="utf-8"?>
 <p:presentation xmlns:p="http://schemas.openxmlformats.org/presentationml/2006/main">
   <p:sldMasterIdLst>
-    <p:sldMasterId xmlns:r="http://schemas.openxmlformats.org/officeDocument/2006/relationships" id="2147483648" r:id="Rad932027e67345d1"/>
+    <p:sldMasterId xmlns:r="http://schemas.openxmlformats.org/officeDocument/2006/relationships" id="2147483648" r:id="R0e8842d58eec4758"/>
   </p:sldMasterIdLst>
   <p:notesMasterIdLst>
-    <p:notesMasterId xmlns:r="http://schemas.openxmlformats.org/officeDocument/2006/relationships" r:id="R9717f12da3ed4360"/>
+    <p:notesMasterId xmlns:r="http://schemas.openxmlformats.org/officeDocument/2006/relationships" r:id="R4a991b03d9124940"/>
   </p:notesMasterIdLst>
   <p:sldIdLst>
-    <p:sldId xmlns:r="http://schemas.openxmlformats.org/officeDocument/2006/relationships" id="256" r:id="Ree86c22933ad40f2"/>
-    <p:sldId xmlns:r="http://schemas.openxmlformats.org/officeDocument/2006/relationships" id="257" r:id="R3c0cdab536b44258"/>
-    <p:sldId xmlns:r="http://schemas.openxmlformats.org/officeDocument/2006/relationships" id="258" r:id="Rf269fe350e0442bb"/>
-    <p:sldId xmlns:r="http://schemas.openxmlformats.org/officeDocument/2006/relationships" id="259" r:id="Read9203d2f5443ac"/>
-    <p:sldId xmlns:r="http://schemas.openxmlformats.org/officeDocument/2006/relationships" id="260" r:id="Rff1a3ccf8c0f472f"/>
+    <p:sldId xmlns:r="http://schemas.openxmlformats.org/officeDocument/2006/relationships" id="256" r:id="R6c8d6ff344bf4c0f"/>
+    <p:sldId xmlns:r="http://schemas.openxmlformats.org/officeDocument/2006/relationships" id="257" r:id="R6cbdf384c86241c3"/>
+    <p:sldId xmlns:r="http://schemas.openxmlformats.org/officeDocument/2006/relationships" id="258" r:id="R851a0ad753d943ac"/>
+    <p:sldId xmlns:r="http://schemas.openxmlformats.org/officeDocument/2006/relationships" id="259" r:id="R1759c4a77057461e"/>
+    <p:sldId xmlns:r="http://schemas.openxmlformats.org/officeDocument/2006/relationships" id="260" r:id="R8dcb748fa1ab4d5e"/>
   </p:sldIdLst>
   <p:sldSz cx="12192000" cy="6858000"/>
   <p:notesSz cx="6858000" cy="9144000"/>
@@ -794,7 +794,7 @@
   </p:cSld>
   <p:clrMap bg1="lt1" tx1="dk1" bg2="lt2" tx2="dk2" accent1="accent1" accent2="accent2" accent3="accent3" accent4="accent4" accent5="accent5" accent6="accent6" hlink="hlink" folHlink="folHlink"/>
   <p:sldLayoutIdLst>
-    <p:sldLayoutId xmlns:r="http://schemas.openxmlformats.org/officeDocument/2006/relationships" id="2147483649" r:id="Rdf191859f87f4955"/>
+    <p:sldLayoutId xmlns:r="http://schemas.openxmlformats.org/officeDocument/2006/relationships" id="2147483649" r:id="R3ea2c05650e04666"/>
   </p:sldLayoutIdLst>
   <p:txStyles>
     <p:titleStyle>
@@ -1345,7 +1345,7 @@
           <p:cNvPr id="3" name="">
             <a:extLst xmlns:a="http://schemas.openxmlformats.org/drawingml/2006/main">
               <a:ext uri="{FF2B5EF4-FFF2-40B4-BE49-F238E27FC236}">
-                <a16:creationId xmlns:a16="http://schemas.microsoft.com/office/drawing/2014/main" id="{CADA974E-C978-43D5-936E-8D128C594A3D}"/>
+                <a16:creationId xmlns:a16="http://schemas.microsoft.com/office/drawing/2014/main" id="{6A1119C0-88C4-4A5B-A6BA-B63116203E57}"/>
               </a:ext>
             </a:extLst>
           </p:cNvPr>
@@ -1406,7 +1406,7 @@
           <p:cNvPr id="2" name="">
             <a:extLst xmlns:a="http://schemas.openxmlformats.org/drawingml/2006/main">
               <a:ext uri="{FF2B5EF4-FFF2-40B4-BE49-F238E27FC236}">
-                <a16:creationId xmlns:a16="http://schemas.microsoft.com/office/drawing/2014/main" id="{8179D66A-471E-4F32-9AE0-03E057D0DE4E}"/>
+                <a16:creationId xmlns:a16="http://schemas.microsoft.com/office/drawing/2014/main" id="{79A8803F-D5C7-4C9E-81B2-2A983C1CE8EA}"/>
               </a:ext>
             </a:extLst>
           </p:cNvPr>
@@ -1492,7 +1492,7 @@
     </p:spTree>
     <p:extLst>
       <p:ext uri="{BB962C8B-B14F-4D97-AF65-F5344CB8AC3E}">
-        <p14:creationId xmlns:p14="http://schemas.microsoft.com/office/powerpoint/2010/main" val="171500543"/>
+        <p14:creationId xmlns:p14="http://schemas.microsoft.com/office/powerpoint/2010/main" val="65740343"/>
       </p:ext>
     </p:extLst>
   </p:cSld>
@@ -1523,7 +1523,7 @@
           <p:cNvPr id="10" name="">
             <a:extLst xmlns:a="http://schemas.openxmlformats.org/drawingml/2006/main">
               <a:ext uri="{FF2B5EF4-FFF2-40B4-BE49-F238E27FC236}">
-                <a16:creationId xmlns:a16="http://schemas.microsoft.com/office/drawing/2014/main" id="{1EFE8D5C-0C7A-4EDB-9B68-CADBC315AEED}"/>
+                <a16:creationId xmlns:a16="http://schemas.microsoft.com/office/drawing/2014/main" id="{2FA673ED-792E-4A67-851B-46686A73794B}"/>
               </a:ext>
             </a:extLst>
           </p:cNvPr>
@@ -1584,7 +1584,7 @@
           <p:cNvPr id="2" name="">
             <a:extLst xmlns:a="http://schemas.openxmlformats.org/drawingml/2006/main">
               <a:ext uri="{FF2B5EF4-FFF2-40B4-BE49-F238E27FC236}">
-                <a16:creationId xmlns:a16="http://schemas.microsoft.com/office/drawing/2014/main" id="{8FAC85EC-D51B-47F2-B449-DF69AFD70E3C}"/>
+                <a16:creationId xmlns:a16="http://schemas.microsoft.com/office/drawing/2014/main" id="{921D1066-FB80-4508-9148-3932BCAC5922}"/>
               </a:ext>
             </a:extLst>
           </p:cNvPr>
@@ -1645,7 +1645,7 @@
           <p:cNvPr id="3" name="">
             <a:extLst xmlns:a="http://schemas.openxmlformats.org/drawingml/2006/main">
               <a:ext uri="{FF2B5EF4-FFF2-40B4-BE49-F238E27FC236}">
-                <a16:creationId xmlns:a16="http://schemas.microsoft.com/office/drawing/2014/main" id="{45DBA91D-C6E1-4188-A6C5-9283E1510A9A}"/>
+                <a16:creationId xmlns:a16="http://schemas.microsoft.com/office/drawing/2014/main" id="{65C8DBD0-58DA-4B9B-95AB-CF89364B77CF}"/>
               </a:ext>
             </a:extLst>
           </p:cNvPr>
@@ -1706,7 +1706,7 @@
           <p:cNvPr id="4" name="">
             <a:extLst xmlns:a="http://schemas.openxmlformats.org/drawingml/2006/main">
               <a:ext uri="{FF2B5EF4-FFF2-40B4-BE49-F238E27FC236}">
-                <a16:creationId xmlns:a16="http://schemas.microsoft.com/office/drawing/2014/main" id="{3D3F6296-40C3-4A78-85A0-D543495038C1}"/>
+                <a16:creationId xmlns:a16="http://schemas.microsoft.com/office/drawing/2014/main" id="{9BBD911E-7711-4F63-AB84-D315F603B597}"/>
               </a:ext>
             </a:extLst>
           </p:cNvPr>
@@ -1767,7 +1767,7 @@
           <p:cNvPr id="5" name="">
             <a:extLst xmlns:a="http://schemas.openxmlformats.org/drawingml/2006/main">
               <a:ext uri="{FF2B5EF4-FFF2-40B4-BE49-F238E27FC236}">
-                <a16:creationId xmlns:a16="http://schemas.microsoft.com/office/drawing/2014/main" id="{22339FCC-93E6-4378-8676-FED173C3A20D}"/>
+                <a16:creationId xmlns:a16="http://schemas.microsoft.com/office/drawing/2014/main" id="{1E7C93EA-4908-4C2B-B0AF-3FFDDBECA2BF}"/>
               </a:ext>
             </a:extLst>
           </p:cNvPr>
@@ -1828,7 +1828,7 @@
           <p:cNvPr id="6" name="">
             <a:extLst xmlns:a="http://schemas.openxmlformats.org/drawingml/2006/main">
               <a:ext uri="{FF2B5EF4-FFF2-40B4-BE49-F238E27FC236}">
-                <a16:creationId xmlns:a16="http://schemas.microsoft.com/office/drawing/2014/main" id="{981B916E-0263-46DB-9400-8E8859C10A23}"/>
+                <a16:creationId xmlns:a16="http://schemas.microsoft.com/office/drawing/2014/main" id="{F34C0989-70C6-4225-BBD7-482A32E96058}"/>
               </a:ext>
             </a:extLst>
           </p:cNvPr>
@@ -1889,7 +1889,7 @@
           <p:cNvPr id="7" name="">
             <a:extLst xmlns:a="http://schemas.openxmlformats.org/drawingml/2006/main">
               <a:ext uri="{FF2B5EF4-FFF2-40B4-BE49-F238E27FC236}">
-                <a16:creationId xmlns:a16="http://schemas.microsoft.com/office/drawing/2014/main" id="{B91B2A95-0B54-4E1E-B32F-A4D4AB4575E3}"/>
+                <a16:creationId xmlns:a16="http://schemas.microsoft.com/office/drawing/2014/main" id="{CAFC9349-4599-497C-A995-6F5ED724CA2F}"/>
               </a:ext>
             </a:extLst>
           </p:cNvPr>
@@ -1950,7 +1950,7 @@
           <p:cNvPr id="8" name="">
             <a:extLst xmlns:a="http://schemas.openxmlformats.org/drawingml/2006/main">
               <a:ext uri="{FF2B5EF4-FFF2-40B4-BE49-F238E27FC236}">
-                <a16:creationId xmlns:a16="http://schemas.microsoft.com/office/drawing/2014/main" id="{1ACCFC56-B1FF-41D0-8ED8-A17F569AE311}"/>
+                <a16:creationId xmlns:a16="http://schemas.microsoft.com/office/drawing/2014/main" id="{707DBDA2-B70C-4773-B404-0E1A6F290C53}"/>
               </a:ext>
             </a:extLst>
           </p:cNvPr>
@@ -2011,7 +2011,7 @@
           <p:cNvPr id="9" name="">
             <a:extLst xmlns:a="http://schemas.openxmlformats.org/drawingml/2006/main">
               <a:ext uri="{FF2B5EF4-FFF2-40B4-BE49-F238E27FC236}">
-                <a16:creationId xmlns:a16="http://schemas.microsoft.com/office/drawing/2014/main" id="{EA8C6E58-C6AD-4C71-9E82-2566CEEFF812}"/>
+                <a16:creationId xmlns:a16="http://schemas.microsoft.com/office/drawing/2014/main" id="{5F541F41-0226-4554-AAE6-5787E42D9BB0}"/>
               </a:ext>
             </a:extLst>
           </p:cNvPr>
@@ -2062,7 +2062,7 @@
                 <a:ea typeface="Liberation Sans"/>
                 <a:cs typeface="Liberation Sans"/>
               </a:rPr>
-              <a:t>A common workflow across different device owners is the product hypothesis.</a:t>
+              <a:t>One paid check connects a software buyer and a device operator.</a:t>
             </a:r>
           </a:p>
         </p:txBody>
@@ -2070,7 +2070,7 @@
     </p:spTree>
     <p:extLst>
       <p:ext uri="{BB962C8B-B14F-4D97-AF65-F5344CB8AC3E}">
-        <p14:creationId xmlns:p14="http://schemas.microsoft.com/office/powerpoint/2010/main" val="2126693891"/>
+        <p14:creationId xmlns:p14="http://schemas.microsoft.com/office/powerpoint/2010/main" val="87196875"/>
       </p:ext>
     </p:extLst>
   </p:cSld>
@@ -2101,7 +2101,7 @@
           <p:cNvPr id="14" name="">
             <a:extLst xmlns:a="http://schemas.openxmlformats.org/drawingml/2006/main">
               <a:ext uri="{FF2B5EF4-FFF2-40B4-BE49-F238E27FC236}">
-                <a16:creationId xmlns:a16="http://schemas.microsoft.com/office/drawing/2014/main" id="{6B93A88D-F65A-4738-9ED7-09A3B56EF016}"/>
+                <a16:creationId xmlns:a16="http://schemas.microsoft.com/office/drawing/2014/main" id="{E656367C-E13E-4EA8-BC88-C1E17064C633}"/>
               </a:ext>
             </a:extLst>
           </p:cNvPr>
@@ -2166,7 +2166,7 @@
           <p:nvPr/>
         </p:nvPicPr>
         <p:blipFill>
-          <a:blip xmlns:r="http://schemas.openxmlformats.org/officeDocument/2006/relationships" xmlns:a="http://schemas.openxmlformats.org/drawingml/2006/main" r:embed="Rb662421ab2fb429e"/>
+          <a:blip xmlns:r="http://schemas.openxmlformats.org/officeDocument/2006/relationships" xmlns:a="http://schemas.openxmlformats.org/drawingml/2006/main" r:embed="R6a754d9efe3d4ae5"/>
           <a:stretch xmlns:a="http://schemas.openxmlformats.org/drawingml/2006/main"/>
         </p:blipFill>
         <p:spPr>
@@ -2184,7 +2184,7 @@
           <p:cNvPr id="3" name="">
             <a:extLst xmlns:a="http://schemas.openxmlformats.org/drawingml/2006/main">
               <a:ext uri="{FF2B5EF4-FFF2-40B4-BE49-F238E27FC236}">
-                <a16:creationId xmlns:a16="http://schemas.microsoft.com/office/drawing/2014/main" id="{60FE2999-A2AC-4FB0-8947-8FDDD1A4C774}"/>
+                <a16:creationId xmlns:a16="http://schemas.microsoft.com/office/drawing/2014/main" id="{6EC38F7F-0A95-4B98-A2F7-CE8455A847A8}"/>
               </a:ext>
             </a:extLst>
           </p:cNvPr>
@@ -2245,7 +2245,7 @@
           <p:cNvPr id="4" name="">
             <a:extLst xmlns:a="http://schemas.openxmlformats.org/drawingml/2006/main">
               <a:ext uri="{FF2B5EF4-FFF2-40B4-BE49-F238E27FC236}">
-                <a16:creationId xmlns:a16="http://schemas.microsoft.com/office/drawing/2014/main" id="{EBFEC9CF-DE00-4EAA-9A69-2B0B182A0DC9}"/>
+                <a16:creationId xmlns:a16="http://schemas.microsoft.com/office/drawing/2014/main" id="{39008448-9EA9-41D8-89E3-4070E339CB63}"/>
               </a:ext>
             </a:extLst>
           </p:cNvPr>
@@ -2306,7 +2306,7 @@
           <p:cNvPr id="5" name="">
             <a:extLst xmlns:a="http://schemas.openxmlformats.org/drawingml/2006/main">
               <a:ext uri="{FF2B5EF4-FFF2-40B4-BE49-F238E27FC236}">
-                <a16:creationId xmlns:a16="http://schemas.microsoft.com/office/drawing/2014/main" id="{D3C8118A-DFBE-4712-ADC8-CC89117EE287}"/>
+                <a16:creationId xmlns:a16="http://schemas.microsoft.com/office/drawing/2014/main" id="{1AE21889-BFF6-4CB6-AA86-91485D3CD9EE}"/>
               </a:ext>
             </a:extLst>
           </p:cNvPr>
@@ -2367,7 +2367,7 @@
           <p:cNvPr id="6" name="">
             <a:extLst xmlns:a="http://schemas.openxmlformats.org/drawingml/2006/main">
               <a:ext uri="{FF2B5EF4-FFF2-40B4-BE49-F238E27FC236}">
-                <a16:creationId xmlns:a16="http://schemas.microsoft.com/office/drawing/2014/main" id="{E4F936DB-D85D-4A73-9FFD-D3291DB50EEE}"/>
+                <a16:creationId xmlns:a16="http://schemas.microsoft.com/office/drawing/2014/main" id="{947648D7-5A07-475F-AC1E-F803D5245BE6}"/>
               </a:ext>
             </a:extLst>
           </p:cNvPr>
@@ -2428,7 +2428,7 @@
           <p:cNvPr id="7" name="">
             <a:extLst xmlns:a="http://schemas.openxmlformats.org/drawingml/2006/main">
               <a:ext uri="{FF2B5EF4-FFF2-40B4-BE49-F238E27FC236}">
-                <a16:creationId xmlns:a16="http://schemas.microsoft.com/office/drawing/2014/main" id="{2D3EECA0-3BB1-43D5-BCE3-B77975A2F35D}"/>
+                <a16:creationId xmlns:a16="http://schemas.microsoft.com/office/drawing/2014/main" id="{93BF8CD9-84A9-48F8-8887-C43507BDEFE4}"/>
               </a:ext>
             </a:extLst>
           </p:cNvPr>
@@ -2489,7 +2489,7 @@
           <p:cNvPr id="8" name="">
             <a:extLst xmlns:a="http://schemas.openxmlformats.org/drawingml/2006/main">
               <a:ext uri="{FF2B5EF4-FFF2-40B4-BE49-F238E27FC236}">
-                <a16:creationId xmlns:a16="http://schemas.microsoft.com/office/drawing/2014/main" id="{F8AFA449-06A4-433A-BCA0-B7EECD7012EF}"/>
+                <a16:creationId xmlns:a16="http://schemas.microsoft.com/office/drawing/2014/main" id="{66F13258-7C00-4D98-9ECB-2779D3F8992B}"/>
               </a:ext>
             </a:extLst>
           </p:cNvPr>
@@ -2550,7 +2550,7 @@
           <p:cNvPr id="9" name="">
             <a:extLst xmlns:a="http://schemas.openxmlformats.org/drawingml/2006/main">
               <a:ext uri="{FF2B5EF4-FFF2-40B4-BE49-F238E27FC236}">
-                <a16:creationId xmlns:a16="http://schemas.microsoft.com/office/drawing/2014/main" id="{932110BF-403E-453A-A8C8-D49FF69165C5}"/>
+                <a16:creationId xmlns:a16="http://schemas.microsoft.com/office/drawing/2014/main" id="{ECA99593-78C7-47BF-8ADB-90DE54EFC271}"/>
               </a:ext>
             </a:extLst>
           </p:cNvPr>
@@ -2611,7 +2611,7 @@
           <p:cNvPr id="10" name="">
             <a:extLst xmlns:a="http://schemas.openxmlformats.org/drawingml/2006/main">
               <a:ext uri="{FF2B5EF4-FFF2-40B4-BE49-F238E27FC236}">
-                <a16:creationId xmlns:a16="http://schemas.microsoft.com/office/drawing/2014/main" id="{C435BA18-3AD8-49F8-A2BE-40BB9F26A5AD}"/>
+                <a16:creationId xmlns:a16="http://schemas.microsoft.com/office/drawing/2014/main" id="{3581DF4B-D162-4402-8376-F1CCF3694D4C}"/>
               </a:ext>
             </a:extLst>
           </p:cNvPr>
@@ -2672,7 +2672,7 @@
           <p:cNvPr id="11" name="">
             <a:extLst xmlns:a="http://schemas.openxmlformats.org/drawingml/2006/main">
               <a:ext uri="{FF2B5EF4-FFF2-40B4-BE49-F238E27FC236}">
-                <a16:creationId xmlns:a16="http://schemas.microsoft.com/office/drawing/2014/main" id="{2E6706D0-EFA4-42D3-9B2A-BE3012318E08}"/>
+                <a16:creationId xmlns:a16="http://schemas.microsoft.com/office/drawing/2014/main" id="{345BE1FD-A5B8-4A87-BB61-C8EA2DA306C0}"/>
               </a:ext>
             </a:extLst>
           </p:cNvPr>
@@ -2733,7 +2733,7 @@
           <p:cNvPr id="12" name="">
             <a:extLst xmlns:a="http://schemas.openxmlformats.org/drawingml/2006/main">
               <a:ext uri="{FF2B5EF4-FFF2-40B4-BE49-F238E27FC236}">
-                <a16:creationId xmlns:a16="http://schemas.microsoft.com/office/drawing/2014/main" id="{6697C91D-DE4B-4266-A966-8E8EC22255B4}"/>
+                <a16:creationId xmlns:a16="http://schemas.microsoft.com/office/drawing/2014/main" id="{E164917E-2A2A-49CC-A492-9185BCD2ADEE}"/>
               </a:ext>
             </a:extLst>
           </p:cNvPr>
@@ -2794,7 +2794,7 @@
           <p:cNvPr id="13" name="">
             <a:extLst xmlns:a="http://schemas.openxmlformats.org/drawingml/2006/main">
               <a:ext uri="{FF2B5EF4-FFF2-40B4-BE49-F238E27FC236}">
-                <a16:creationId xmlns:a16="http://schemas.microsoft.com/office/drawing/2014/main" id="{7009E01F-8162-4D20-92B9-FB0ACAE4F808}"/>
+                <a16:creationId xmlns:a16="http://schemas.microsoft.com/office/drawing/2014/main" id="{57C679CA-B587-442C-BFE6-C47B54FF6C9B}"/>
               </a:ext>
             </a:extLst>
           </p:cNvPr>
@@ -2853,7 +2853,7 @@
     </p:spTree>
     <p:extLst>
       <p:ext uri="{BB962C8B-B14F-4D97-AF65-F5344CB8AC3E}">
-        <p14:creationId xmlns:p14="http://schemas.microsoft.com/office/powerpoint/2010/main" val="357328579"/>
+        <p14:creationId xmlns:p14="http://schemas.microsoft.com/office/powerpoint/2010/main" val="1484323260"/>
       </p:ext>
     </p:extLst>
   </p:cSld>
@@ -2884,7 +2884,7 @@
           <p:cNvPr id="8" name="">
             <a:extLst xmlns:a="http://schemas.openxmlformats.org/drawingml/2006/main">
               <a:ext uri="{FF2B5EF4-FFF2-40B4-BE49-F238E27FC236}">
-                <a16:creationId xmlns:a16="http://schemas.microsoft.com/office/drawing/2014/main" id="{731457B2-1DC3-4836-8A1D-979681C611D8}"/>
+                <a16:creationId xmlns:a16="http://schemas.microsoft.com/office/drawing/2014/main" id="{250D3E40-378F-462E-9240-F66765D7A212}"/>
               </a:ext>
             </a:extLst>
           </p:cNvPr>
@@ -2945,7 +2945,7 @@
           <p:cNvPr id="2" name="">
             <a:extLst xmlns:a="http://schemas.openxmlformats.org/drawingml/2006/main">
               <a:ext uri="{FF2B5EF4-FFF2-40B4-BE49-F238E27FC236}">
-                <a16:creationId xmlns:a16="http://schemas.microsoft.com/office/drawing/2014/main" id="{15B3A513-AD3D-40E4-B2F8-5E794AB80444}"/>
+                <a16:creationId xmlns:a16="http://schemas.microsoft.com/office/drawing/2014/main" id="{EFFCB0A7-3EEB-4094-942A-8430D52D66EA}"/>
               </a:ext>
             </a:extLst>
           </p:cNvPr>
@@ -3006,7 +3006,7 @@
           <p:cNvPr id="3" name="">
             <a:extLst xmlns:a="http://schemas.openxmlformats.org/drawingml/2006/main">
               <a:ext uri="{FF2B5EF4-FFF2-40B4-BE49-F238E27FC236}">
-                <a16:creationId xmlns:a16="http://schemas.microsoft.com/office/drawing/2014/main" id="{17631251-6971-49BF-B434-68942F09FEA4}"/>
+                <a16:creationId xmlns:a16="http://schemas.microsoft.com/office/drawing/2014/main" id="{61461F05-BF42-45AA-84E0-E7C7ECFECB23}"/>
               </a:ext>
             </a:extLst>
           </p:cNvPr>
@@ -3067,7 +3067,7 @@
           <p:cNvPr id="4" name="">
             <a:extLst xmlns:a="http://schemas.openxmlformats.org/drawingml/2006/main">
               <a:ext uri="{FF2B5EF4-FFF2-40B4-BE49-F238E27FC236}">
-                <a16:creationId xmlns:a16="http://schemas.microsoft.com/office/drawing/2014/main" id="{8B64E3F7-68A9-4125-9C2F-6F574AB785CA}"/>
+                <a16:creationId xmlns:a16="http://schemas.microsoft.com/office/drawing/2014/main" id="{91613478-B6CD-4FFE-81F8-60D3800D4576}"/>
               </a:ext>
             </a:extLst>
           </p:cNvPr>
@@ -3128,7 +3128,7 @@
           <p:cNvPr id="5" name="">
             <a:extLst xmlns:a="http://schemas.openxmlformats.org/drawingml/2006/main">
               <a:ext uri="{FF2B5EF4-FFF2-40B4-BE49-F238E27FC236}">
-                <a16:creationId xmlns:a16="http://schemas.microsoft.com/office/drawing/2014/main" id="{082FB663-A12C-46E6-B7C5-336951FB6991}"/>
+                <a16:creationId xmlns:a16="http://schemas.microsoft.com/office/drawing/2014/main" id="{D027A557-9B74-4B3B-AA68-A32CAC0EF0F1}"/>
               </a:ext>
             </a:extLst>
           </p:cNvPr>
@@ -3189,7 +3189,7 @@
           <p:cNvPr id="6" name="">
             <a:extLst xmlns:a="http://schemas.openxmlformats.org/drawingml/2006/main">
               <a:ext uri="{FF2B5EF4-FFF2-40B4-BE49-F238E27FC236}">
-                <a16:creationId xmlns:a16="http://schemas.microsoft.com/office/drawing/2014/main" id="{D0CDAC81-40C3-4C33-8737-281E3A7248AE}"/>
+                <a16:creationId xmlns:a16="http://schemas.microsoft.com/office/drawing/2014/main" id="{A1053E4A-9321-44E1-8369-34CAEA3FCDFB}"/>
               </a:ext>
             </a:extLst>
           </p:cNvPr>
@@ -3250,7 +3250,7 @@
           <p:cNvPr id="7" name="">
             <a:extLst xmlns:a="http://schemas.openxmlformats.org/drawingml/2006/main">
               <a:ext uri="{FF2B5EF4-FFF2-40B4-BE49-F238E27FC236}">
-                <a16:creationId xmlns:a16="http://schemas.microsoft.com/office/drawing/2014/main" id="{D28E698F-3BB4-4A02-B51B-1BF48CCE2CA3}"/>
+                <a16:creationId xmlns:a16="http://schemas.microsoft.com/office/drawing/2014/main" id="{B23F4C1F-E839-46EF-89FC-0D1DA796C18E}"/>
               </a:ext>
             </a:extLst>
           </p:cNvPr>
@@ -3309,7 +3309,7 @@
     </p:spTree>
     <p:extLst>
       <p:ext uri="{BB962C8B-B14F-4D97-AF65-F5344CB8AC3E}">
-        <p14:creationId xmlns:p14="http://schemas.microsoft.com/office/powerpoint/2010/main" val="727731073"/>
+        <p14:creationId xmlns:p14="http://schemas.microsoft.com/office/powerpoint/2010/main" val="296433561"/>
       </p:ext>
     </p:extLst>
   </p:cSld>
@@ -3340,7 +3340,7 @@
           <p:cNvPr id="8" name="">
             <a:extLst xmlns:a="http://schemas.openxmlformats.org/drawingml/2006/main">
               <a:ext uri="{FF2B5EF4-FFF2-40B4-BE49-F238E27FC236}">
-                <a16:creationId xmlns:a16="http://schemas.microsoft.com/office/drawing/2014/main" id="{A0A62E7C-731B-4431-A937-EA8D87FE8199}"/>
+                <a16:creationId xmlns:a16="http://schemas.microsoft.com/office/drawing/2014/main" id="{3B5261AB-A3DE-481B-88E4-4B41EBB9DCF4}"/>
               </a:ext>
             </a:extLst>
           </p:cNvPr>
@@ -3405,7 +3405,7 @@
           <p:nvPr/>
         </p:nvPicPr>
         <p:blipFill>
-          <a:blip xmlns:r="http://schemas.openxmlformats.org/officeDocument/2006/relationships" xmlns:a="http://schemas.openxmlformats.org/drawingml/2006/main" r:embed="Rbeac64cf91f04a6b"/>
+          <a:blip xmlns:r="http://schemas.openxmlformats.org/officeDocument/2006/relationships" xmlns:a="http://schemas.openxmlformats.org/drawingml/2006/main" r:embed="R9cdfd9572eba406b"/>
           <a:stretch xmlns:a="http://schemas.openxmlformats.org/drawingml/2006/main"/>
         </p:blipFill>
         <p:spPr>
@@ -3423,7 +3423,7 @@
           <p:cNvPr id="3" name="">
             <a:extLst xmlns:a="http://schemas.openxmlformats.org/drawingml/2006/main">
               <a:ext uri="{FF2B5EF4-FFF2-40B4-BE49-F238E27FC236}">
-                <a16:creationId xmlns:a16="http://schemas.microsoft.com/office/drawing/2014/main" id="{00B0CF48-A0F2-4292-9DD5-2F562C57270F}"/>
+                <a16:creationId xmlns:a16="http://schemas.microsoft.com/office/drawing/2014/main" id="{D69655C1-3CDB-488C-AAC4-BBCE5E70BF86}"/>
               </a:ext>
             </a:extLst>
           </p:cNvPr>
@@ -3474,7 +3474,7 @@
                 <a:ea typeface="Liberation Sans"/>
                 <a:cs typeface="Liberation Sans"/>
               </a:rPr>
-              <a:t>Will a buyer pay repeatedly?</a:t>
+              <a:t>Next: one recurring paid check</a:t>
             </a:r>
           </a:p>
         </p:txBody>
@@ -3484,7 +3484,7 @@
           <p:cNvPr id="4" name="">
             <a:extLst xmlns:a="http://schemas.openxmlformats.org/drawingml/2006/main">
               <a:ext uri="{FF2B5EF4-FFF2-40B4-BE49-F238E27FC236}">
-                <a16:creationId xmlns:a16="http://schemas.microsoft.com/office/drawing/2014/main" id="{2507821C-7DFB-42E6-9668-7EBEE2FDB4CC}"/>
+                <a16:creationId xmlns:a16="http://schemas.microsoft.com/office/drawing/2014/main" id="{F1A3AC5D-BF08-4DFE-B709-02D5C6D68102}"/>
               </a:ext>
             </a:extLst>
           </p:cNvPr>
@@ -3535,7 +3535,7 @@
                 <a:ea typeface="Liberation Sans"/>
                 <a:cs typeface="Liberation Sans"/>
               </a:rPr>
-              <a:t>Buyer hypothesis: software teams that already pay for remote checks.</a:t>
+              <a:t>First buyers to recruit: software teams that pay for remote checks.</a:t>
             </a:r>
           </a:p>
         </p:txBody>
@@ -3545,7 +3545,7 @@
           <p:cNvPr id="5" name="">
             <a:extLst xmlns:a="http://schemas.openxmlformats.org/drawingml/2006/main">
               <a:ext uri="{FF2B5EF4-FFF2-40B4-BE49-F238E27FC236}">
-                <a16:creationId xmlns:a16="http://schemas.microsoft.com/office/drawing/2014/main" id="{DDA3EAA3-70C0-4ED5-8C65-4A8263B5FE4B}"/>
+                <a16:creationId xmlns:a16="http://schemas.microsoft.com/office/drawing/2014/main" id="{D4610F9B-1EF7-4B64-A2C7-A9E5D75D6EB3}"/>
               </a:ext>
             </a:extLst>
           </p:cNvPr>
@@ -3596,7 +3596,7 @@
                 <a:ea typeface="Liberation Sans"/>
                 <a:cs typeface="Liberation Sans"/>
               </a:rPr>
-              <a:t>Next test: one operator and one recurring question.</a:t>
+              <a:t>Pilot plan: one operator, one buyer, measured cost and reliability.</a:t>
             </a:r>
           </a:p>
         </p:txBody>
@@ -3606,7 +3606,7 @@
           <p:cNvPr id="6" name="">
             <a:extLst xmlns:a="http://schemas.openxmlformats.org/drawingml/2006/main">
               <a:ext uri="{FF2B5EF4-FFF2-40B4-BE49-F238E27FC236}">
-                <a16:creationId xmlns:a16="http://schemas.microsoft.com/office/drawing/2014/main" id="{DFE4E6FE-BE33-4BF3-9D70-DF62CD7C65B1}"/>
+                <a16:creationId xmlns:a16="http://schemas.microsoft.com/office/drawing/2014/main" id="{73169C9F-CC3B-4860-8E11-2EC926BA9B96}"/>
               </a:ext>
             </a:extLst>
           </p:cNvPr>
@@ -3657,7 +3657,7 @@
                 <a:ea typeface="Liberation Sans"/>
                 <a:cs typeface="Liberation Sans"/>
               </a:rPr>
-              <a:t>Revenue hypothesis: integration and per-check fees.</a:t>
+              <a:t>Revenue plan: integration and service fees.</a:t>
             </a:r>
           </a:p>
         </p:txBody>
@@ -3667,7 +3667,7 @@
           <p:cNvPr id="7" name="">
             <a:extLst xmlns:a="http://schemas.openxmlformats.org/drawingml/2006/main">
               <a:ext uri="{FF2B5EF4-FFF2-40B4-BE49-F238E27FC236}">
-                <a16:creationId xmlns:a16="http://schemas.microsoft.com/office/drawing/2014/main" id="{85AA6EB4-76EF-43A6-AD4F-62663A18A756}"/>
+                <a16:creationId xmlns:a16="http://schemas.microsoft.com/office/drawing/2014/main" id="{C7D237B1-AF16-4260-AAEE-C38318A33996}"/>
               </a:ext>
             </a:extLst>
           </p:cNvPr>
@@ -3718,7 +3718,7 @@
                 <a:ea typeface="Liberation Sans"/>
                 <a:cs typeface="Liberation Sans"/>
               </a:rPr>
-              <a:t>The network, customer demand, and reputation remain unvalidated.</a:t>
+              <a:t>Today: one provider. The paid pilot will test demand and pricing.</a:t>
             </a:r>
           </a:p>
         </p:txBody>
@@ -3726,7 +3726,7 @@
     </p:spTree>
     <p:extLst>
       <p:ext uri="{BB962C8B-B14F-4D97-AF65-F5344CB8AC3E}">
-        <p14:creationId xmlns:p14="http://schemas.microsoft.com/office/powerpoint/2010/main" val="139742060"/>
+        <p14:creationId xmlns:p14="http://schemas.microsoft.com/office/powerpoint/2010/main" val="1332558348"/>
       </p:ext>
     </p:extLst>
   </p:cSld>

</xml_diff>